<commit_message>
Align customer slides to TDP opening, walkthrough, value, and closing.
Restructures the Google Slides deck and script so each required segment is explicit, including critical decisions, future possibilities, and one concrete next step.

Co-authored-by: Cursor <cursoragent@cursor.com>
</commit_message>
<xml_diff>
--- a/docs/Fedora-Lane-Expansion-Pack-Technical-Solution.pptx
+++ b/docs/Fedora-Lane-Expansion-Pack-Technical-Solution.pptx
@@ -3194,7 +3194,7 @@
         </p:nvSpPr>
         <p:spPr>
           <a:xfrm>
-            <a:off x="731520" y="2011680"/>
+            <a:off x="731520" y="1920240"/>
             <a:ext cx="10515600" cy="1097280"/>
           </a:xfrm>
           <a:prstGeom prst="rect">
@@ -3209,7 +3209,7 @@
           <a:lstStyle/>
           <a:p>
             <a:r>
-              <a:rPr sz="4000" b="1">
+              <a:rPr sz="3600" b="1">
                 <a:solidFill>
                   <a:srgbClr val="FFFFFF"/>
                 </a:solidFill>
@@ -3243,13 +3243,13 @@
           <a:lstStyle/>
           <a:p>
             <a:r>
-              <a:rPr sz="2000" b="0">
+              <a:rPr sz="1800" b="0">
                 <a:solidFill>
                   <a:srgbClr val="CCCCCC"/>
                 </a:solidFill>
                 <a:latin typeface="Calibri"/>
               </a:rPr>
-              <a:t>Secure RHEL gold image for the e-commerce web fleet</a:t>
+              <a:t>Server/Cloud OS TDP  ·  Technical solution briefing</a:t>
             </a:r>
           </a:p>
         </p:txBody>
@@ -3277,13 +3277,13 @@
           <a:lstStyle/>
           <a:p>
             <a:r>
-              <a:rPr sz="2000" b="0">
+              <a:rPr sz="1800" b="0">
                 <a:solidFill>
                   <a:srgbClr val="CCCCCC"/>
                 </a:solidFill>
                 <a:latin typeface="Calibri"/>
               </a:rPr>
-              <a:t>Local RHEL Image Builder  ·  Proven on AWS (AMI) and Azure (VHD)</a:t>
+              <a:t>Local RHEL Image Builder gold image  ·  AWS AMI + Azure VHD</a:t>
             </a:r>
           </a:p>
         </p:txBody>
@@ -3311,13 +3311,13 @@
           <a:lstStyle/>
           <a:p>
             <a:r>
-              <a:rPr sz="2000" b="0">
+              <a:rPr sz="1800" b="0">
                 <a:solidFill>
                   <a:srgbClr val="CCCCCC"/>
                 </a:solidFill>
                 <a:latin typeface="Calibri"/>
               </a:rPr>
-              <a:t>Technical solution briefing  ·  ~15 minutes</a:t>
+              <a:t>~15 minutes  ·  Opening → Live walkthrough → Value → Closing</a:t>
             </a:r>
           </a:p>
         </p:txBody>
@@ -3428,50 +3428,16 @@
       </p:sp>
       <p:sp>
         <p:nvSpPr>
-          <p:cNvPr id="4" name="TextBox 3"/>
-          <p:cNvSpPr txBox="1"/>
-          <p:nvPr/>
-        </p:nvSpPr>
-        <p:spPr>
-          <a:xfrm>
-            <a:off x="548640" y="320040"/>
-            <a:ext cx="10972800" cy="640080"/>
-          </a:xfrm>
-          <a:prstGeom prst="rect">
-            <a:avLst/>
-          </a:prstGeom>
-          <a:noFill/>
-        </p:spPr>
-        <p:txBody>
-          <a:bodyPr wrap="none">
-            <a:spAutoFit/>
-          </a:bodyPr>
-          <a:lstStyle/>
-          <a:p>
-            <a:r>
-              <a:rPr sz="2800" b="1">
-                <a:solidFill>
-                  <a:srgbClr val="1A1A1A"/>
-                </a:solidFill>
-                <a:latin typeface="Calibri"/>
-              </a:rPr>
-              <a:t>Scaling toward ~1,600 servers</a:t>
-            </a:r>
-          </a:p>
-        </p:txBody>
-      </p:sp>
-      <p:sp>
-        <p:nvSpPr>
-          <p:cNvPr id="5" name="Rectangle 4"/>
+          <p:cNvPr id="4" name="Rounded Rectangle 3"/>
           <p:cNvSpPr/>
           <p:nvPr/>
         </p:nvSpPr>
         <p:spPr>
           <a:xfrm>
-            <a:off x="548640" y="960120"/>
-            <a:ext cx="2011680" cy="54864"/>
-          </a:xfrm>
-          <a:prstGeom prst="rect">
+            <a:off x="548640" y="228600"/>
+            <a:ext cx="2194560" cy="320040"/>
+          </a:xfrm>
+          <a:prstGeom prst="roundRect">
             <a:avLst/>
           </a:prstGeom>
           <a:solidFill>
@@ -3505,14 +3471,126 @@
       </p:sp>
       <p:sp>
         <p:nvSpPr>
+          <p:cNvPr id="5" name="TextBox 4"/>
+          <p:cNvSpPr txBox="1"/>
+          <p:nvPr/>
+        </p:nvSpPr>
+        <p:spPr>
+          <a:xfrm>
+            <a:off x="548640" y="256032"/>
+            <a:ext cx="2194560" cy="292608"/>
+          </a:xfrm>
+          <a:prstGeom prst="rect">
+            <a:avLst/>
+          </a:prstGeom>
+          <a:noFill/>
+        </p:spPr>
+        <p:txBody>
+          <a:bodyPr wrap="none">
+            <a:spAutoFit/>
+          </a:bodyPr>
+          <a:lstStyle/>
+          <a:p>
+            <a:pPr algn="l"/>
+            <a:r>
+              <a:rPr sz="1100" b="1">
+                <a:solidFill>
+                  <a:srgbClr val="FFFFFF"/>
+                </a:solidFill>
+                <a:latin typeface="Calibri"/>
+              </a:rPr>
+              <a:t>VALUE</a:t>
+            </a:r>
+          </a:p>
+        </p:txBody>
+      </p:sp>
+      <p:sp>
+        <p:nvSpPr>
           <p:cNvPr id="6" name="TextBox 5"/>
           <p:cNvSpPr txBox="1"/>
           <p:nvPr/>
         </p:nvSpPr>
         <p:spPr>
           <a:xfrm>
-            <a:off x="548640" y="1280160"/>
-            <a:ext cx="10972800" cy="5029200"/>
+            <a:off x="548640" y="640080"/>
+            <a:ext cx="10972800" cy="548640"/>
+          </a:xfrm>
+          <a:prstGeom prst="rect">
+            <a:avLst/>
+          </a:prstGeom>
+          <a:noFill/>
+        </p:spPr>
+        <p:txBody>
+          <a:bodyPr wrap="none">
+            <a:spAutoFit/>
+          </a:bodyPr>
+          <a:lstStyle/>
+          <a:p>
+            <a:r>
+              <a:rPr sz="2600" b="1">
+                <a:solidFill>
+                  <a:srgbClr val="1A1A1A"/>
+                </a:solidFill>
+                <a:latin typeface="Calibri"/>
+              </a:rPr>
+              <a:t>What this leaves open for the future</a:t>
+            </a:r>
+          </a:p>
+        </p:txBody>
+      </p:sp>
+      <p:sp>
+        <p:nvSpPr>
+          <p:cNvPr id="7" name="Rectangle 6"/>
+          <p:cNvSpPr/>
+          <p:nvPr/>
+        </p:nvSpPr>
+        <p:spPr>
+          <a:xfrm>
+            <a:off x="548640" y="1234440"/>
+            <a:ext cx="1828800" cy="45720"/>
+          </a:xfrm>
+          <a:prstGeom prst="rect">
+            <a:avLst/>
+          </a:prstGeom>
+          <a:solidFill>
+            <a:srgbClr val="EE0000"/>
+          </a:solidFill>
+          <a:ln>
+            <a:noFill/>
+          </a:ln>
+        </p:spPr>
+        <p:style>
+          <a:lnRef idx="1">
+            <a:schemeClr val="accent1"/>
+          </a:lnRef>
+          <a:fillRef idx="3">
+            <a:schemeClr val="accent1"/>
+          </a:fillRef>
+          <a:effectRef idx="2">
+            <a:schemeClr val="accent1"/>
+          </a:effectRef>
+          <a:fontRef idx="minor">
+            <a:schemeClr val="lt1"/>
+          </a:fontRef>
+        </p:style>
+        <p:txBody>
+          <a:bodyPr rtlCol="0" anchor="ctr"/>
+          <a:lstStyle/>
+          <a:p>
+            <a:pPr algn="ctr"/>
+          </a:p>
+        </p:txBody>
+      </p:sp>
+      <p:sp>
+        <p:nvSpPr>
+          <p:cNvPr id="8" name="TextBox 7"/>
+          <p:cNvSpPr txBox="1"/>
+          <p:nvPr/>
+        </p:nvSpPr>
+        <p:spPr>
+          <a:xfrm>
+            <a:off x="548640" y="1463040"/>
+            <a:ext cx="10972800" cy="4572000"/>
           </a:xfrm>
           <a:prstGeom prst="rect">
             <a:avLst/>
@@ -3527,97 +3605,81 @@
           <a:p>
             <a:pPr>
               <a:spcAft>
-                <a:spcPts val="1000"/>
+                <a:spcPts val="900"/>
               </a:spcAft>
             </a:pPr>
             <a:r>
-              <a:rPr sz="2000" b="0">
+              <a:rPr sz="1800" b="0">
                 <a:solidFill>
                   <a:srgbClr val="1A1A1A"/>
                 </a:solidFill>
                 <a:latin typeface="Calibri"/>
               </a:rPr>
-              <a:t>•  Do not run Image Builder 1,600 times</a:t>
+              <a:t>•  Scale: Launch Templates / ASG (AWS) and Scale Sets / Shared Image Gallery (Azure)</a:t>
             </a:r>
           </a:p>
           <a:p>
             <a:pPr>
               <a:spcAft>
-                <a:spcPts val="1000"/>
+                <a:spcPts val="900"/>
               </a:spcAft>
             </a:pPr>
             <a:r>
-              <a:rPr sz="2000" b="0">
+              <a:rPr sz="1800" b="0">
                 <a:solidFill>
                   <a:srgbClr val="1A1A1A"/>
                 </a:solidFill>
                 <a:latin typeface="Calibri"/>
               </a:rPr>
-              <a:t>•  Freeze a versioned gold AMI / Azure image</a:t>
+              <a:t>•  Day-2: change blueprint → recompose new gold version → roll replace waves</a:t>
             </a:r>
           </a:p>
           <a:p>
             <a:pPr>
               <a:spcAft>
-                <a:spcPts val="1000"/>
+                <a:spcPts val="900"/>
               </a:spcAft>
             </a:pPr>
             <a:r>
-              <a:rPr sz="2000" b="0">
+              <a:rPr sz="1800" b="0">
                 <a:solidFill>
                   <a:srgbClr val="1A1A1A"/>
                 </a:solidFill>
                 <a:latin typeface="Calibri"/>
               </a:rPr>
-              <a:t>•  Launch from Launch Template / ASG (AWS) or Scale Sets / Gallery (Azure)</a:t>
+              <a:t>•  Security: add OpenSCAP / CIS profile to the same Image Builder factory</a:t>
             </a:r>
           </a:p>
           <a:p>
             <a:pPr>
               <a:spcAft>
-                <a:spcPts val="1000"/>
+                <a:spcPts val="900"/>
               </a:spcAft>
             </a:pPr>
             <a:r>
-              <a:rPr sz="2000" b="0">
+              <a:rPr sz="1800" b="0">
                 <a:solidFill>
                   <a:srgbClr val="1A1A1A"/>
                 </a:solidFill>
                 <a:latin typeface="Calibri"/>
               </a:rPr>
-              <a:t>•  Replace in waves: canary → batches → rest</a:t>
+              <a:t>•  Alternates already in repo: Kickstart and Image Mode if you prefer those factories</a:t>
             </a:r>
           </a:p>
           <a:p>
             <a:pPr>
               <a:spcAft>
-                <a:spcPts val="1000"/>
+                <a:spcPts val="900"/>
               </a:spcAft>
             </a:pPr>
             <a:r>
-              <a:rPr sz="2000" b="0">
+              <a:rPr sz="1800" b="0">
                 <a:solidFill>
                   <a:srgbClr val="1A1A1A"/>
                 </a:solidFill>
                 <a:latin typeface="Calibri"/>
               </a:rPr>
-              <a:t>•  Day-2: change blueprint in Git → recompose → roll new waves</a:t>
-            </a:r>
-          </a:p>
-          <a:p>
-            <a:pPr>
-              <a:spcAft>
-                <a:spcPts val="1000"/>
-              </a:spcAft>
-            </a:pPr>
-            <a:r>
-              <a:rPr sz="2000" b="0">
-                <a:solidFill>
-                  <a:srgbClr val="1A1A1A"/>
-                </a:solidFill>
-                <a:latin typeface="Calibri"/>
-              </a:rPr>
-              <a:t>•  Primary model: replace from gold image (not in-place root swap)</a:t>
+              <a:t>•  Integration: feed gold images into existing CI/CD, IaC, and change-control processes</a:t>
             </a:r>
           </a:p>
         </p:txBody>
@@ -3728,50 +3790,16 @@
       </p:sp>
       <p:sp>
         <p:nvSpPr>
-          <p:cNvPr id="4" name="TextBox 3"/>
-          <p:cNvSpPr txBox="1"/>
-          <p:nvPr/>
-        </p:nvSpPr>
-        <p:spPr>
-          <a:xfrm>
-            <a:off x="548640" y="320040"/>
-            <a:ext cx="10972800" cy="640080"/>
-          </a:xfrm>
-          <a:prstGeom prst="rect">
-            <a:avLst/>
-          </a:prstGeom>
-          <a:noFill/>
-        </p:spPr>
-        <p:txBody>
-          <a:bodyPr wrap="none">
-            <a:spAutoFit/>
-          </a:bodyPr>
-          <a:lstStyle/>
-          <a:p>
-            <a:r>
-              <a:rPr sz="2800" b="1">
-                <a:solidFill>
-                  <a:srgbClr val="1A1A1A"/>
-                </a:solidFill>
-                <a:latin typeface="Calibri"/>
-              </a:rPr>
-              <a:t>Value mapped to your challenges</a:t>
-            </a:r>
-          </a:p>
-        </p:txBody>
-      </p:sp>
-      <p:sp>
-        <p:nvSpPr>
-          <p:cNvPr id="5" name="Rectangle 4"/>
+          <p:cNvPr id="4" name="Rounded Rectangle 3"/>
           <p:cNvSpPr/>
           <p:nvPr/>
         </p:nvSpPr>
         <p:spPr>
           <a:xfrm>
-            <a:off x="548640" y="960120"/>
-            <a:ext cx="2011680" cy="54864"/>
-          </a:xfrm>
-          <a:prstGeom prst="rect">
+            <a:off x="548640" y="228600"/>
+            <a:ext cx="2194560" cy="320040"/>
+          </a:xfrm>
+          <a:prstGeom prst="roundRect">
             <a:avLst/>
           </a:prstGeom>
           <a:solidFill>
@@ -3805,14 +3833,126 @@
       </p:sp>
       <p:sp>
         <p:nvSpPr>
+          <p:cNvPr id="5" name="TextBox 4"/>
+          <p:cNvSpPr txBox="1"/>
+          <p:nvPr/>
+        </p:nvSpPr>
+        <p:spPr>
+          <a:xfrm>
+            <a:off x="548640" y="256032"/>
+            <a:ext cx="2194560" cy="292608"/>
+          </a:xfrm>
+          <a:prstGeom prst="rect">
+            <a:avLst/>
+          </a:prstGeom>
+          <a:noFill/>
+        </p:spPr>
+        <p:txBody>
+          <a:bodyPr wrap="none">
+            <a:spAutoFit/>
+          </a:bodyPr>
+          <a:lstStyle/>
+          <a:p>
+            <a:pPr algn="l"/>
+            <a:r>
+              <a:rPr sz="1100" b="1">
+                <a:solidFill>
+                  <a:srgbClr val="FFFFFF"/>
+                </a:solidFill>
+                <a:latin typeface="Calibri"/>
+              </a:rPr>
+              <a:t>CLOSING · 1–2 min</a:t>
+            </a:r>
+          </a:p>
+        </p:txBody>
+      </p:sp>
+      <p:sp>
+        <p:nvSpPr>
           <p:cNvPr id="6" name="TextBox 5"/>
           <p:cNvSpPr txBox="1"/>
           <p:nvPr/>
         </p:nvSpPr>
         <p:spPr>
           <a:xfrm>
-            <a:off x="548640" y="1280160"/>
-            <a:ext cx="10972800" cy="5029200"/>
+            <a:off x="548640" y="640080"/>
+            <a:ext cx="10972800" cy="548640"/>
+          </a:xfrm>
+          <a:prstGeom prst="rect">
+            <a:avLst/>
+          </a:prstGeom>
+          <a:noFill/>
+        </p:spPr>
+        <p:txBody>
+          <a:bodyPr wrap="none">
+            <a:spAutoFit/>
+          </a:bodyPr>
+          <a:lstStyle/>
+          <a:p>
+            <a:r>
+              <a:rPr sz="2600" b="1">
+                <a:solidFill>
+                  <a:srgbClr val="1A1A1A"/>
+                </a:solidFill>
+                <a:latin typeface="Calibri"/>
+              </a:rPr>
+              <a:t>Core message</a:t>
+            </a:r>
+          </a:p>
+        </p:txBody>
+      </p:sp>
+      <p:sp>
+        <p:nvSpPr>
+          <p:cNvPr id="7" name="Rectangle 6"/>
+          <p:cNvSpPr/>
+          <p:nvPr/>
+        </p:nvSpPr>
+        <p:spPr>
+          <a:xfrm>
+            <a:off x="548640" y="1234440"/>
+            <a:ext cx="1828800" cy="45720"/>
+          </a:xfrm>
+          <a:prstGeom prst="rect">
+            <a:avLst/>
+          </a:prstGeom>
+          <a:solidFill>
+            <a:srgbClr val="EE0000"/>
+          </a:solidFill>
+          <a:ln>
+            <a:noFill/>
+          </a:ln>
+        </p:spPr>
+        <p:style>
+          <a:lnRef idx="1">
+            <a:schemeClr val="accent1"/>
+          </a:lnRef>
+          <a:fillRef idx="3">
+            <a:schemeClr val="accent1"/>
+          </a:fillRef>
+          <a:effectRef idx="2">
+            <a:schemeClr val="accent1"/>
+          </a:effectRef>
+          <a:fontRef idx="minor">
+            <a:schemeClr val="lt1"/>
+          </a:fontRef>
+        </p:style>
+        <p:txBody>
+          <a:bodyPr rtlCol="0" anchor="ctr"/>
+          <a:lstStyle/>
+          <a:p>
+            <a:pPr algn="ctr"/>
+          </a:p>
+        </p:txBody>
+      </p:sp>
+      <p:sp>
+        <p:nvSpPr>
+          <p:cNvPr id="8" name="TextBox 7"/>
+          <p:cNvSpPr txBox="1"/>
+          <p:nvPr/>
+        </p:nvSpPr>
+        <p:spPr>
+          <a:xfrm>
+            <a:off x="548640" y="1463040"/>
+            <a:ext cx="10972800" cy="4572000"/>
           </a:xfrm>
           <a:prstGeom prst="rect">
             <a:avLst/>
@@ -3827,65 +3967,49 @@
           <a:p>
             <a:pPr>
               <a:spcAft>
-                <a:spcPts val="1000"/>
+                <a:spcPts val="900"/>
               </a:spcAft>
             </a:pPr>
             <a:r>
-              <a:rPr sz="2000" b="0">
+              <a:rPr sz="1800" b="0">
                 <a:solidFill>
                   <a:srgbClr val="1A1A1A"/>
                 </a:solidFill>
                 <a:latin typeface="Calibri"/>
               </a:rPr>
-              <a:t>•  Inconsistency → one blueprint → identical AMI/VHD baselines</a:t>
+              <a:t>•  Fedora Lane can standardize the e-commerce web OS with a repeatable RHEL gold image</a:t>
             </a:r>
           </a:p>
           <a:p>
             <a:pPr>
               <a:spcAft>
-                <a:spcPts val="1000"/>
+                <a:spcPts val="900"/>
               </a:spcAft>
             </a:pPr>
             <a:r>
-              <a:rPr sz="2000" b="0">
+              <a:rPr sz="1800" b="0">
                 <a:solidFill>
                   <a:srgbClr val="1A1A1A"/>
                 </a:solidFill>
                 <a:latin typeface="Calibri"/>
               </a:rPr>
-              <a:t>•  Risky change → hardened SSH/sudo baked in; rebuild from Git</a:t>
+              <a:t>•  Built with Red Hat Image Builder, versioned in Git, proven on AWS and Azure</a:t>
             </a:r>
           </a:p>
           <a:p>
             <a:pPr>
               <a:spcAft>
-                <a:spcPts val="1000"/>
+                <a:spcPts val="900"/>
               </a:spcAft>
             </a:pPr>
             <a:r>
-              <a:rPr sz="2000" b="0">
+              <a:rPr sz="1800" b="0">
                 <a:solidFill>
                   <a:srgbClr val="1A1A1A"/>
                 </a:solidFill>
                 <a:latin typeface="Calibri"/>
               </a:rPr>
-              <a:t>•  Container skills gap → httpd runs as a container on every gold VM</a:t>
-            </a:r>
-          </a:p>
-          <a:p>
-            <a:pPr>
-              <a:spcAft>
-                <a:spcPts val="1000"/>
-              </a:spcAft>
-            </a:pPr>
-            <a:r>
-              <a:rPr sz="2000" b="0">
-                <a:solidFill>
-                  <a:srgbClr val="1A1A1A"/>
-                </a:solidFill>
-                <a:latin typeface="Calibri"/>
-              </a:rPr>
-              <a:t>•  Dual cloud → proven path on both AWS and Azure</a:t>
+              <a:t>•  Technical value today: Expansion Pack controls + containerized httpd + dual-cloud deploy</a:t>
             </a:r>
           </a:p>
         </p:txBody>
@@ -3996,50 +4120,16 @@
       </p:sp>
       <p:sp>
         <p:nvSpPr>
-          <p:cNvPr id="4" name="TextBox 3"/>
-          <p:cNvSpPr txBox="1"/>
-          <p:nvPr/>
-        </p:nvSpPr>
-        <p:spPr>
-          <a:xfrm>
-            <a:off x="548640" y="320040"/>
-            <a:ext cx="10972800" cy="640080"/>
-          </a:xfrm>
-          <a:prstGeom prst="rect">
-            <a:avLst/>
-          </a:prstGeom>
-          <a:noFill/>
-        </p:spPr>
-        <p:txBody>
-          <a:bodyPr wrap="none">
-            <a:spAutoFit/>
-          </a:bodyPr>
-          <a:lstStyle/>
-          <a:p>
-            <a:r>
-              <a:rPr sz="2800" b="1">
-                <a:solidFill>
-                  <a:srgbClr val="1A1A1A"/>
-                </a:solidFill>
-                <a:latin typeface="Calibri"/>
-              </a:rPr>
-              <a:t>Recommendations &amp; next phase</a:t>
-            </a:r>
-          </a:p>
-        </p:txBody>
-      </p:sp>
-      <p:sp>
-        <p:nvSpPr>
-          <p:cNvPr id="5" name="Rectangle 4"/>
+          <p:cNvPr id="4" name="Rounded Rectangle 3"/>
           <p:cNvSpPr/>
           <p:nvPr/>
         </p:nvSpPr>
         <p:spPr>
           <a:xfrm>
-            <a:off x="548640" y="960120"/>
-            <a:ext cx="2011680" cy="54864"/>
-          </a:xfrm>
-          <a:prstGeom prst="rect">
+            <a:off x="548640" y="228600"/>
+            <a:ext cx="2194560" cy="320040"/>
+          </a:xfrm>
+          <a:prstGeom prst="roundRect">
             <a:avLst/>
           </a:prstGeom>
           <a:solidFill>
@@ -4073,14 +4163,126 @@
       </p:sp>
       <p:sp>
         <p:nvSpPr>
+          <p:cNvPr id="5" name="TextBox 4"/>
+          <p:cNvSpPr txBox="1"/>
+          <p:nvPr/>
+        </p:nvSpPr>
+        <p:spPr>
+          <a:xfrm>
+            <a:off x="548640" y="256032"/>
+            <a:ext cx="2194560" cy="292608"/>
+          </a:xfrm>
+          <a:prstGeom prst="rect">
+            <a:avLst/>
+          </a:prstGeom>
+          <a:noFill/>
+        </p:spPr>
+        <p:txBody>
+          <a:bodyPr wrap="none">
+            <a:spAutoFit/>
+          </a:bodyPr>
+          <a:lstStyle/>
+          <a:p>
+            <a:pPr algn="l"/>
+            <a:r>
+              <a:rPr sz="1100" b="1">
+                <a:solidFill>
+                  <a:srgbClr val="FFFFFF"/>
+                </a:solidFill>
+                <a:latin typeface="Calibri"/>
+              </a:rPr>
+              <a:t>CLOSING</a:t>
+            </a:r>
+          </a:p>
+        </p:txBody>
+      </p:sp>
+      <p:sp>
+        <p:nvSpPr>
           <p:cNvPr id="6" name="TextBox 5"/>
           <p:cNvSpPr txBox="1"/>
           <p:nvPr/>
         </p:nvSpPr>
         <p:spPr>
           <a:xfrm>
-            <a:off x="548640" y="1280160"/>
-            <a:ext cx="10972800" cy="5029200"/>
+            <a:off x="548640" y="640080"/>
+            <a:ext cx="10972800" cy="548640"/>
+          </a:xfrm>
+          <a:prstGeom prst="rect">
+            <a:avLst/>
+          </a:prstGeom>
+          <a:noFill/>
+        </p:spPr>
+        <p:txBody>
+          <a:bodyPr wrap="none">
+            <a:spAutoFit/>
+          </a:bodyPr>
+          <a:lstStyle/>
+          <a:p>
+            <a:r>
+              <a:rPr sz="2600" b="1">
+                <a:solidFill>
+                  <a:srgbClr val="1A1A1A"/>
+                </a:solidFill>
+                <a:latin typeface="Calibri"/>
+              </a:rPr>
+              <a:t>One concrete next step</a:t>
+            </a:r>
+          </a:p>
+        </p:txBody>
+      </p:sp>
+      <p:sp>
+        <p:nvSpPr>
+          <p:cNvPr id="7" name="Rectangle 6"/>
+          <p:cNvSpPr/>
+          <p:nvPr/>
+        </p:nvSpPr>
+        <p:spPr>
+          <a:xfrm>
+            <a:off x="548640" y="1234440"/>
+            <a:ext cx="1828800" cy="45720"/>
+          </a:xfrm>
+          <a:prstGeom prst="rect">
+            <a:avLst/>
+          </a:prstGeom>
+          <a:solidFill>
+            <a:srgbClr val="EE0000"/>
+          </a:solidFill>
+          <a:ln>
+            <a:noFill/>
+          </a:ln>
+        </p:spPr>
+        <p:style>
+          <a:lnRef idx="1">
+            <a:schemeClr val="accent1"/>
+          </a:lnRef>
+          <a:fillRef idx="3">
+            <a:schemeClr val="accent1"/>
+          </a:fillRef>
+          <a:effectRef idx="2">
+            <a:schemeClr val="accent1"/>
+          </a:effectRef>
+          <a:fontRef idx="minor">
+            <a:schemeClr val="lt1"/>
+          </a:fontRef>
+        </p:style>
+        <p:txBody>
+          <a:bodyPr rtlCol="0" anchor="ctr"/>
+          <a:lstStyle/>
+          <a:p>
+            <a:pPr algn="ctr"/>
+          </a:p>
+        </p:txBody>
+      </p:sp>
+      <p:sp>
+        <p:nvSpPr>
+          <p:cNvPr id="8" name="TextBox 7"/>
+          <p:cNvSpPr txBox="1"/>
+          <p:nvPr/>
+        </p:nvSpPr>
+        <p:spPr>
+          <a:xfrm>
+            <a:off x="548640" y="1463040"/>
+            <a:ext cx="10972800" cy="4572000"/>
           </a:xfrm>
           <a:prstGeom prst="rect">
             <a:avLst/>
@@ -4095,97 +4297,83 @@
           <a:p>
             <a:pPr>
               <a:spcAft>
-                <a:spcPts val="1000"/>
+                <a:spcPts val="900"/>
               </a:spcAft>
             </a:pPr>
             <a:r>
-              <a:rPr sz="2000" b="0">
+              <a:rPr sz="1800" b="0">
                 <a:solidFill>
                   <a:srgbClr val="1A1A1A"/>
                 </a:solidFill>
                 <a:latin typeface="Calibri"/>
               </a:rPr>
-              <a:t>•  This month: pilot gold image on non-prod web nodes</a:t>
+              <a:t>•  Approve a non-prod pilot: launch web nodes from the gold AMI / Azure image</a:t>
             </a:r>
           </a:p>
           <a:p>
             <a:pPr>
               <a:spcAft>
-                <a:spcPts val="1000"/>
+                <a:spcPts val="900"/>
               </a:spcAft>
             </a:pPr>
             <a:r>
-              <a:rPr sz="2000" b="0">
+              <a:rPr sz="1800" b="0">
                 <a:solidFill>
                   <a:srgbClr val="1A1A1A"/>
                 </a:solidFill>
                 <a:latin typeface="Calibri"/>
               </a:rPr>
-              <a:t>•  Adopt Launch Template / scale set for new capacity</a:t>
+              <a:t>•  Use Launch Template / scale set for new capacity; keep Git as change control</a:t>
             </a:r>
           </a:p>
           <a:p>
             <a:pPr>
               <a:spcAft>
-                <a:spcPts val="1000"/>
+                <a:spcPts val="900"/>
               </a:spcAft>
             </a:pPr>
             <a:r>
-              <a:rPr sz="2000" b="0">
+              <a:rPr sz="1800" b="0">
                 <a:solidFill>
                   <a:srgbClr val="1A1A1A"/>
                 </a:solidFill>
                 <a:latin typeface="Calibri"/>
               </a:rPr>
-              <a:t>•  Keep Git blueprint as the change-control source of truth</a:t>
-            </a:r>
-          </a:p>
-          <a:p>
-            <a:pPr>
-              <a:spcAft>
-                <a:spcPts val="1000"/>
-              </a:spcAft>
-            </a:pPr>
-            <a:r>
-              <a:rPr sz="2000" b="0">
-                <a:solidFill>
-                  <a:srgbClr val="1A1A1A"/>
-                </a:solidFill>
-                <a:latin typeface="Calibri"/>
-              </a:rPr>
-              <a:t>•  Next: wave-replace selected prod pools</a:t>
-            </a:r>
-          </a:p>
-          <a:p>
-            <a:pPr>
-              <a:spcAft>
-                <a:spcPts val="1000"/>
-              </a:spcAft>
-            </a:pPr>
-            <a:r>
-              <a:rPr sz="2000" b="0">
-                <a:solidFill>
-                  <a:srgbClr val="1A1A1A"/>
-                </a:solidFill>
-                <a:latin typeface="Calibri"/>
-              </a:rPr>
-              <a:t>•  Optional: OpenSCAP CIS · Kickstart / Image Mode alternates in repo</a:t>
-            </a:r>
-          </a:p>
-          <a:p>
-            <a:pPr>
-              <a:spcAft>
-                <a:spcPts val="1000"/>
-              </a:spcAft>
-            </a:pPr>
-            <a:r>
-              <a:rPr sz="2000" b="0">
-                <a:solidFill>
-                  <a:srgbClr val="1A1A1A"/>
-                </a:solidFill>
-                <a:latin typeface="Calibri"/>
-              </a:rPr>
-              <a:t>•  Ask: Approve non-prod pilot as the web OS standard</a:t>
+              <a:t>•  After pilot: wave-replace selected prod pools</a:t>
+            </a:r>
+          </a:p>
+        </p:txBody>
+      </p:sp>
+      <p:sp>
+        <p:nvSpPr>
+          <p:cNvPr id="9" name="TextBox 8"/>
+          <p:cNvSpPr txBox="1"/>
+          <p:nvPr/>
+        </p:nvSpPr>
+        <p:spPr>
+          <a:xfrm>
+            <a:off x="548640" y="6263640"/>
+            <a:ext cx="10972800" cy="365760"/>
+          </a:xfrm>
+          <a:prstGeom prst="rect">
+            <a:avLst/>
+          </a:prstGeom>
+          <a:noFill/>
+        </p:spPr>
+        <p:txBody>
+          <a:bodyPr wrap="none">
+            <a:spAutoFit/>
+          </a:bodyPr>
+          <a:lstStyle/>
+          <a:p>
+            <a:r>
+              <a:rPr sz="1300" b="0">
+                <a:solidFill>
+                  <a:srgbClr val="666666"/>
+                </a:solidFill>
+                <a:latin typeface="Calibri"/>
+              </a:rPr>
+              <a:t>Ask: green-light non-prod pilot as the web OS standard</a:t>
             </a:r>
           </a:p>
         </p:txBody>
@@ -4302,8 +4490,8 @@
         </p:nvSpPr>
         <p:spPr>
           <a:xfrm>
-            <a:off x="731520" y="1828800"/>
-            <a:ext cx="10515600" cy="914400"/>
+            <a:off x="731520" y="1920240"/>
+            <a:ext cx="10515600" cy="1097280"/>
           </a:xfrm>
           <a:prstGeom prst="rect">
             <a:avLst/>
@@ -4336,7 +4524,7 @@
         </p:nvSpPr>
         <p:spPr>
           <a:xfrm>
-            <a:off x="731520" y="3108960"/>
+            <a:off x="731520" y="3200400"/>
             <a:ext cx="10515600" cy="411480"/>
           </a:xfrm>
           <a:prstGeom prst="rect">
@@ -4357,7 +4545,7 @@
                 </a:solidFill>
                 <a:latin typeface="Calibri"/>
               </a:rPr>
-              <a:t>Repository: github.com/ydandge-oss/fedora-lane-core-pack-faster</a:t>
+              <a:t>Git source of truth: github.com/ydandge-oss/fedora-lane-core-pack-faster</a:t>
             </a:r>
           </a:p>
         </p:txBody>
@@ -4370,7 +4558,7 @@
         </p:nvSpPr>
         <p:spPr>
           <a:xfrm>
-            <a:off x="731520" y="3566160"/>
+            <a:off x="731520" y="3611880"/>
             <a:ext cx="10515600" cy="411480"/>
           </a:xfrm>
           <a:prstGeom prst="rect">
@@ -4391,7 +4579,7 @@
                 </a:solidFill>
                 <a:latin typeface="Calibri"/>
               </a:rPr>
-              <a:t>Branch: expansion-tdp-solution</a:t>
+              <a:t>Branch: expansion-tdp-solution  ·  README + runbooks + verify checklist</a:t>
             </a:r>
           </a:p>
         </p:txBody>
@@ -4425,7 +4613,7 @@
                 </a:solidFill>
                 <a:latin typeface="Calibri"/>
               </a:rPr>
-              <a:t>Docs: solution-overview · AWS/Azure runbooks · launch CLI/console · verify checklist</a:t>
+              <a:t>Spoken script: docs/presentation-script-part1-video.md</a:t>
             </a:r>
           </a:p>
         </p:txBody>
@@ -4536,50 +4724,16 @@
       </p:sp>
       <p:sp>
         <p:nvSpPr>
-          <p:cNvPr id="4" name="TextBox 3"/>
-          <p:cNvSpPr txBox="1"/>
-          <p:nvPr/>
-        </p:nvSpPr>
-        <p:spPr>
-          <a:xfrm>
-            <a:off x="548640" y="320040"/>
-            <a:ext cx="10972800" cy="640080"/>
-          </a:xfrm>
-          <a:prstGeom prst="rect">
-            <a:avLst/>
-          </a:prstGeom>
-          <a:noFill/>
-        </p:spPr>
-        <p:txBody>
-          <a:bodyPr wrap="none">
-            <a:spAutoFit/>
-          </a:bodyPr>
-          <a:lstStyle/>
-          <a:p>
-            <a:r>
-              <a:rPr sz="2800" b="1">
-                <a:solidFill>
-                  <a:srgbClr val="1A1A1A"/>
-                </a:solidFill>
-                <a:latin typeface="Calibri"/>
-              </a:rPr>
-              <a:t>Agenda</a:t>
-            </a:r>
-          </a:p>
-        </p:txBody>
-      </p:sp>
-      <p:sp>
-        <p:nvSpPr>
-          <p:cNvPr id="5" name="Rectangle 4"/>
+          <p:cNvPr id="4" name="Rounded Rectangle 3"/>
           <p:cNvSpPr/>
           <p:nvPr/>
         </p:nvSpPr>
         <p:spPr>
           <a:xfrm>
-            <a:off x="548640" y="960120"/>
-            <a:ext cx="2011680" cy="54864"/>
-          </a:xfrm>
-          <a:prstGeom prst="rect">
+            <a:off x="548640" y="228600"/>
+            <a:ext cx="2194560" cy="320040"/>
+          </a:xfrm>
+          <a:prstGeom prst="roundRect">
             <a:avLst/>
           </a:prstGeom>
           <a:solidFill>
@@ -4613,14 +4767,126 @@
       </p:sp>
       <p:sp>
         <p:nvSpPr>
+          <p:cNvPr id="5" name="TextBox 4"/>
+          <p:cNvSpPr txBox="1"/>
+          <p:nvPr/>
+        </p:nvSpPr>
+        <p:spPr>
+          <a:xfrm>
+            <a:off x="548640" y="256032"/>
+            <a:ext cx="2194560" cy="292608"/>
+          </a:xfrm>
+          <a:prstGeom prst="rect">
+            <a:avLst/>
+          </a:prstGeom>
+          <a:noFill/>
+        </p:spPr>
+        <p:txBody>
+          <a:bodyPr wrap="none">
+            <a:spAutoFit/>
+          </a:bodyPr>
+          <a:lstStyle/>
+          <a:p>
+            <a:pPr algn="l"/>
+            <a:r>
+              <a:rPr sz="1100" b="1">
+                <a:solidFill>
+                  <a:srgbClr val="FFFFFF"/>
+                </a:solidFill>
+                <a:latin typeface="Calibri"/>
+              </a:rPr>
+              <a:t>OPENING · 1–2 min</a:t>
+            </a:r>
+          </a:p>
+        </p:txBody>
+      </p:sp>
+      <p:sp>
+        <p:nvSpPr>
           <p:cNvPr id="6" name="TextBox 5"/>
           <p:cNvSpPr txBox="1"/>
           <p:nvPr/>
         </p:nvSpPr>
         <p:spPr>
           <a:xfrm>
-            <a:off x="548640" y="1280160"/>
-            <a:ext cx="10972800" cy="5029200"/>
+            <a:off x="548640" y="640080"/>
+            <a:ext cx="10972800" cy="548640"/>
+          </a:xfrm>
+          <a:prstGeom prst="rect">
+            <a:avLst/>
+          </a:prstGeom>
+          <a:noFill/>
+        </p:spPr>
+        <p:txBody>
+          <a:bodyPr wrap="none">
+            <a:spAutoFit/>
+          </a:bodyPr>
+          <a:lstStyle/>
+          <a:p>
+            <a:r>
+              <a:rPr sz="2600" b="1">
+                <a:solidFill>
+                  <a:srgbClr val="1A1A1A"/>
+                </a:solidFill>
+                <a:latin typeface="Calibri"/>
+              </a:rPr>
+              <a:t>Why we are here</a:t>
+            </a:r>
+          </a:p>
+        </p:txBody>
+      </p:sp>
+      <p:sp>
+        <p:nvSpPr>
+          <p:cNvPr id="7" name="Rectangle 6"/>
+          <p:cNvSpPr/>
+          <p:nvPr/>
+        </p:nvSpPr>
+        <p:spPr>
+          <a:xfrm>
+            <a:off x="548640" y="1234440"/>
+            <a:ext cx="1828800" cy="45720"/>
+          </a:xfrm>
+          <a:prstGeom prst="rect">
+            <a:avLst/>
+          </a:prstGeom>
+          <a:solidFill>
+            <a:srgbClr val="EE0000"/>
+          </a:solidFill>
+          <a:ln>
+            <a:noFill/>
+          </a:ln>
+        </p:spPr>
+        <p:style>
+          <a:lnRef idx="1">
+            <a:schemeClr val="accent1"/>
+          </a:lnRef>
+          <a:fillRef idx="3">
+            <a:schemeClr val="accent1"/>
+          </a:fillRef>
+          <a:effectRef idx="2">
+            <a:schemeClr val="accent1"/>
+          </a:effectRef>
+          <a:fontRef idx="minor">
+            <a:schemeClr val="lt1"/>
+          </a:fontRef>
+        </p:style>
+        <p:txBody>
+          <a:bodyPr rtlCol="0" anchor="ctr"/>
+          <a:lstStyle/>
+          <a:p>
+            <a:pPr algn="ctr"/>
+          </a:p>
+        </p:txBody>
+      </p:sp>
+      <p:sp>
+        <p:nvSpPr>
+          <p:cNvPr id="8" name="TextBox 7"/>
+          <p:cNvSpPr txBox="1"/>
+          <p:nvPr/>
+        </p:nvSpPr>
+        <p:spPr>
+          <a:xfrm>
+            <a:off x="548640" y="1463040"/>
+            <a:ext cx="10972800" cy="4572000"/>
           </a:xfrm>
           <a:prstGeom prst="rect">
             <a:avLst/>
@@ -4635,113 +4901,65 @@
           <a:p>
             <a:pPr>
               <a:spcAft>
-                <a:spcPts val="1000"/>
+                <a:spcPts val="900"/>
               </a:spcAft>
             </a:pPr>
             <a:r>
-              <a:rPr sz="2000" b="0">
+              <a:rPr sz="1800" b="0">
                 <a:solidFill>
                   <a:srgbClr val="1A1A1A"/>
                 </a:solidFill>
                 <a:latin typeface="Calibri"/>
               </a:rPr>
-              <a:t>•  Your challenges — confirm understanding</a:t>
+              <a:t>•  Team: Junior Consultant(s) — FASTER Server/Cloud OS TDP</a:t>
             </a:r>
           </a:p>
           <a:p>
             <a:pPr>
               <a:spcAft>
-                <a:spcPts val="1000"/>
+                <a:spcPts val="900"/>
               </a:spcAft>
             </a:pPr>
             <a:r>
-              <a:rPr sz="2000" b="0">
+              <a:rPr sz="1800" b="0">
                 <a:solidFill>
                   <a:srgbClr val="1A1A1A"/>
                 </a:solidFill>
                 <a:latin typeface="Calibri"/>
               </a:rPr>
-              <a:t>•  What we built — gold image solution</a:t>
+              <a:t>•  Fedora Lane asked for a secure, repeatable RHEL web baseline for cloud</a:t>
             </a:r>
           </a:p>
           <a:p>
             <a:pPr>
               <a:spcAft>
-                <a:spcPts val="1000"/>
+                <a:spcPts val="900"/>
               </a:spcAft>
             </a:pPr>
             <a:r>
-              <a:rPr sz="2000" b="0">
+              <a:rPr sz="1800" b="0">
                 <a:solidFill>
                   <a:srgbClr val="1A1A1A"/>
                 </a:solidFill>
                 <a:latin typeface="Calibri"/>
               </a:rPr>
-              <a:t>•  How it works — blueprint → image → VM</a:t>
+              <a:t>•  Today we show a working gold-image solution built with Red Hat technology</a:t>
             </a:r>
           </a:p>
           <a:p>
             <a:pPr>
               <a:spcAft>
-                <a:spcPts val="1000"/>
+                <a:spcPts val="900"/>
               </a:spcAft>
             </a:pPr>
             <a:r>
-              <a:rPr sz="2000" b="0">
+              <a:rPr sz="1800" b="0">
                 <a:solidFill>
                   <a:srgbClr val="1A1A1A"/>
                 </a:solidFill>
                 <a:latin typeface="Calibri"/>
               </a:rPr>
-              <a:t>•  Security &amp; Expansion Pack controls</a:t>
-            </a:r>
-          </a:p>
-          <a:p>
-            <a:pPr>
-              <a:spcAft>
-                <a:spcPts val="1000"/>
-              </a:spcAft>
-            </a:pPr>
-            <a:r>
-              <a:rPr sz="2000" b="0">
-                <a:solidFill>
-                  <a:srgbClr val="1A1A1A"/>
-                </a:solidFill>
-                <a:latin typeface="Calibri"/>
-              </a:rPr>
-              <a:t>•  How you operate it — Console and CLI</a:t>
-            </a:r>
-          </a:p>
-          <a:p>
-            <a:pPr>
-              <a:spcAft>
-                <a:spcPts val="1000"/>
-              </a:spcAft>
-            </a:pPr>
-            <a:r>
-              <a:rPr sz="2000" b="0">
-                <a:solidFill>
-                  <a:srgbClr val="1A1A1A"/>
-                </a:solidFill>
-                <a:latin typeface="Calibri"/>
-              </a:rPr>
-              <a:t>•  Scaling toward ~1,600 servers</a:t>
-            </a:r>
-          </a:p>
-          <a:p>
-            <a:pPr>
-              <a:spcAft>
-                <a:spcPts val="1000"/>
-              </a:spcAft>
-            </a:pPr>
-            <a:r>
-              <a:rPr sz="2000" b="0">
-                <a:solidFill>
-                  <a:srgbClr val="1A1A1A"/>
-                </a:solidFill>
-                <a:latin typeface="Calibri"/>
-              </a:rPr>
-              <a:t>•  Recommendations and next phase</a:t>
+              <a:t>•  Objective: confirm challenges → walk the live implementation → agree next step</a:t>
             </a:r>
           </a:p>
         </p:txBody>
@@ -4852,50 +5070,16 @@
       </p:sp>
       <p:sp>
         <p:nvSpPr>
-          <p:cNvPr id="4" name="TextBox 3"/>
-          <p:cNvSpPr txBox="1"/>
-          <p:nvPr/>
-        </p:nvSpPr>
-        <p:spPr>
-          <a:xfrm>
-            <a:off x="548640" y="320040"/>
-            <a:ext cx="10972800" cy="640080"/>
-          </a:xfrm>
-          <a:prstGeom prst="rect">
-            <a:avLst/>
-          </a:prstGeom>
-          <a:noFill/>
-        </p:spPr>
-        <p:txBody>
-          <a:bodyPr wrap="none">
-            <a:spAutoFit/>
-          </a:bodyPr>
-          <a:lstStyle/>
-          <a:p>
-            <a:r>
-              <a:rPr sz="2800" b="1">
-                <a:solidFill>
-                  <a:srgbClr val="1A1A1A"/>
-                </a:solidFill>
-                <a:latin typeface="Calibri"/>
-              </a:rPr>
-              <a:t>Challenges we heard</a:t>
-            </a:r>
-          </a:p>
-        </p:txBody>
-      </p:sp>
-      <p:sp>
-        <p:nvSpPr>
-          <p:cNvPr id="5" name="Rectangle 4"/>
+          <p:cNvPr id="4" name="Rounded Rectangle 3"/>
           <p:cNvSpPr/>
           <p:nvPr/>
         </p:nvSpPr>
         <p:spPr>
           <a:xfrm>
-            <a:off x="548640" y="960120"/>
-            <a:ext cx="2011680" cy="54864"/>
-          </a:xfrm>
-          <a:prstGeom prst="rect">
+            <a:off x="548640" y="228600"/>
+            <a:ext cx="2194560" cy="320040"/>
+          </a:xfrm>
+          <a:prstGeom prst="roundRect">
             <a:avLst/>
           </a:prstGeom>
           <a:solidFill>
@@ -4929,14 +5113,126 @@
       </p:sp>
       <p:sp>
         <p:nvSpPr>
+          <p:cNvPr id="5" name="TextBox 4"/>
+          <p:cNvSpPr txBox="1"/>
+          <p:nvPr/>
+        </p:nvSpPr>
+        <p:spPr>
+          <a:xfrm>
+            <a:off x="548640" y="256032"/>
+            <a:ext cx="2194560" cy="292608"/>
+          </a:xfrm>
+          <a:prstGeom prst="rect">
+            <a:avLst/>
+          </a:prstGeom>
+          <a:noFill/>
+        </p:spPr>
+        <p:txBody>
+          <a:bodyPr wrap="none">
+            <a:spAutoFit/>
+          </a:bodyPr>
+          <a:lstStyle/>
+          <a:p>
+            <a:pPr algn="l"/>
+            <a:r>
+              <a:rPr sz="1100" b="1">
+                <a:solidFill>
+                  <a:srgbClr val="FFFFFF"/>
+                </a:solidFill>
+                <a:latin typeface="Calibri"/>
+              </a:rPr>
+              <a:t>OPENING</a:t>
+            </a:r>
+          </a:p>
+        </p:txBody>
+      </p:sp>
+      <p:sp>
+        <p:nvSpPr>
           <p:cNvPr id="6" name="TextBox 5"/>
           <p:cNvSpPr txBox="1"/>
           <p:nvPr/>
         </p:nvSpPr>
         <p:spPr>
           <a:xfrm>
-            <a:off x="548640" y="1280160"/>
-            <a:ext cx="10972800" cy="5029200"/>
+            <a:off x="548640" y="640080"/>
+            <a:ext cx="10972800" cy="548640"/>
+          </a:xfrm>
+          <a:prstGeom prst="rect">
+            <a:avLst/>
+          </a:prstGeom>
+          <a:noFill/>
+        </p:spPr>
+        <p:txBody>
+          <a:bodyPr wrap="none">
+            <a:spAutoFit/>
+          </a:bodyPr>
+          <a:lstStyle/>
+          <a:p>
+            <a:r>
+              <a:rPr sz="2600" b="1">
+                <a:solidFill>
+                  <a:srgbClr val="1A1A1A"/>
+                </a:solidFill>
+                <a:latin typeface="Calibri"/>
+              </a:rPr>
+              <a:t>Challenges we confirm with you</a:t>
+            </a:r>
+          </a:p>
+        </p:txBody>
+      </p:sp>
+      <p:sp>
+        <p:nvSpPr>
+          <p:cNvPr id="7" name="Rectangle 6"/>
+          <p:cNvSpPr/>
+          <p:nvPr/>
+        </p:nvSpPr>
+        <p:spPr>
+          <a:xfrm>
+            <a:off x="548640" y="1234440"/>
+            <a:ext cx="1828800" cy="45720"/>
+          </a:xfrm>
+          <a:prstGeom prst="rect">
+            <a:avLst/>
+          </a:prstGeom>
+          <a:solidFill>
+            <a:srgbClr val="EE0000"/>
+          </a:solidFill>
+          <a:ln>
+            <a:noFill/>
+          </a:ln>
+        </p:spPr>
+        <p:style>
+          <a:lnRef idx="1">
+            <a:schemeClr val="accent1"/>
+          </a:lnRef>
+          <a:fillRef idx="3">
+            <a:schemeClr val="accent1"/>
+          </a:fillRef>
+          <a:effectRef idx="2">
+            <a:schemeClr val="accent1"/>
+          </a:effectRef>
+          <a:fontRef idx="minor">
+            <a:schemeClr val="lt1"/>
+          </a:fontRef>
+        </p:style>
+        <p:txBody>
+          <a:bodyPr rtlCol="0" anchor="ctr"/>
+          <a:lstStyle/>
+          <a:p>
+            <a:pPr algn="ctr"/>
+          </a:p>
+        </p:txBody>
+      </p:sp>
+      <p:sp>
+        <p:nvSpPr>
+          <p:cNvPr id="8" name="TextBox 7"/>
+          <p:cNvSpPr txBox="1"/>
+          <p:nvPr/>
+        </p:nvSpPr>
+        <p:spPr>
+          <a:xfrm>
+            <a:off x="548640" y="1463040"/>
+            <a:ext cx="10972800" cy="4572000"/>
           </a:xfrm>
           <a:prstGeom prst="rect">
             <a:avLst/>
@@ -4951,65 +5247,99 @@
           <a:p>
             <a:pPr>
               <a:spcAft>
-                <a:spcPts val="1000"/>
+                <a:spcPts val="900"/>
               </a:spcAft>
             </a:pPr>
             <a:r>
-              <a:rPr sz="2000" b="0">
+              <a:rPr sz="1800" b="0">
                 <a:solidFill>
                   <a:srgbClr val="1A1A1A"/>
                 </a:solidFill>
                 <a:latin typeface="Calibri"/>
               </a:rPr>
-              <a:t>•  Inconsistent estate — ~1,600 servers; Rocky, Ubuntu, CentOS Stream, Amazon Linux</a:t>
+              <a:t>•  Inconsistent estate — ~1,600 servers; mixed Rocky, Ubuntu, CentOS Stream, Amazon Linux</a:t>
             </a:r>
           </a:p>
           <a:p>
             <a:pPr>
               <a:spcAft>
-                <a:spcPts val="1000"/>
+                <a:spcPts val="900"/>
               </a:spcAft>
             </a:pPr>
             <a:r>
-              <a:rPr sz="2000" b="0">
+              <a:rPr sz="1800" b="0">
                 <a:solidFill>
                   <a:srgbClr val="1A1A1A"/>
                 </a:solidFill>
                 <a:latin typeface="Calibri"/>
               </a:rPr>
-              <a:t>•  Risky / untraceable change — drift and ad-hoc updates create long outages</a:t>
+              <a:t>•  Risky / untraceable change — drift and ad-hoc updates drive long outages</a:t>
             </a:r>
           </a:p>
           <a:p>
             <a:pPr>
               <a:spcAft>
-                <a:spcPts val="1000"/>
+                <a:spcPts val="900"/>
               </a:spcAft>
             </a:pPr>
             <a:r>
-              <a:rPr sz="2000" b="0">
+              <a:rPr sz="1800" b="0">
                 <a:solidFill>
                   <a:srgbClr val="1A1A1A"/>
                 </a:solidFill>
                 <a:latin typeface="Calibri"/>
               </a:rPr>
-              <a:t>•  Container skills gap — need a clear, repeatable way to run services on RHEL</a:t>
+              <a:t>•  Container skills gap — ops need a clear, repeatable container path on RHEL</a:t>
             </a:r>
           </a:p>
           <a:p>
             <a:pPr>
               <a:spcAft>
-                <a:spcPts val="1000"/>
+                <a:spcPts val="900"/>
               </a:spcAft>
             </a:pPr>
             <a:r>
-              <a:rPr sz="2000" b="0">
+              <a:rPr sz="1800" b="0">
                 <a:solidFill>
                   <a:srgbClr val="1A1A1A"/>
                 </a:solidFill>
                 <a:latin typeface="Calibri"/>
               </a:rPr>
-              <a:t>•  Want: one secure RHEL baseline for AWS and Azure, rebuildable from Git</a:t>
+              <a:t>•  Expansion Pack want: manual/local Image Builder gold image for AWS and Azure</a:t>
+            </a:r>
+          </a:p>
+        </p:txBody>
+      </p:sp>
+      <p:sp>
+        <p:nvSpPr>
+          <p:cNvPr id="9" name="TextBox 8"/>
+          <p:cNvSpPr txBox="1"/>
+          <p:nvPr/>
+        </p:nvSpPr>
+        <p:spPr>
+          <a:xfrm>
+            <a:off x="548640" y="6263640"/>
+            <a:ext cx="10972800" cy="365760"/>
+          </a:xfrm>
+          <a:prstGeom prst="rect">
+            <a:avLst/>
+          </a:prstGeom>
+          <a:noFill/>
+        </p:spPr>
+        <p:txBody>
+          <a:bodyPr wrap="none">
+            <a:spAutoFit/>
+          </a:bodyPr>
+          <a:lstStyle/>
+          <a:p>
+            <a:r>
+              <a:rPr sz="1300" b="0">
+                <a:solidFill>
+                  <a:srgbClr val="666666"/>
+                </a:solidFill>
+                <a:latin typeface="Calibri"/>
+              </a:rPr>
+              <a:t>Confirming understanding before we walk the solution</a:t>
             </a:r>
           </a:p>
         </p:txBody>
@@ -5120,50 +5450,16 @@
       </p:sp>
       <p:sp>
         <p:nvSpPr>
-          <p:cNvPr id="4" name="TextBox 3"/>
-          <p:cNvSpPr txBox="1"/>
-          <p:nvPr/>
-        </p:nvSpPr>
-        <p:spPr>
-          <a:xfrm>
-            <a:off x="548640" y="320040"/>
-            <a:ext cx="10972800" cy="640080"/>
-          </a:xfrm>
-          <a:prstGeom prst="rect">
-            <a:avLst/>
-          </a:prstGeom>
-          <a:noFill/>
-        </p:spPr>
-        <p:txBody>
-          <a:bodyPr wrap="none">
-            <a:spAutoFit/>
-          </a:bodyPr>
-          <a:lstStyle/>
-          <a:p>
-            <a:r>
-              <a:rPr sz="2800" b="1">
-                <a:solidFill>
-                  <a:srgbClr val="1A1A1A"/>
-                </a:solidFill>
-                <a:latin typeface="Calibri"/>
-              </a:rPr>
-              <a:t>Solution in one sentence</a:t>
-            </a:r>
-          </a:p>
-        </p:txBody>
-      </p:sp>
-      <p:sp>
-        <p:nvSpPr>
-          <p:cNvPr id="5" name="Rectangle 4"/>
+          <p:cNvPr id="4" name="Rounded Rectangle 3"/>
           <p:cNvSpPr/>
           <p:nvPr/>
         </p:nvSpPr>
         <p:spPr>
           <a:xfrm>
-            <a:off x="548640" y="960120"/>
-            <a:ext cx="2011680" cy="54864"/>
-          </a:xfrm>
-          <a:prstGeom prst="rect">
+            <a:off x="548640" y="228600"/>
+            <a:ext cx="2194560" cy="320040"/>
+          </a:xfrm>
+          <a:prstGeom prst="roundRect">
             <a:avLst/>
           </a:prstGeom>
           <a:solidFill>
@@ -5197,14 +5493,126 @@
       </p:sp>
       <p:sp>
         <p:nvSpPr>
+          <p:cNvPr id="5" name="TextBox 4"/>
+          <p:cNvSpPr txBox="1"/>
+          <p:nvPr/>
+        </p:nvSpPr>
+        <p:spPr>
+          <a:xfrm>
+            <a:off x="548640" y="256032"/>
+            <a:ext cx="2194560" cy="292608"/>
+          </a:xfrm>
+          <a:prstGeom prst="rect">
+            <a:avLst/>
+          </a:prstGeom>
+          <a:noFill/>
+        </p:spPr>
+        <p:txBody>
+          <a:bodyPr wrap="none">
+            <a:spAutoFit/>
+          </a:bodyPr>
+          <a:lstStyle/>
+          <a:p>
+            <a:pPr algn="l"/>
+            <a:r>
+              <a:rPr sz="1100" b="1">
+                <a:solidFill>
+                  <a:srgbClr val="FFFFFF"/>
+                </a:solidFill>
+                <a:latin typeface="Calibri"/>
+              </a:rPr>
+              <a:t>OPENING</a:t>
+            </a:r>
+          </a:p>
+        </p:txBody>
+      </p:sp>
+      <p:sp>
+        <p:nvSpPr>
           <p:cNvPr id="6" name="TextBox 5"/>
           <p:cNvSpPr txBox="1"/>
           <p:nvPr/>
         </p:nvSpPr>
         <p:spPr>
           <a:xfrm>
-            <a:off x="548640" y="1280160"/>
-            <a:ext cx="10972800" cy="5029200"/>
+            <a:off x="548640" y="640080"/>
+            <a:ext cx="10972800" cy="548640"/>
+          </a:xfrm>
+          <a:prstGeom prst="rect">
+            <a:avLst/>
+          </a:prstGeom>
+          <a:noFill/>
+        </p:spPr>
+        <p:txBody>
+          <a:bodyPr wrap="none">
+            <a:spAutoFit/>
+          </a:bodyPr>
+          <a:lstStyle/>
+          <a:p>
+            <a:r>
+              <a:rPr sz="2600" b="1">
+                <a:solidFill>
+                  <a:srgbClr val="1A1A1A"/>
+                </a:solidFill>
+                <a:latin typeface="Calibri"/>
+              </a:rPr>
+              <a:t>Agenda</a:t>
+            </a:r>
+          </a:p>
+        </p:txBody>
+      </p:sp>
+      <p:sp>
+        <p:nvSpPr>
+          <p:cNvPr id="7" name="Rectangle 6"/>
+          <p:cNvSpPr/>
+          <p:nvPr/>
+        </p:nvSpPr>
+        <p:spPr>
+          <a:xfrm>
+            <a:off x="548640" y="1234440"/>
+            <a:ext cx="1828800" cy="45720"/>
+          </a:xfrm>
+          <a:prstGeom prst="rect">
+            <a:avLst/>
+          </a:prstGeom>
+          <a:solidFill>
+            <a:srgbClr val="EE0000"/>
+          </a:solidFill>
+          <a:ln>
+            <a:noFill/>
+          </a:ln>
+        </p:spPr>
+        <p:style>
+          <a:lnRef idx="1">
+            <a:schemeClr val="accent1"/>
+          </a:lnRef>
+          <a:fillRef idx="3">
+            <a:schemeClr val="accent1"/>
+          </a:fillRef>
+          <a:effectRef idx="2">
+            <a:schemeClr val="accent1"/>
+          </a:effectRef>
+          <a:fontRef idx="minor">
+            <a:schemeClr val="lt1"/>
+          </a:fontRef>
+        </p:style>
+        <p:txBody>
+          <a:bodyPr rtlCol="0" anchor="ctr"/>
+          <a:lstStyle/>
+          <a:p>
+            <a:pPr algn="ctr"/>
+          </a:p>
+        </p:txBody>
+      </p:sp>
+      <p:sp>
+        <p:nvSpPr>
+          <p:cNvPr id="8" name="TextBox 7"/>
+          <p:cNvSpPr txBox="1"/>
+          <p:nvPr/>
+        </p:nvSpPr>
+        <p:spPr>
+          <a:xfrm>
+            <a:off x="548640" y="1463040"/>
+            <a:ext cx="10972800" cy="4572000"/>
           </a:xfrm>
           <a:prstGeom prst="rect">
             <a:avLst/>
@@ -5219,65 +5627,99 @@
           <a:p>
             <a:pPr>
               <a:spcAft>
-                <a:spcPts val="1000"/>
+                <a:spcPts val="900"/>
               </a:spcAft>
             </a:pPr>
             <a:r>
-              <a:rPr sz="2000" b="0">
+              <a:rPr sz="1800" b="0">
                 <a:solidFill>
                   <a:srgbClr val="1A1A1A"/>
                 </a:solidFill>
                 <a:latin typeface="Calibri"/>
               </a:rPr>
-              <a:t>•  Gold RHEL image from a versioned Image Builder blueprint in Git</a:t>
+              <a:t>•  Opening — team, challenges, objective (now)</a:t>
             </a:r>
           </a:p>
           <a:p>
             <a:pPr>
               <a:spcAft>
-                <a:spcPts val="1000"/>
+                <a:spcPts val="900"/>
               </a:spcAft>
             </a:pPr>
             <a:r>
-              <a:rPr sz="2000" b="0">
+              <a:rPr sz="1800" b="0">
                 <a:solidFill>
                   <a:srgbClr val="1A1A1A"/>
                 </a:solidFill>
                 <a:latin typeface="Calibri"/>
               </a:rPr>
-              <a:t>•  Compose once to AMI (AWS) and VHD (Azure)</a:t>
+              <a:t>•  Live walkthrough — end-user path: gold image → VM → prove controls (5–10 min)</a:t>
             </a:r>
           </a:p>
           <a:p>
             <a:pPr>
               <a:spcAft>
-                <a:spcPts val="1000"/>
+                <a:spcPts val="900"/>
               </a:spcAft>
             </a:pPr>
             <a:r>
-              <a:rPr sz="2000" b="0">
+              <a:rPr sz="1800" b="0">
                 <a:solidFill>
                   <a:srgbClr val="1A1A1A"/>
                 </a:solidFill>
                 <a:latin typeface="Calibri"/>
               </a:rPr>
-              <a:t>•  Launch VMs from that image — same controls every time</a:t>
+              <a:t>•  Value summary — how this solves Fedora Lane’s challenges (2–5 min)</a:t>
             </a:r>
           </a:p>
           <a:p>
             <a:pPr>
               <a:spcAft>
-                <a:spcPts val="1000"/>
+                <a:spcPts val="900"/>
               </a:spcAft>
             </a:pPr>
             <a:r>
-              <a:rPr sz="2000" b="0">
+              <a:rPr sz="1800" b="0">
                 <a:solidFill>
                   <a:srgbClr val="1A1A1A"/>
                 </a:solidFill>
                 <a:latin typeface="Calibri"/>
               </a:rPr>
-              <a:t>•  Local Image Builder (not hosted console.redhat.com)</a:t>
+              <a:t>•  Closing — one concrete next step (1–2 min)</a:t>
+            </a:r>
+          </a:p>
+        </p:txBody>
+      </p:sp>
+      <p:sp>
+        <p:nvSpPr>
+          <p:cNvPr id="9" name="TextBox 8"/>
+          <p:cNvSpPr txBox="1"/>
+          <p:nvPr/>
+        </p:nvSpPr>
+        <p:spPr>
+          <a:xfrm>
+            <a:off x="548640" y="6263640"/>
+            <a:ext cx="10972800" cy="365760"/>
+          </a:xfrm>
+          <a:prstGeom prst="rect">
+            <a:avLst/>
+          </a:prstGeom>
+          <a:noFill/>
+        </p:spPr>
+        <p:txBody>
+          <a:bodyPr wrap="none">
+            <a:spAutoFit/>
+          </a:bodyPr>
+          <a:lstStyle/>
+          <a:p>
+            <a:r>
+              <a:rPr sz="1300" b="0">
+                <a:solidFill>
+                  <a:srgbClr val="666666"/>
+                </a:solidFill>
+                <a:latin typeface="Calibri"/>
+              </a:rPr>
+              <a:t>Transition → live walkthrough</a:t>
             </a:r>
           </a:p>
         </p:txBody>
@@ -5388,50 +5830,16 @@
       </p:sp>
       <p:sp>
         <p:nvSpPr>
-          <p:cNvPr id="4" name="TextBox 3"/>
-          <p:cNvSpPr txBox="1"/>
-          <p:nvPr/>
-        </p:nvSpPr>
-        <p:spPr>
-          <a:xfrm>
-            <a:off x="548640" y="320040"/>
-            <a:ext cx="10972800" cy="640080"/>
-          </a:xfrm>
-          <a:prstGeom prst="rect">
-            <a:avLst/>
-          </a:prstGeom>
-          <a:noFill/>
-        </p:spPr>
-        <p:txBody>
-          <a:bodyPr wrap="none">
-            <a:spAutoFit/>
-          </a:bodyPr>
-          <a:lstStyle/>
-          <a:p>
-            <a:r>
-              <a:rPr sz="2800" b="1">
-                <a:solidFill>
-                  <a:srgbClr val="1A1A1A"/>
-                </a:solidFill>
-                <a:latin typeface="Calibri"/>
-              </a:rPr>
-              <a:t>Architecture</a:t>
-            </a:r>
-          </a:p>
-        </p:txBody>
-      </p:sp>
-      <p:sp>
-        <p:nvSpPr>
-          <p:cNvPr id="5" name="Rectangle 4"/>
+          <p:cNvPr id="4" name="Rounded Rectangle 3"/>
           <p:cNvSpPr/>
           <p:nvPr/>
         </p:nvSpPr>
         <p:spPr>
           <a:xfrm>
-            <a:off x="548640" y="960120"/>
-            <a:ext cx="2011680" cy="54864"/>
-          </a:xfrm>
-          <a:prstGeom prst="rect">
+            <a:off x="548640" y="228600"/>
+            <a:ext cx="2194560" cy="320040"/>
+          </a:xfrm>
+          <a:prstGeom prst="roundRect">
             <a:avLst/>
           </a:prstGeom>
           <a:solidFill>
@@ -5465,14 +5873,126 @@
       </p:sp>
       <p:sp>
         <p:nvSpPr>
+          <p:cNvPr id="5" name="TextBox 4"/>
+          <p:cNvSpPr txBox="1"/>
+          <p:nvPr/>
+        </p:nvSpPr>
+        <p:spPr>
+          <a:xfrm>
+            <a:off x="548640" y="256032"/>
+            <a:ext cx="2194560" cy="292608"/>
+          </a:xfrm>
+          <a:prstGeom prst="rect">
+            <a:avLst/>
+          </a:prstGeom>
+          <a:noFill/>
+        </p:spPr>
+        <p:txBody>
+          <a:bodyPr wrap="none">
+            <a:spAutoFit/>
+          </a:bodyPr>
+          <a:lstStyle/>
+          <a:p>
+            <a:pPr algn="l"/>
+            <a:r>
+              <a:rPr sz="1100" b="1">
+                <a:solidFill>
+                  <a:srgbClr val="FFFFFF"/>
+                </a:solidFill>
+                <a:latin typeface="Calibri"/>
+              </a:rPr>
+              <a:t>WALKTHROUGH · 5–10 min</a:t>
+            </a:r>
+          </a:p>
+        </p:txBody>
+      </p:sp>
+      <p:sp>
+        <p:nvSpPr>
           <p:cNvPr id="6" name="TextBox 5"/>
           <p:cNvSpPr txBox="1"/>
           <p:nvPr/>
         </p:nvSpPr>
         <p:spPr>
           <a:xfrm>
-            <a:off x="548640" y="1280160"/>
-            <a:ext cx="10972800" cy="5029200"/>
+            <a:off x="548640" y="640080"/>
+            <a:ext cx="10972800" cy="548640"/>
+          </a:xfrm>
+          <a:prstGeom prst="rect">
+            <a:avLst/>
+          </a:prstGeom>
+          <a:noFill/>
+        </p:spPr>
+        <p:txBody>
+          <a:bodyPr wrap="none">
+            <a:spAutoFit/>
+          </a:bodyPr>
+          <a:lstStyle/>
+          <a:p>
+            <a:r>
+              <a:rPr sz="2600" b="1">
+                <a:solidFill>
+                  <a:srgbClr val="1A1A1A"/>
+                </a:solidFill>
+                <a:latin typeface="Calibri"/>
+              </a:rPr>
+              <a:t>What we implemented</a:t>
+            </a:r>
+          </a:p>
+        </p:txBody>
+      </p:sp>
+      <p:sp>
+        <p:nvSpPr>
+          <p:cNvPr id="7" name="Rectangle 6"/>
+          <p:cNvSpPr/>
+          <p:nvPr/>
+        </p:nvSpPr>
+        <p:spPr>
+          <a:xfrm>
+            <a:off x="548640" y="1234440"/>
+            <a:ext cx="1828800" cy="45720"/>
+          </a:xfrm>
+          <a:prstGeom prst="rect">
+            <a:avLst/>
+          </a:prstGeom>
+          <a:solidFill>
+            <a:srgbClr val="EE0000"/>
+          </a:solidFill>
+          <a:ln>
+            <a:noFill/>
+          </a:ln>
+        </p:spPr>
+        <p:style>
+          <a:lnRef idx="1">
+            <a:schemeClr val="accent1"/>
+          </a:lnRef>
+          <a:fillRef idx="3">
+            <a:schemeClr val="accent1"/>
+          </a:fillRef>
+          <a:effectRef idx="2">
+            <a:schemeClr val="accent1"/>
+          </a:effectRef>
+          <a:fontRef idx="minor">
+            <a:schemeClr val="lt1"/>
+          </a:fontRef>
+        </p:style>
+        <p:txBody>
+          <a:bodyPr rtlCol="0" anchor="ctr"/>
+          <a:lstStyle/>
+          <a:p>
+            <a:pPr algn="ctr"/>
+          </a:p>
+        </p:txBody>
+      </p:sp>
+      <p:sp>
+        <p:nvSpPr>
+          <p:cNvPr id="8" name="TextBox 7"/>
+          <p:cNvSpPr txBox="1"/>
+          <p:nvPr/>
+        </p:nvSpPr>
+        <p:spPr>
+          <a:xfrm>
+            <a:off x="548640" y="1463040"/>
+            <a:ext cx="10972800" cy="4572000"/>
           </a:xfrm>
           <a:prstGeom prst="rect">
             <a:avLst/>
@@ -5487,99 +6007,81 @@
           <a:p>
             <a:pPr>
               <a:spcAft>
-                <a:spcPts val="1000"/>
+                <a:spcPts val="900"/>
               </a:spcAft>
             </a:pPr>
             <a:r>
-              <a:rPr sz="2000" b="0">
+              <a:rPr sz="1800" b="0">
                 <a:solidFill>
                   <a:srgbClr val="1A1A1A"/>
                 </a:solidFill>
                 <a:latin typeface="Calibri"/>
               </a:rPr>
-              <a:t>•  Expansion Pack controls live in the blueprint (Git)</a:t>
+              <a:t>•  Versioned Image Builder blueprint in Git (source of truth)</a:t>
             </a:r>
           </a:p>
           <a:p>
             <a:pPr>
               <a:spcAft>
-                <a:spcPts val="1000"/>
+                <a:spcPts val="900"/>
               </a:spcAft>
             </a:pPr>
             <a:r>
-              <a:rPr sz="2000" b="0">
+              <a:rPr sz="1800" b="0">
                 <a:solidFill>
                   <a:srgbClr val="1A1A1A"/>
                 </a:solidFill>
                 <a:latin typeface="Calibri"/>
               </a:rPr>
-              <a:t>•  Local RHEL Image Builder composes the gold image</a:t>
+              <a:t>•  Local RHEL Image Builder compose → gold AMI (AWS) and gold VHD (Azure)</a:t>
             </a:r>
           </a:p>
           <a:p>
             <a:pPr>
               <a:spcAft>
-                <a:spcPts val="1000"/>
+                <a:spcPts val="900"/>
               </a:spcAft>
             </a:pPr>
             <a:r>
-              <a:rPr sz="2000" b="0">
+              <a:rPr sz="1800" b="0">
                 <a:solidFill>
                   <a:srgbClr val="1A1A1A"/>
                 </a:solidFill>
                 <a:latin typeface="Calibri"/>
               </a:rPr>
-              <a:t>•  Outputs: AWS gold AMI  and  Azure gold VHD → managed image</a:t>
+              <a:t>•  Launch gold VMs from that image — not stock Marketplace OS</a:t>
             </a:r>
           </a:p>
           <a:p>
             <a:pPr>
               <a:spcAft>
-                <a:spcPts val="1000"/>
+                <a:spcPts val="900"/>
               </a:spcAft>
             </a:pPr>
             <a:r>
-              <a:rPr sz="2000" b="0">
+              <a:rPr sz="1800" b="0">
                 <a:solidFill>
                   <a:srgbClr val="1A1A1A"/>
                 </a:solidFill>
                 <a:latin typeface="Calibri"/>
               </a:rPr>
-              <a:t>•  Launch gold VMs — verify + reboot proven on both clouds</a:t>
-            </a:r>
-          </a:p>
-        </p:txBody>
-      </p:sp>
-      <p:sp>
-        <p:nvSpPr>
-          <p:cNvPr id="7" name="TextBox 6"/>
-          <p:cNvSpPr txBox="1"/>
-          <p:nvPr/>
-        </p:nvSpPr>
-        <p:spPr>
-          <a:xfrm>
-            <a:off x="548640" y="6263640"/>
-            <a:ext cx="10972800" cy="365760"/>
-          </a:xfrm>
-          <a:prstGeom prst="rect">
-            <a:avLst/>
-          </a:prstGeom>
-          <a:noFill/>
-        </p:spPr>
-        <p:txBody>
-          <a:bodyPr wrap="none">
-            <a:spAutoFit/>
-          </a:bodyPr>
-          <a:lstStyle/>
-          <a:p>
-            <a:r>
-              <a:rPr sz="1400" b="0">
-                <a:solidFill>
-                  <a:srgbClr val="666666"/>
-                </a:solidFill>
-                <a:latin typeface="Calibri"/>
-              </a:rPr>
-              <a:t>Blueprint → Compose → AMI/VHD → Launch → Gold web node</a:t>
+              <a:t>•  Expansion Pack controls baked in; httpd runs as a container on port 35443</a:t>
+            </a:r>
+          </a:p>
+          <a:p>
+            <a:pPr>
+              <a:spcAft>
+                <a:spcPts val="900"/>
+              </a:spcAft>
+            </a:pPr>
+            <a:r>
+              <a:rPr sz="1800" b="0">
+                <a:solidFill>
+                  <a:srgbClr val="1A1A1A"/>
+                </a:solidFill>
+                <a:latin typeface="Calibri"/>
+              </a:rPr>
+              <a:t>•  Working deployment you can verify live (SSH 2222 + curl 35443)</a:t>
             </a:r>
           </a:p>
         </p:txBody>
@@ -5690,50 +6192,16 @@
       </p:sp>
       <p:sp>
         <p:nvSpPr>
-          <p:cNvPr id="4" name="TextBox 3"/>
-          <p:cNvSpPr txBox="1"/>
-          <p:nvPr/>
-        </p:nvSpPr>
-        <p:spPr>
-          <a:xfrm>
-            <a:off x="548640" y="320040"/>
-            <a:ext cx="10972800" cy="640080"/>
-          </a:xfrm>
-          <a:prstGeom prst="rect">
-            <a:avLst/>
-          </a:prstGeom>
-          <a:noFill/>
-        </p:spPr>
-        <p:txBody>
-          <a:bodyPr wrap="none">
-            <a:spAutoFit/>
-          </a:bodyPr>
-          <a:lstStyle/>
-          <a:p>
-            <a:r>
-              <a:rPr sz="2800" b="1">
-                <a:solidFill>
-                  <a:srgbClr val="1A1A1A"/>
-                </a:solidFill>
-                <a:latin typeface="Calibri"/>
-              </a:rPr>
-              <a:t>Path: blueprint → running VM</a:t>
-            </a:r>
-          </a:p>
-        </p:txBody>
-      </p:sp>
-      <p:sp>
-        <p:nvSpPr>
-          <p:cNvPr id="5" name="Rectangle 4"/>
+          <p:cNvPr id="4" name="Rounded Rectangle 3"/>
           <p:cNvSpPr/>
           <p:nvPr/>
         </p:nvSpPr>
         <p:spPr>
           <a:xfrm>
-            <a:off x="548640" y="960120"/>
-            <a:ext cx="2011680" cy="54864"/>
-          </a:xfrm>
-          <a:prstGeom prst="rect">
+            <a:off x="548640" y="228600"/>
+            <a:ext cx="2194560" cy="320040"/>
+          </a:xfrm>
+          <a:prstGeom prst="roundRect">
             <a:avLst/>
           </a:prstGeom>
           <a:solidFill>
@@ -5767,14 +6235,126 @@
       </p:sp>
       <p:sp>
         <p:nvSpPr>
+          <p:cNvPr id="5" name="TextBox 4"/>
+          <p:cNvSpPr txBox="1"/>
+          <p:nvPr/>
+        </p:nvSpPr>
+        <p:spPr>
+          <a:xfrm>
+            <a:off x="548640" y="256032"/>
+            <a:ext cx="2194560" cy="292608"/>
+          </a:xfrm>
+          <a:prstGeom prst="rect">
+            <a:avLst/>
+          </a:prstGeom>
+          <a:noFill/>
+        </p:spPr>
+        <p:txBody>
+          <a:bodyPr wrap="none">
+            <a:spAutoFit/>
+          </a:bodyPr>
+          <a:lstStyle/>
+          <a:p>
+            <a:pPr algn="l"/>
+            <a:r>
+              <a:rPr sz="1100" b="1">
+                <a:solidFill>
+                  <a:srgbClr val="FFFFFF"/>
+                </a:solidFill>
+                <a:latin typeface="Calibri"/>
+              </a:rPr>
+              <a:t>WALKTHROUGH</a:t>
+            </a:r>
+          </a:p>
+        </p:txBody>
+      </p:sp>
+      <p:sp>
+        <p:nvSpPr>
           <p:cNvPr id="6" name="TextBox 5"/>
           <p:cNvSpPr txBox="1"/>
           <p:nvPr/>
         </p:nvSpPr>
         <p:spPr>
           <a:xfrm>
-            <a:off x="548640" y="1280160"/>
-            <a:ext cx="10972800" cy="5029200"/>
+            <a:off x="548640" y="640080"/>
+            <a:ext cx="10972800" cy="548640"/>
+          </a:xfrm>
+          <a:prstGeom prst="rect">
+            <a:avLst/>
+          </a:prstGeom>
+          <a:noFill/>
+        </p:spPr>
+        <p:txBody>
+          <a:bodyPr wrap="none">
+            <a:spAutoFit/>
+          </a:bodyPr>
+          <a:lstStyle/>
+          <a:p>
+            <a:r>
+              <a:rPr sz="2600" b="1">
+                <a:solidFill>
+                  <a:srgbClr val="1A1A1A"/>
+                </a:solidFill>
+                <a:latin typeface="Calibri"/>
+              </a:rPr>
+              <a:t>Critical decisions — and why</a:t>
+            </a:r>
+          </a:p>
+        </p:txBody>
+      </p:sp>
+      <p:sp>
+        <p:nvSpPr>
+          <p:cNvPr id="7" name="Rectangle 6"/>
+          <p:cNvSpPr/>
+          <p:nvPr/>
+        </p:nvSpPr>
+        <p:spPr>
+          <a:xfrm>
+            <a:off x="548640" y="1234440"/>
+            <a:ext cx="1828800" cy="45720"/>
+          </a:xfrm>
+          <a:prstGeom prst="rect">
+            <a:avLst/>
+          </a:prstGeom>
+          <a:solidFill>
+            <a:srgbClr val="EE0000"/>
+          </a:solidFill>
+          <a:ln>
+            <a:noFill/>
+          </a:ln>
+        </p:spPr>
+        <p:style>
+          <a:lnRef idx="1">
+            <a:schemeClr val="accent1"/>
+          </a:lnRef>
+          <a:fillRef idx="3">
+            <a:schemeClr val="accent1"/>
+          </a:fillRef>
+          <a:effectRef idx="2">
+            <a:schemeClr val="accent1"/>
+          </a:effectRef>
+          <a:fontRef idx="minor">
+            <a:schemeClr val="lt1"/>
+          </a:fontRef>
+        </p:style>
+        <p:txBody>
+          <a:bodyPr rtlCol="0" anchor="ctr"/>
+          <a:lstStyle/>
+          <a:p>
+            <a:pPr algn="ctr"/>
+          </a:p>
+        </p:txBody>
+      </p:sp>
+      <p:sp>
+        <p:nvSpPr>
+          <p:cNvPr id="8" name="TextBox 7"/>
+          <p:cNvSpPr txBox="1"/>
+          <p:nvPr/>
+        </p:nvSpPr>
+        <p:spPr>
+          <a:xfrm>
+            <a:off x="548640" y="1463040"/>
+            <a:ext cx="10972800" cy="4572000"/>
           </a:xfrm>
           <a:prstGeom prst="rect">
             <a:avLst/>
@@ -5789,131 +6369,81 @@
           <a:p>
             <a:pPr>
               <a:spcAft>
-                <a:spcPts val="1000"/>
+                <a:spcPts val="900"/>
               </a:spcAft>
             </a:pPr>
             <a:r>
-              <a:rPr sz="2000" b="0">
+              <a:rPr sz="1800" b="0">
                 <a:solidFill>
                   <a:srgbClr val="1A1A1A"/>
                 </a:solidFill>
                 <a:latin typeface="Calibri"/>
               </a:rPr>
-              <a:t>•  1. Blueprint — mounts, users, ports, packages (Git)</a:t>
+              <a:t>•  Local Image Builder (not hosted console.redhat.com) — matches Expansion Pack manual compose</a:t>
             </a:r>
           </a:p>
           <a:p>
             <a:pPr>
               <a:spcAft>
-                <a:spcPts val="1000"/>
+                <a:spcPts val="900"/>
               </a:spcAft>
             </a:pPr>
             <a:r>
-              <a:rPr sz="2000" b="0">
+              <a:rPr sz="1800" b="0">
                 <a:solidFill>
                   <a:srgbClr val="1A1A1A"/>
                 </a:solidFill>
                 <a:latin typeface="Calibri"/>
               </a:rPr>
-              <a:t>•  2. Compose — Image Builder builds AMI or VHD (RHSM builder)</a:t>
+              <a:t>•  One blueprint → two cloud artifacts — same controls on AWS and Azure</a:t>
             </a:r>
           </a:p>
           <a:p>
             <a:pPr>
               <a:spcAft>
-                <a:spcPts val="1000"/>
+                <a:spcPts val="900"/>
               </a:spcAft>
             </a:pPr>
             <a:r>
-              <a:rPr sz="2000" b="0">
+              <a:rPr sz="1800" b="0">
                 <a:solidFill>
                   <a:srgbClr val="1A1A1A"/>
                 </a:solidFill>
                 <a:latin typeface="Calibri"/>
               </a:rPr>
-              <a:t>•  3. Register — AMI in AWS / managed image in Azure</a:t>
+              <a:t>•  Replace from gold image in waves — not rebuild 1,600×, not in-place root swap</a:t>
             </a:r>
           </a:p>
           <a:p>
             <a:pPr>
               <a:spcAft>
-                <a:spcPts val="1000"/>
+                <a:spcPts val="900"/>
               </a:spcAft>
             </a:pPr>
             <a:r>
-              <a:rPr sz="2000" b="0">
+              <a:rPr sz="1800" b="0">
                 <a:solidFill>
                   <a:srgbClr val="1A1A1A"/>
                 </a:solidFill>
                 <a:latin typeface="Calibri"/>
               </a:rPr>
-              <a:t>•  4. Launch — new VM from gold image (not stock Marketplace)</a:t>
+              <a:t>•  Firstboot / User data starts httpd — image has the tooling; launch completes the service</a:t>
             </a:r>
           </a:p>
           <a:p>
             <a:pPr>
               <a:spcAft>
-                <a:spcPts val="1000"/>
+                <a:spcPts val="900"/>
               </a:spcAft>
             </a:pPr>
             <a:r>
-              <a:rPr sz="2000" b="0">
+              <a:rPr sz="1800" b="0">
                 <a:solidFill>
                   <a:srgbClr val="1A1A1A"/>
                 </a:solidFill>
                 <a:latin typeface="Calibri"/>
               </a:rPr>
-              <a:t>•  5. Firstboot — starts httpd container on port 35443</a:t>
-            </a:r>
-          </a:p>
-          <a:p>
-            <a:pPr>
-              <a:spcAft>
-                <a:spcPts val="1000"/>
-              </a:spcAft>
-            </a:pPr>
-            <a:r>
-              <a:rPr sz="2000" b="0">
-                <a:solidFill>
-                  <a:srgbClr val="1A1A1A"/>
-                </a:solidFill>
-                <a:latin typeface="Calibri"/>
-              </a:rPr>
-              <a:t>•  6. Verify — SELinux, mounts, ports, curl, reboot</a:t>
-            </a:r>
-          </a:p>
-        </p:txBody>
-      </p:sp>
-      <p:sp>
-        <p:nvSpPr>
-          <p:cNvPr id="7" name="TextBox 6"/>
-          <p:cNvSpPr txBox="1"/>
-          <p:nvPr/>
-        </p:nvSpPr>
-        <p:spPr>
-          <a:xfrm>
-            <a:off x="548640" y="6263640"/>
-            <a:ext cx="10972800" cy="365760"/>
-          </a:xfrm>
-          <a:prstGeom prst="rect">
-            <a:avLst/>
-          </a:prstGeom>
-          <a:noFill/>
-        </p:spPr>
-        <p:txBody>
-          <a:bodyPr wrap="none">
-            <a:spAutoFit/>
-          </a:bodyPr>
-          <a:lstStyle/>
-          <a:p>
-            <a:r>
-              <a:rPr sz="1400" b="0">
-                <a:solidFill>
-                  <a:srgbClr val="666666"/>
-                </a:solidFill>
-                <a:latin typeface="Calibri"/>
-              </a:rPr>
-              <a:t>SG/NSG opens ports 2222 &amp; 35443 · Firstboot / User data starts httpd</a:t>
+              <a:t>•  SG/NSG separate from image — network policy stays in cloud controls</a:t>
             </a:r>
           </a:p>
         </p:txBody>
@@ -6024,50 +6554,16 @@
       </p:sp>
       <p:sp>
         <p:nvSpPr>
-          <p:cNvPr id="4" name="TextBox 3"/>
-          <p:cNvSpPr txBox="1"/>
-          <p:nvPr/>
-        </p:nvSpPr>
-        <p:spPr>
-          <a:xfrm>
-            <a:off x="548640" y="320040"/>
-            <a:ext cx="10972800" cy="640080"/>
-          </a:xfrm>
-          <a:prstGeom prst="rect">
-            <a:avLst/>
-          </a:prstGeom>
-          <a:noFill/>
-        </p:spPr>
-        <p:txBody>
-          <a:bodyPr wrap="none">
-            <a:spAutoFit/>
-          </a:bodyPr>
-          <a:lstStyle/>
-          <a:p>
-            <a:r>
-              <a:rPr sz="2800" b="1">
-                <a:solidFill>
-                  <a:srgbClr val="1A1A1A"/>
-                </a:solidFill>
-                <a:latin typeface="Calibri"/>
-              </a:rPr>
-              <a:t>Expansion Pack controls (baked in)</a:t>
-            </a:r>
-          </a:p>
-        </p:txBody>
-      </p:sp>
-      <p:sp>
-        <p:nvSpPr>
-          <p:cNvPr id="5" name="Rectangle 4"/>
+          <p:cNvPr id="4" name="Rounded Rectangle 3"/>
           <p:cNvSpPr/>
           <p:nvPr/>
         </p:nvSpPr>
         <p:spPr>
           <a:xfrm>
-            <a:off x="548640" y="960120"/>
-            <a:ext cx="2011680" cy="54864"/>
-          </a:xfrm>
-          <a:prstGeom prst="rect">
+            <a:off x="548640" y="228600"/>
+            <a:ext cx="2194560" cy="320040"/>
+          </a:xfrm>
+          <a:prstGeom prst="roundRect">
             <a:avLst/>
           </a:prstGeom>
           <a:solidFill>
@@ -6101,14 +6597,126 @@
       </p:sp>
       <p:sp>
         <p:nvSpPr>
+          <p:cNvPr id="5" name="TextBox 4"/>
+          <p:cNvSpPr txBox="1"/>
+          <p:nvPr/>
+        </p:nvSpPr>
+        <p:spPr>
+          <a:xfrm>
+            <a:off x="548640" y="256032"/>
+            <a:ext cx="2194560" cy="292608"/>
+          </a:xfrm>
+          <a:prstGeom prst="rect">
+            <a:avLst/>
+          </a:prstGeom>
+          <a:noFill/>
+        </p:spPr>
+        <p:txBody>
+          <a:bodyPr wrap="none">
+            <a:spAutoFit/>
+          </a:bodyPr>
+          <a:lstStyle/>
+          <a:p>
+            <a:pPr algn="l"/>
+            <a:r>
+              <a:rPr sz="1100" b="1">
+                <a:solidFill>
+                  <a:srgbClr val="FFFFFF"/>
+                </a:solidFill>
+                <a:latin typeface="Calibri"/>
+              </a:rPr>
+              <a:t>WALKTHROUGH</a:t>
+            </a:r>
+          </a:p>
+        </p:txBody>
+      </p:sp>
+      <p:sp>
+        <p:nvSpPr>
           <p:cNvPr id="6" name="TextBox 5"/>
           <p:cNvSpPr txBox="1"/>
           <p:nvPr/>
         </p:nvSpPr>
         <p:spPr>
           <a:xfrm>
-            <a:off x="548640" y="1280160"/>
-            <a:ext cx="10972800" cy="5029200"/>
+            <a:off x="548640" y="640080"/>
+            <a:ext cx="10972800" cy="548640"/>
+          </a:xfrm>
+          <a:prstGeom prst="rect">
+            <a:avLst/>
+          </a:prstGeom>
+          <a:noFill/>
+        </p:spPr>
+        <p:txBody>
+          <a:bodyPr wrap="none">
+            <a:spAutoFit/>
+          </a:bodyPr>
+          <a:lstStyle/>
+          <a:p>
+            <a:r>
+              <a:rPr sz="2600" b="1">
+                <a:solidFill>
+                  <a:srgbClr val="1A1A1A"/>
+                </a:solidFill>
+                <a:latin typeface="Calibri"/>
+              </a:rPr>
+              <a:t>Live path (end-user view)</a:t>
+            </a:r>
+          </a:p>
+        </p:txBody>
+      </p:sp>
+      <p:sp>
+        <p:nvSpPr>
+          <p:cNvPr id="7" name="Rectangle 6"/>
+          <p:cNvSpPr/>
+          <p:nvPr/>
+        </p:nvSpPr>
+        <p:spPr>
+          <a:xfrm>
+            <a:off x="548640" y="1234440"/>
+            <a:ext cx="1828800" cy="45720"/>
+          </a:xfrm>
+          <a:prstGeom prst="rect">
+            <a:avLst/>
+          </a:prstGeom>
+          <a:solidFill>
+            <a:srgbClr val="EE0000"/>
+          </a:solidFill>
+          <a:ln>
+            <a:noFill/>
+          </a:ln>
+        </p:spPr>
+        <p:style>
+          <a:lnRef idx="1">
+            <a:schemeClr val="accent1"/>
+          </a:lnRef>
+          <a:fillRef idx="3">
+            <a:schemeClr val="accent1"/>
+          </a:fillRef>
+          <a:effectRef idx="2">
+            <a:schemeClr val="accent1"/>
+          </a:effectRef>
+          <a:fontRef idx="minor">
+            <a:schemeClr val="lt1"/>
+          </a:fontRef>
+        </p:style>
+        <p:txBody>
+          <a:bodyPr rtlCol="0" anchor="ctr"/>
+          <a:lstStyle/>
+          <a:p>
+            <a:pPr algn="ctr"/>
+          </a:p>
+        </p:txBody>
+      </p:sp>
+      <p:sp>
+        <p:nvSpPr>
+          <p:cNvPr id="8" name="TextBox 7"/>
+          <p:cNvSpPr txBox="1"/>
+          <p:nvPr/>
+        </p:nvSpPr>
+        <p:spPr>
+          <a:xfrm>
+            <a:off x="548640" y="1463040"/>
+            <a:ext cx="10972800" cy="4572000"/>
           </a:xfrm>
           <a:prstGeom prst="rect">
             <a:avLst/>
@@ -6123,97 +6731,131 @@
           <a:p>
             <a:pPr>
               <a:spcAft>
-                <a:spcPts val="1000"/>
+                <a:spcPts val="900"/>
               </a:spcAft>
             </a:pPr>
             <a:r>
-              <a:rPr sz="2000" b="0">
+              <a:rPr sz="1800" b="0">
                 <a:solidFill>
                   <a:srgbClr val="1A1A1A"/>
                 </a:solidFill>
                 <a:latin typeface="Calibri"/>
               </a:rPr>
-              <a:t>•  Separate filesystems: /var/log, /home, /tmp, /var/tmp</a:t>
+              <a:t>•  1. Blueprint in Git — recipe for mounts, SSH, fladmins, ports</a:t>
             </a:r>
           </a:p>
           <a:p>
             <a:pPr>
               <a:spcAft>
-                <a:spcPts val="1000"/>
+                <a:spcPts val="900"/>
               </a:spcAft>
             </a:pPr>
             <a:r>
-              <a:rPr sz="2000" b="0">
+              <a:rPr sz="1800" b="0">
                 <a:solidFill>
                   <a:srgbClr val="1A1A1A"/>
                 </a:solidFill>
                 <a:latin typeface="Calibri"/>
               </a:rPr>
-              <a:t>•  /tmp mounted noexec · SELinux enforcing</a:t>
+              <a:t>•  2. Compose on subscribed RHEL builder → AMI or VHD</a:t>
             </a:r>
           </a:p>
           <a:p>
             <a:pPr>
               <a:spcAft>
-                <a:spcPts val="1000"/>
+                <a:spcPts val="900"/>
               </a:spcAft>
             </a:pPr>
             <a:r>
-              <a:rPr sz="2000" b="0">
+              <a:rPr sz="1800" b="0">
                 <a:solidFill>
                   <a:srgbClr val="1A1A1A"/>
                 </a:solidFill>
                 <a:latin typeface="Calibri"/>
               </a:rPr>
-              <a:t>•  SSH on port 2222 — key-only, no root SSH</a:t>
+              <a:t>•  3. Register gold image in AWS / Azure</a:t>
             </a:r>
           </a:p>
           <a:p>
             <a:pPr>
               <a:spcAft>
-                <a:spcPts val="1000"/>
+                <a:spcPts val="900"/>
               </a:spcAft>
             </a:pPr>
             <a:r>
-              <a:rPr sz="2000" b="0">
+              <a:rPr sz="1800" b="0">
                 <a:solidFill>
                   <a:srgbClr val="1A1A1A"/>
                 </a:solidFill>
                 <a:latin typeface="Calibri"/>
               </a:rPr>
-              <a:t>•  Admins: fladmins group · fladmin1 / fladmin2</a:t>
+              <a:t>•  4. Launch VM from gold image (Console or CLI)</a:t>
             </a:r>
           </a:p>
           <a:p>
             <a:pPr>
               <a:spcAft>
-                <a:spcPts val="1000"/>
+                <a:spcPts val="900"/>
               </a:spcAft>
             </a:pPr>
             <a:r>
-              <a:rPr sz="2000" b="0">
+              <a:rPr sz="1800" b="0">
                 <a:solidFill>
                   <a:srgbClr val="1A1A1A"/>
                 </a:solidFill>
                 <a:latin typeface="Calibri"/>
               </a:rPr>
-              <a:t>•  httpd in a container on port 35443</a:t>
+              <a:t>•  5. Firstboot starts httpd container on 35443</a:t>
             </a:r>
           </a:p>
           <a:p>
             <a:pPr>
               <a:spcAft>
-                <a:spcPts val="1000"/>
+                <a:spcPts val="900"/>
               </a:spcAft>
             </a:pPr>
             <a:r>
-              <a:rPr sz="2000" b="0">
+              <a:rPr sz="1800" b="0">
                 <a:solidFill>
                   <a:srgbClr val="1A1A1A"/>
                 </a:solidFill>
                 <a:latin typeface="Calibri"/>
               </a:rPr>
-              <a:t>•  Firewall limited to SSH + httpd · Proven after reboot</a:t>
+              <a:t>•  6. Verify live: SELinux, mounts, ports, curl, reboot</a:t>
+            </a:r>
+          </a:p>
+        </p:txBody>
+      </p:sp>
+      <p:sp>
+        <p:nvSpPr>
+          <p:cNvPr id="9" name="TextBox 8"/>
+          <p:cNvSpPr txBox="1"/>
+          <p:nvPr/>
+        </p:nvSpPr>
+        <p:spPr>
+          <a:xfrm>
+            <a:off x="548640" y="6263640"/>
+            <a:ext cx="10972800" cy="365760"/>
+          </a:xfrm>
+          <a:prstGeom prst="rect">
+            <a:avLst/>
+          </a:prstGeom>
+          <a:noFill/>
+        </p:spPr>
+        <p:txBody>
+          <a:bodyPr wrap="none">
+            <a:spAutoFit/>
+          </a:bodyPr>
+          <a:lstStyle/>
+          <a:p>
+            <a:r>
+              <a:rPr sz="1300" b="0">
+                <a:solidFill>
+                  <a:srgbClr val="666666"/>
+                </a:solidFill>
+                <a:latin typeface="Calibri"/>
+              </a:rPr>
+              <a:t>Demo now: open gold VM + verify commands (see presentation script)</a:t>
             </a:r>
           </a:p>
         </p:txBody>
@@ -6324,50 +6966,16 @@
       </p:sp>
       <p:sp>
         <p:nvSpPr>
-          <p:cNvPr id="4" name="TextBox 3"/>
-          <p:cNvSpPr txBox="1"/>
-          <p:nvPr/>
-        </p:nvSpPr>
-        <p:spPr>
-          <a:xfrm>
-            <a:off x="548640" y="320040"/>
-            <a:ext cx="10972800" cy="640080"/>
-          </a:xfrm>
-          <a:prstGeom prst="rect">
-            <a:avLst/>
-          </a:prstGeom>
-          <a:noFill/>
-        </p:spPr>
-        <p:txBody>
-          <a:bodyPr wrap="none">
-            <a:spAutoFit/>
-          </a:bodyPr>
-          <a:lstStyle/>
-          <a:p>
-            <a:r>
-              <a:rPr sz="2800" b="1">
-                <a:solidFill>
-                  <a:srgbClr val="1A1A1A"/>
-                </a:solidFill>
-                <a:latin typeface="Calibri"/>
-              </a:rPr>
-              <a:t>Operate with Console or CLI</a:t>
-            </a:r>
-          </a:p>
-        </p:txBody>
-      </p:sp>
-      <p:sp>
-        <p:nvSpPr>
-          <p:cNvPr id="5" name="Rectangle 4"/>
+          <p:cNvPr id="4" name="Rounded Rectangle 3"/>
           <p:cNvSpPr/>
           <p:nvPr/>
         </p:nvSpPr>
         <p:spPr>
           <a:xfrm>
-            <a:off x="548640" y="960120"/>
-            <a:ext cx="2011680" cy="54864"/>
-          </a:xfrm>
-          <a:prstGeom prst="rect">
+            <a:off x="548640" y="228600"/>
+            <a:ext cx="2194560" cy="320040"/>
+          </a:xfrm>
+          <a:prstGeom prst="roundRect">
             <a:avLst/>
           </a:prstGeom>
           <a:solidFill>
@@ -6401,14 +7009,83 @@
       </p:sp>
       <p:sp>
         <p:nvSpPr>
-          <p:cNvPr id="6" name="Rounded Rectangle 5"/>
+          <p:cNvPr id="5" name="TextBox 4"/>
+          <p:cNvSpPr txBox="1"/>
+          <p:nvPr/>
+        </p:nvSpPr>
+        <p:spPr>
+          <a:xfrm>
+            <a:off x="548640" y="256032"/>
+            <a:ext cx="2194560" cy="292608"/>
+          </a:xfrm>
+          <a:prstGeom prst="rect">
+            <a:avLst/>
+          </a:prstGeom>
+          <a:noFill/>
+        </p:spPr>
+        <p:txBody>
+          <a:bodyPr wrap="none">
+            <a:spAutoFit/>
+          </a:bodyPr>
+          <a:lstStyle/>
+          <a:p>
+            <a:pPr algn="l"/>
+            <a:r>
+              <a:rPr sz="1100" b="1">
+                <a:solidFill>
+                  <a:srgbClr val="FFFFFF"/>
+                </a:solidFill>
+                <a:latin typeface="Calibri"/>
+              </a:rPr>
+              <a:t>WALKTHROUGH</a:t>
+            </a:r>
+          </a:p>
+        </p:txBody>
+      </p:sp>
+      <p:sp>
+        <p:nvSpPr>
+          <p:cNvPr id="6" name="TextBox 5"/>
+          <p:cNvSpPr txBox="1"/>
+          <p:nvPr/>
+        </p:nvSpPr>
+        <p:spPr>
+          <a:xfrm>
+            <a:off x="548640" y="640080"/>
+            <a:ext cx="10972800" cy="502920"/>
+          </a:xfrm>
+          <a:prstGeom prst="rect">
+            <a:avLst/>
+          </a:prstGeom>
+          <a:noFill/>
+        </p:spPr>
+        <p:txBody>
+          <a:bodyPr wrap="none">
+            <a:spAutoFit/>
+          </a:bodyPr>
+          <a:lstStyle/>
+          <a:p>
+            <a:r>
+              <a:rPr sz="2400" b="1">
+                <a:solidFill>
+                  <a:srgbClr val="1A1A1A"/>
+                </a:solidFill>
+                <a:latin typeface="Calibri"/>
+              </a:rPr>
+              <a:t>What we prove on the live VM</a:t>
+            </a:r>
+          </a:p>
+        </p:txBody>
+      </p:sp>
+      <p:sp>
+        <p:nvSpPr>
+          <p:cNvPr id="7" name="Rounded Rectangle 6"/>
           <p:cNvSpPr/>
           <p:nvPr/>
         </p:nvSpPr>
         <p:spPr>
           <a:xfrm>
-            <a:off x="548640" y="1280160"/>
-            <a:ext cx="5120640" cy="4754880"/>
+            <a:off x="548640" y="1371600"/>
+            <a:ext cx="5120640" cy="4663440"/>
           </a:xfrm>
           <a:prstGeom prst="roundRect">
             <a:avLst/>
@@ -6446,14 +7123,14 @@
       </p:sp>
       <p:sp>
         <p:nvSpPr>
-          <p:cNvPr id="7" name="TextBox 6"/>
+          <p:cNvPr id="8" name="TextBox 7"/>
           <p:cNvSpPr txBox="1"/>
           <p:nvPr/>
         </p:nvSpPr>
         <p:spPr>
           <a:xfrm>
-            <a:off x="822959" y="1463040"/>
-            <a:ext cx="4572000" cy="457200"/>
+            <a:off x="822959" y="1554480"/>
+            <a:ext cx="4572000" cy="411480"/>
           </a:xfrm>
           <a:prstGeom prst="rect">
             <a:avLst/>
@@ -6467,26 +7144,26 @@
           <a:lstStyle/>
           <a:p>
             <a:r>
-              <a:rPr sz="1800" b="1">
+              <a:rPr sz="1600" b="1">
                 <a:solidFill>
                   <a:srgbClr val="EE0000"/>
                 </a:solidFill>
                 <a:latin typeface="Calibri"/>
               </a:rPr>
-              <a:t>AWS</a:t>
-            </a:r>
-          </a:p>
-        </p:txBody>
-      </p:sp>
-      <p:sp>
-        <p:nvSpPr>
-          <p:cNvPr id="8" name="TextBox 7"/>
+              <a:t>Expansion Pack controls</a:t>
+            </a:r>
+          </a:p>
+        </p:txBody>
+      </p:sp>
+      <p:sp>
+        <p:nvSpPr>
+          <p:cNvPr id="9" name="TextBox 8"/>
           <p:cNvSpPr txBox="1"/>
           <p:nvPr/>
         </p:nvSpPr>
         <p:spPr>
           <a:xfrm>
-            <a:off x="822959" y="2011680"/>
+            <a:off x="822959" y="2103120"/>
             <a:ext cx="4572000" cy="3657600"/>
           </a:xfrm>
           <a:prstGeom prst="rect">
@@ -6502,111 +7179,111 @@
           <a:p>
             <a:pPr>
               <a:spcAft>
-                <a:spcPts val="800"/>
+                <a:spcPts val="700"/>
               </a:spcAft>
             </a:pPr>
             <a:r>
-              <a:rPr sz="1600" b="0">
+              <a:rPr sz="1500" b="0">
                 <a:solidFill>
                   <a:srgbClr val="1A1A1A"/>
                 </a:solidFill>
                 <a:latin typeface="Calibri"/>
               </a:rPr>
-              <a:t>•  Region: us-east-2 (Ohio)</a:t>
+              <a:t>•  SELinux Enforcing</a:t>
             </a:r>
           </a:p>
           <a:p>
             <a:pPr>
               <a:spcAft>
-                <a:spcPts val="800"/>
+                <a:spcPts val="700"/>
               </a:spcAft>
             </a:pPr>
             <a:r>
-              <a:rPr sz="1600" b="0">
+              <a:rPr sz="1500" b="0">
                 <a:solidFill>
                   <a:srgbClr val="1A1A1A"/>
                 </a:solidFill>
                 <a:latin typeface="Calibri"/>
               </a:rPr>
-              <a:t>•  Launch from AMI fl-rhel-gold</a:t>
+              <a:t>•  Separate /var/log /home /tmp /var/tmp</a:t>
             </a:r>
           </a:p>
           <a:p>
             <a:pPr>
               <a:spcAft>
-                <a:spcPts val="800"/>
+                <a:spcPts val="700"/>
               </a:spcAft>
             </a:pPr>
             <a:r>
-              <a:rPr sz="1600" b="0">
+              <a:rPr sz="1500" b="0">
                 <a:solidFill>
                   <a:srgbClr val="1A1A1A"/>
                 </a:solidFill>
                 <a:latin typeface="Calibri"/>
               </a:rPr>
-              <a:t>•  SG: TCP 2222 + 35443</a:t>
+              <a:t>•  /tmp noexec</a:t>
             </a:r>
           </a:p>
           <a:p>
             <a:pPr>
               <a:spcAft>
-                <a:spcPts val="800"/>
+                <a:spcPts val="700"/>
               </a:spcAft>
             </a:pPr>
             <a:r>
-              <a:rPr sz="1600" b="0">
+              <a:rPr sz="1500" b="0">
                 <a:solidFill>
                   <a:srgbClr val="1A1A1A"/>
                 </a:solidFill>
                 <a:latin typeface="Calibri"/>
               </a:rPr>
-              <a:t>•  User data re-runs firstboot</a:t>
+              <a:t>•  SSH 2222 key-only · no root SSH</a:t>
             </a:r>
           </a:p>
           <a:p>
             <a:pPr>
               <a:spcAft>
-                <a:spcPts val="800"/>
+                <a:spcPts val="700"/>
               </a:spcAft>
             </a:pPr>
             <a:r>
-              <a:rPr sz="1600" b="0">
+              <a:rPr sz="1500" b="0">
                 <a:solidFill>
                   <a:srgbClr val="1A1A1A"/>
                 </a:solidFill>
                 <a:latin typeface="Calibri"/>
               </a:rPr>
-              <a:t>•  SSH: fladmin1 @ port 2222</a:t>
+              <a:t>•  fladmins · fladmin1 / fladmin2</a:t>
             </a:r>
           </a:p>
           <a:p>
             <a:pPr>
               <a:spcAft>
-                <a:spcPts val="800"/>
+                <a:spcPts val="700"/>
               </a:spcAft>
             </a:pPr>
             <a:r>
-              <a:rPr sz="1600" b="0">
+              <a:rPr sz="1500" b="0">
                 <a:solidFill>
                   <a:srgbClr val="1A1A1A"/>
                 </a:solidFill>
                 <a:latin typeface="Calibri"/>
               </a:rPr>
-              <a:t>•  curl http://&lt;ip&gt;:35443/</a:t>
-            </a:r>
-          </a:p>
-        </p:txBody>
-      </p:sp>
-      <p:sp>
-        <p:nvSpPr>
-          <p:cNvPr id="9" name="Rounded Rectangle 8"/>
+              <a:t>•  Firewall: 2222 + 35443 only</a:t>
+            </a:r>
+          </a:p>
+        </p:txBody>
+      </p:sp>
+      <p:sp>
+        <p:nvSpPr>
+          <p:cNvPr id="10" name="Rounded Rectangle 9"/>
           <p:cNvSpPr/>
           <p:nvPr/>
         </p:nvSpPr>
         <p:spPr>
           <a:xfrm>
-            <a:off x="6400800" y="1280160"/>
-            <a:ext cx="5120640" cy="4754880"/>
+            <a:off x="6400800" y="1371600"/>
+            <a:ext cx="5120640" cy="4663440"/>
           </a:xfrm>
           <a:prstGeom prst="roundRect">
             <a:avLst/>
@@ -6644,14 +7321,14 @@
       </p:sp>
       <p:sp>
         <p:nvSpPr>
-          <p:cNvPr id="10" name="TextBox 9"/>
+          <p:cNvPr id="11" name="TextBox 10"/>
           <p:cNvSpPr txBox="1"/>
           <p:nvPr/>
         </p:nvSpPr>
         <p:spPr>
           <a:xfrm>
-            <a:off x="6675120" y="1463040"/>
-            <a:ext cx="4572000" cy="457200"/>
+            <a:off x="6675120" y="1554480"/>
+            <a:ext cx="4572000" cy="411480"/>
           </a:xfrm>
           <a:prstGeom prst="rect">
             <a:avLst/>
@@ -6665,26 +7342,26 @@
           <a:lstStyle/>
           <a:p>
             <a:r>
-              <a:rPr sz="1800" b="1">
+              <a:rPr sz="1600" b="1">
                 <a:solidFill>
                   <a:srgbClr val="EE0000"/>
                 </a:solidFill>
                 <a:latin typeface="Calibri"/>
               </a:rPr>
-              <a:t>Azure</a:t>
-            </a:r>
-          </a:p>
-        </p:txBody>
-      </p:sp>
-      <p:sp>
-        <p:nvSpPr>
-          <p:cNvPr id="11" name="TextBox 10"/>
+              <a:t>Service in action</a:t>
+            </a:r>
+          </a:p>
+        </p:txBody>
+      </p:sp>
+      <p:sp>
+        <p:nvSpPr>
+          <p:cNvPr id="12" name="TextBox 11"/>
           <p:cNvSpPr txBox="1"/>
           <p:nvPr/>
         </p:nvSpPr>
         <p:spPr>
           <a:xfrm>
-            <a:off x="6675120" y="2011680"/>
+            <a:off x="6675120" y="2103120"/>
             <a:ext cx="4572000" cy="3657600"/>
           </a:xfrm>
           <a:prstGeom prst="rect">
@@ -6700,81 +7377,81 @@
           <a:p>
             <a:pPr>
               <a:spcAft>
-                <a:spcPts val="800"/>
+                <a:spcPts val="700"/>
               </a:spcAft>
             </a:pPr>
             <a:r>
-              <a:rPr sz="1600" b="0">
+              <a:rPr sz="1500" b="0">
                 <a:solidFill>
                   <a:srgbClr val="1A1A1A"/>
                 </a:solidFill>
                 <a:latin typeface="Calibri"/>
               </a:rPr>
-              <a:t>•  Create VM from image fl-rhel-gold</a:t>
+              <a:t>•  httpd container listening on 35443</a:t>
             </a:r>
           </a:p>
           <a:p>
             <a:pPr>
               <a:spcAft>
-                <a:spcPts val="800"/>
+                <a:spcPts val="700"/>
               </a:spcAft>
             </a:pPr>
             <a:r>
-              <a:rPr sz="1600" b="0">
+              <a:rPr sz="1500" b="0">
                 <a:solidFill>
                   <a:srgbClr val="1A1A1A"/>
                 </a:solidFill>
                 <a:latin typeface="Calibri"/>
               </a:rPr>
-              <a:t>•  NSG: TCP 2222 + 35443</a:t>
+              <a:t>•  Fedora Lane index page via curl</a:t>
             </a:r>
           </a:p>
           <a:p>
             <a:pPr>
               <a:spcAft>
-                <a:spcPts val="800"/>
+                <a:spcPts val="700"/>
               </a:spcAft>
             </a:pPr>
             <a:r>
-              <a:rPr sz="1600" b="0">
+              <a:rPr sz="1500" b="0">
                 <a:solidFill>
                   <a:srgbClr val="1A1A1A"/>
                 </a:solidFill>
                 <a:latin typeface="Calibri"/>
               </a:rPr>
-              <a:t>•  SSH fladmin1 on port 2222</a:t>
+              <a:t>•  Same checklist after reboot</a:t>
             </a:r>
           </a:p>
           <a:p>
             <a:pPr>
               <a:spcAft>
-                <a:spcPts val="800"/>
+                <a:spcPts val="700"/>
               </a:spcAft>
             </a:pPr>
             <a:r>
-              <a:rPr sz="1600" b="0">
+              <a:rPr sz="1500" b="0">
                 <a:solidFill>
                   <a:srgbClr val="1A1A1A"/>
                 </a:solidFill>
                 <a:latin typeface="Calibri"/>
               </a:rPr>
-              <a:t>•  Same verify checklist</a:t>
+              <a:t>•  Proven on AWS and Azure</a:t>
             </a:r>
           </a:p>
           <a:p>
             <a:pPr>
               <a:spcAft>
-                <a:spcPts val="800"/>
+                <a:spcPts val="700"/>
               </a:spcAft>
             </a:pPr>
             <a:r>
-              <a:rPr sz="1600" b="0">
+              <a:rPr sz="1500" b="0">
                 <a:solidFill>
                   <a:srgbClr val="1A1A1A"/>
                 </a:solidFill>
                 <a:latin typeface="Calibri"/>
               </a:rPr>
-              <a:t>•  Docs in Git for step-by-step</a:t>
+              <a:t>•  Repeatable from README + runbooks</a:t>
             </a:r>
           </a:p>
         </p:txBody>
@@ -6885,50 +7562,16 @@
       </p:sp>
       <p:sp>
         <p:nvSpPr>
-          <p:cNvPr id="4" name="TextBox 3"/>
-          <p:cNvSpPr txBox="1"/>
-          <p:nvPr/>
-        </p:nvSpPr>
-        <p:spPr>
-          <a:xfrm>
-            <a:off x="548640" y="320040"/>
-            <a:ext cx="10972800" cy="640080"/>
-          </a:xfrm>
-          <a:prstGeom prst="rect">
-            <a:avLst/>
-          </a:prstGeom>
-          <a:noFill/>
-        </p:spPr>
-        <p:txBody>
-          <a:bodyPr wrap="none">
-            <a:spAutoFit/>
-          </a:bodyPr>
-          <a:lstStyle/>
-          <a:p>
-            <a:r>
-              <a:rPr sz="2800" b="1">
-                <a:solidFill>
-                  <a:srgbClr val="1A1A1A"/>
-                </a:solidFill>
-                <a:latin typeface="Calibri"/>
-              </a:rPr>
-              <a:t>Live evidence — what we demo</a:t>
-            </a:r>
-          </a:p>
-        </p:txBody>
-      </p:sp>
-      <p:sp>
-        <p:nvSpPr>
-          <p:cNvPr id="5" name="Rectangle 4"/>
+          <p:cNvPr id="4" name="Rounded Rectangle 3"/>
           <p:cNvSpPr/>
           <p:nvPr/>
         </p:nvSpPr>
         <p:spPr>
           <a:xfrm>
-            <a:off x="548640" y="960120"/>
-            <a:ext cx="2011680" cy="54864"/>
-          </a:xfrm>
-          <a:prstGeom prst="rect">
+            <a:off x="548640" y="228600"/>
+            <a:ext cx="2194560" cy="320040"/>
+          </a:xfrm>
+          <a:prstGeom prst="roundRect">
             <a:avLst/>
           </a:prstGeom>
           <a:solidFill>
@@ -6962,14 +7605,126 @@
       </p:sp>
       <p:sp>
         <p:nvSpPr>
+          <p:cNvPr id="5" name="TextBox 4"/>
+          <p:cNvSpPr txBox="1"/>
+          <p:nvPr/>
+        </p:nvSpPr>
+        <p:spPr>
+          <a:xfrm>
+            <a:off x="548640" y="256032"/>
+            <a:ext cx="2194560" cy="292608"/>
+          </a:xfrm>
+          <a:prstGeom prst="rect">
+            <a:avLst/>
+          </a:prstGeom>
+          <a:noFill/>
+        </p:spPr>
+        <p:txBody>
+          <a:bodyPr wrap="none">
+            <a:spAutoFit/>
+          </a:bodyPr>
+          <a:lstStyle/>
+          <a:p>
+            <a:pPr algn="l"/>
+            <a:r>
+              <a:rPr sz="1100" b="1">
+                <a:solidFill>
+                  <a:srgbClr val="FFFFFF"/>
+                </a:solidFill>
+                <a:latin typeface="Calibri"/>
+              </a:rPr>
+              <a:t>VALUE · 2–5 min</a:t>
+            </a:r>
+          </a:p>
+        </p:txBody>
+      </p:sp>
+      <p:sp>
+        <p:nvSpPr>
           <p:cNvPr id="6" name="TextBox 5"/>
           <p:cNvSpPr txBox="1"/>
           <p:nvPr/>
         </p:nvSpPr>
         <p:spPr>
           <a:xfrm>
-            <a:off x="548640" y="1280160"/>
-            <a:ext cx="10972800" cy="5029200"/>
+            <a:off x="548640" y="640080"/>
+            <a:ext cx="10972800" cy="548640"/>
+          </a:xfrm>
+          <a:prstGeom prst="rect">
+            <a:avLst/>
+          </a:prstGeom>
+          <a:noFill/>
+        </p:spPr>
+        <p:txBody>
+          <a:bodyPr wrap="none">
+            <a:spAutoFit/>
+          </a:bodyPr>
+          <a:lstStyle/>
+          <a:p>
+            <a:r>
+              <a:rPr sz="2600" b="1">
+                <a:solidFill>
+                  <a:srgbClr val="1A1A1A"/>
+                </a:solidFill>
+                <a:latin typeface="Calibri"/>
+              </a:rPr>
+              <a:t>How this addresses Fedora Lane’s challenges</a:t>
+            </a:r>
+          </a:p>
+        </p:txBody>
+      </p:sp>
+      <p:sp>
+        <p:nvSpPr>
+          <p:cNvPr id="7" name="Rectangle 6"/>
+          <p:cNvSpPr/>
+          <p:nvPr/>
+        </p:nvSpPr>
+        <p:spPr>
+          <a:xfrm>
+            <a:off x="548640" y="1234440"/>
+            <a:ext cx="1828800" cy="45720"/>
+          </a:xfrm>
+          <a:prstGeom prst="rect">
+            <a:avLst/>
+          </a:prstGeom>
+          <a:solidFill>
+            <a:srgbClr val="EE0000"/>
+          </a:solidFill>
+          <a:ln>
+            <a:noFill/>
+          </a:ln>
+        </p:spPr>
+        <p:style>
+          <a:lnRef idx="1">
+            <a:schemeClr val="accent1"/>
+          </a:lnRef>
+          <a:fillRef idx="3">
+            <a:schemeClr val="accent1"/>
+          </a:fillRef>
+          <a:effectRef idx="2">
+            <a:schemeClr val="accent1"/>
+          </a:effectRef>
+          <a:fontRef idx="minor">
+            <a:schemeClr val="lt1"/>
+          </a:fontRef>
+        </p:style>
+        <p:txBody>
+          <a:bodyPr rtlCol="0" anchor="ctr"/>
+          <a:lstStyle/>
+          <a:p>
+            <a:pPr algn="ctr"/>
+          </a:p>
+        </p:txBody>
+      </p:sp>
+      <p:sp>
+        <p:nvSpPr>
+          <p:cNvPr id="8" name="TextBox 7"/>
+          <p:cNvSpPr txBox="1"/>
+          <p:nvPr/>
+        </p:nvSpPr>
+        <p:spPr>
+          <a:xfrm>
+            <a:off x="548640" y="1463040"/>
+            <a:ext cx="10972800" cy="4572000"/>
           </a:xfrm>
           <a:prstGeom prst="rect">
             <a:avLst/>
@@ -6984,97 +7739,65 @@
           <a:p>
             <a:pPr>
               <a:spcAft>
-                <a:spcPts val="1000"/>
+                <a:spcPts val="900"/>
               </a:spcAft>
             </a:pPr>
             <a:r>
-              <a:rPr sz="2000" b="0">
+              <a:rPr sz="1800" b="0">
                 <a:solidFill>
                   <a:srgbClr val="1A1A1A"/>
                 </a:solidFill>
                 <a:latin typeface="Calibri"/>
               </a:rPr>
-              <a:t>•  SELinux Enforcing · separate mounts · /tmp noexec</a:t>
+              <a:t>•  Inconsistency → one Git blueprint → identical gold baselines on AWS and Azure</a:t>
             </a:r>
           </a:p>
           <a:p>
             <a:pPr>
               <a:spcAft>
-                <a:spcPts val="1000"/>
+                <a:spcPts val="900"/>
               </a:spcAft>
             </a:pPr>
             <a:r>
-              <a:rPr sz="2000" b="0">
+              <a:rPr sz="1800" b="0">
                 <a:solidFill>
                   <a:srgbClr val="1A1A1A"/>
                 </a:solidFill>
                 <a:latin typeface="Calibri"/>
               </a:rPr>
-              <a:t>•  Listeners on 2222 and 35443</a:t>
+              <a:t>•  Risky change → hardened SSH/sudo baked in; rebuild anytime from source of truth</a:t>
             </a:r>
           </a:p>
           <a:p>
             <a:pPr>
               <a:spcAft>
-                <a:spcPts val="1000"/>
+                <a:spcPts val="900"/>
               </a:spcAft>
             </a:pPr>
             <a:r>
-              <a:rPr sz="2000" b="0">
+              <a:rPr sz="1800" b="0">
                 <a:solidFill>
                   <a:srgbClr val="1A1A1A"/>
                 </a:solidFill>
                 <a:latin typeface="Calibri"/>
               </a:rPr>
-              <a:t>•  Fedora Lane index page from the httpd container</a:t>
+              <a:t>•  Container skills gap → httpd runs as a container on every gold web VM</a:t>
             </a:r>
           </a:p>
           <a:p>
             <a:pPr>
               <a:spcAft>
-                <a:spcPts val="1000"/>
+                <a:spcPts val="900"/>
               </a:spcAft>
             </a:pPr>
             <a:r>
-              <a:rPr sz="2000" b="0">
+              <a:rPr sz="1800" b="0">
                 <a:solidFill>
                   <a:srgbClr val="1A1A1A"/>
                 </a:solidFill>
                 <a:latin typeface="Calibri"/>
               </a:rPr>
-              <a:t>•  fladmins / fladmin1 present</a:t>
-            </a:r>
-          </a:p>
-          <a:p>
-            <a:pPr>
-              <a:spcAft>
-                <a:spcPts val="1000"/>
-              </a:spcAft>
-            </a:pPr>
-            <a:r>
-              <a:rPr sz="2000" b="0">
-                <a:solidFill>
-                  <a:srgbClr val="1A1A1A"/>
-                </a:solidFill>
-                <a:latin typeface="Calibri"/>
-              </a:rPr>
-              <a:t>•  Root SSH rejected · password SSH rejected</a:t>
-            </a:r>
-          </a:p>
-          <a:p>
-            <a:pPr>
-              <a:spcAft>
-                <a:spcPts val="1000"/>
-              </a:spcAft>
-            </a:pPr>
-            <a:r>
-              <a:rPr sz="2000" b="0">
-                <a:solidFill>
-                  <a:srgbClr val="1A1A1A"/>
-                </a:solidFill>
-                <a:latin typeface="Calibri"/>
-              </a:rPr>
-              <a:t>•  Survives reboot — same checklist on AWS and Azure</a:t>
+              <a:t>•  Dual-cloud reality → proven AMI path and VHD path with the same recipe</a:t>
             </a:r>
           </a:p>
         </p:txBody>

</xml_diff>

<commit_message>
Add solution-architecture and build-steps slides to the customer deck.
Shows TOML → Image Builder → .raw → AMI → web nodes plus the Expansion Pack baseline on every gold VM.

Co-authored-by: Cursor <cursoragent@cursor.com>
</commit_message>
<xml_diff>
--- a/docs/Fedora-Lane-Expansion-Pack-Technical-Solution.pptx
+++ b/docs/Fedora-Lane-Expansion-Pack-Technical-Solution.pptx
@@ -18,6 +18,7 @@
     <p:sldId id="266" r:id="rId17"/>
     <p:sldId id="267" r:id="rId18"/>
     <p:sldId id="268" r:id="rId19"/>
+    <p:sldId id="269" r:id="rId20"/>
   </p:sldIdLst>
   <p:sldSz cx="12191695" cy="6858000" type="screen4x3"/>
   <p:notesSz cx="6858000" cy="9144000"/>
@@ -3435,7 +3436,7 @@
         <p:spPr>
           <a:xfrm>
             <a:off x="548640" y="228600"/>
-            <a:ext cx="2194560" cy="320040"/>
+            <a:ext cx="2377440" cy="320040"/>
           </a:xfrm>
           <a:prstGeom prst="roundRect">
             <a:avLst/>
@@ -3478,7 +3479,7 @@
         <p:spPr>
           <a:xfrm>
             <a:off x="548640" y="256032"/>
-            <a:ext cx="2194560" cy="292608"/>
+            <a:ext cx="2377440" cy="292608"/>
           </a:xfrm>
           <a:prstGeom prst="rect">
             <a:avLst/>
@@ -3491,7 +3492,7 @@
           </a:bodyPr>
           <a:lstStyle/>
           <a:p>
-            <a:pPr algn="l"/>
+            <a:pPr algn="ctr"/>
             <a:r>
               <a:rPr sz="1100" b="1">
                 <a:solidFill>
@@ -3499,7 +3500,7 @@
                 </a:solidFill>
                 <a:latin typeface="Calibri"/>
               </a:rPr>
-              <a:t>VALUE</a:t>
+              <a:t>VALUE · 2–5 min</a:t>
             </a:r>
           </a:p>
         </p:txBody>
@@ -3533,7 +3534,7 @@
                 </a:solidFill>
                 <a:latin typeface="Calibri"/>
               </a:rPr>
-              <a:t>What this leaves open for the future</a:t>
+              <a:t>How this addresses Fedora Lane’s challenges</a:t>
             </a:r>
           </a:p>
         </p:txBody>
@@ -3615,7 +3616,7 @@
                 </a:solidFill>
                 <a:latin typeface="Calibri"/>
               </a:rPr>
-              <a:t>•  Scale: Launch Templates / ASG (AWS) and Scale Sets / Shared Image Gallery (Azure)</a:t>
+              <a:t>•  Inconsistency → one Git blueprint → identical gold baselines on AWS and Azure</a:t>
             </a:r>
           </a:p>
           <a:p>
@@ -3631,7 +3632,7 @@
                 </a:solidFill>
                 <a:latin typeface="Calibri"/>
               </a:rPr>
-              <a:t>•  Day-2: change blueprint → recompose new gold version → roll replace waves</a:t>
+              <a:t>•  Risky change → hardened SSH/sudo baked in; rebuild anytime from source of truth</a:t>
             </a:r>
           </a:p>
           <a:p>
@@ -3647,7 +3648,7 @@
                 </a:solidFill>
                 <a:latin typeface="Calibri"/>
               </a:rPr>
-              <a:t>•  Security: add OpenSCAP / CIS profile to the same Image Builder factory</a:t>
+              <a:t>•  Container skills gap → httpd runs as a container on every gold web VM</a:t>
             </a:r>
           </a:p>
           <a:p>
@@ -3663,23 +3664,7 @@
                 </a:solidFill>
                 <a:latin typeface="Calibri"/>
               </a:rPr>
-              <a:t>•  Alternates already in repo: Kickstart and Image Mode if you prefer those factories</a:t>
-            </a:r>
-          </a:p>
-          <a:p>
-            <a:pPr>
-              <a:spcAft>
-                <a:spcPts val="900"/>
-              </a:spcAft>
-            </a:pPr>
-            <a:r>
-              <a:rPr sz="1800" b="0">
-                <a:solidFill>
-                  <a:srgbClr val="1A1A1A"/>
-                </a:solidFill>
-                <a:latin typeface="Calibri"/>
-              </a:rPr>
-              <a:t>•  Integration: feed gold images into existing CI/CD, IaC, and change-control processes</a:t>
+              <a:t>•  Dual-cloud reality → proven AMI path and VHD path with the same recipe</a:t>
             </a:r>
           </a:p>
         </p:txBody>
@@ -3797,7 +3782,7 @@
         <p:spPr>
           <a:xfrm>
             <a:off x="548640" y="228600"/>
-            <a:ext cx="2194560" cy="320040"/>
+            <a:ext cx="2377440" cy="320040"/>
           </a:xfrm>
           <a:prstGeom prst="roundRect">
             <a:avLst/>
@@ -3840,7 +3825,7 @@
         <p:spPr>
           <a:xfrm>
             <a:off x="548640" y="256032"/>
-            <a:ext cx="2194560" cy="292608"/>
+            <a:ext cx="2377440" cy="292608"/>
           </a:xfrm>
           <a:prstGeom prst="rect">
             <a:avLst/>
@@ -3853,7 +3838,7 @@
           </a:bodyPr>
           <a:lstStyle/>
           <a:p>
-            <a:pPr algn="l"/>
+            <a:pPr algn="ctr"/>
             <a:r>
               <a:rPr sz="1100" b="1">
                 <a:solidFill>
@@ -3861,7 +3846,7 @@
                 </a:solidFill>
                 <a:latin typeface="Calibri"/>
               </a:rPr>
-              <a:t>CLOSING · 1–2 min</a:t>
+              <a:t>VALUE</a:t>
             </a:r>
           </a:p>
         </p:txBody>
@@ -3895,7 +3880,7 @@
                 </a:solidFill>
                 <a:latin typeface="Calibri"/>
               </a:rPr>
-              <a:t>Core message</a:t>
+              <a:t>What this leaves open for the future</a:t>
             </a:r>
           </a:p>
         </p:txBody>
@@ -3977,7 +3962,7 @@
                 </a:solidFill>
                 <a:latin typeface="Calibri"/>
               </a:rPr>
-              <a:t>•  Fedora Lane can standardize the e-commerce web OS with a repeatable RHEL gold image</a:t>
+              <a:t>•  Scale: Launch Templates / ASG (AWS) and Scale Sets / Shared Image Gallery (Azure)</a:t>
             </a:r>
           </a:p>
           <a:p>
@@ -3993,7 +3978,7 @@
                 </a:solidFill>
                 <a:latin typeface="Calibri"/>
               </a:rPr>
-              <a:t>•  Built with Red Hat Image Builder, versioned in Git, proven on AWS and Azure</a:t>
+              <a:t>•  Day-2: change blueprint → recompose new gold version → roll replace waves</a:t>
             </a:r>
           </a:p>
           <a:p>
@@ -4009,7 +3994,39 @@
                 </a:solidFill>
                 <a:latin typeface="Calibri"/>
               </a:rPr>
-              <a:t>•  Technical value today: Expansion Pack controls + containerized httpd + dual-cloud deploy</a:t>
+              <a:t>•  Security: add OpenSCAP / CIS profile to the same Image Builder factory</a:t>
+            </a:r>
+          </a:p>
+          <a:p>
+            <a:pPr>
+              <a:spcAft>
+                <a:spcPts val="900"/>
+              </a:spcAft>
+            </a:pPr>
+            <a:r>
+              <a:rPr sz="1800" b="0">
+                <a:solidFill>
+                  <a:srgbClr val="1A1A1A"/>
+                </a:solidFill>
+                <a:latin typeface="Calibri"/>
+              </a:rPr>
+              <a:t>•  App hosting: deploy onto httpd volume without rebuilding the AMI</a:t>
+            </a:r>
+          </a:p>
+          <a:p>
+            <a:pPr>
+              <a:spcAft>
+                <a:spcPts val="900"/>
+              </a:spcAft>
+            </a:pPr>
+            <a:r>
+              <a:rPr sz="1800" b="0">
+                <a:solidFill>
+                  <a:srgbClr val="1A1A1A"/>
+                </a:solidFill>
+                <a:latin typeface="Calibri"/>
+              </a:rPr>
+              <a:t>•  Integration: feed gold images into existing CI/CD and change-control</a:t>
             </a:r>
           </a:p>
         </p:txBody>
@@ -4127,7 +4144,7 @@
         <p:spPr>
           <a:xfrm>
             <a:off x="548640" y="228600"/>
-            <a:ext cx="2194560" cy="320040"/>
+            <a:ext cx="2377440" cy="320040"/>
           </a:xfrm>
           <a:prstGeom prst="roundRect">
             <a:avLst/>
@@ -4170,7 +4187,7 @@
         <p:spPr>
           <a:xfrm>
             <a:off x="548640" y="256032"/>
-            <a:ext cx="2194560" cy="292608"/>
+            <a:ext cx="2377440" cy="292608"/>
           </a:xfrm>
           <a:prstGeom prst="rect">
             <a:avLst/>
@@ -4183,7 +4200,7 @@
           </a:bodyPr>
           <a:lstStyle/>
           <a:p>
-            <a:pPr algn="l"/>
+            <a:pPr algn="ctr"/>
             <a:r>
               <a:rPr sz="1100" b="1">
                 <a:solidFill>
@@ -4191,7 +4208,7 @@
                 </a:solidFill>
                 <a:latin typeface="Calibri"/>
               </a:rPr>
-              <a:t>CLOSING</a:t>
+              <a:t>CLOSING · 1–2 min</a:t>
             </a:r>
           </a:p>
         </p:txBody>
@@ -4225,7 +4242,7 @@
                 </a:solidFill>
                 <a:latin typeface="Calibri"/>
               </a:rPr>
-              <a:t>One concrete next step</a:t>
+              <a:t>Core message</a:t>
             </a:r>
           </a:p>
         </p:txBody>
@@ -4307,7 +4324,7 @@
                 </a:solidFill>
                 <a:latin typeface="Calibri"/>
               </a:rPr>
-              <a:t>•  Approve a non-prod pilot: launch web nodes from the gold AMI / Azure image</a:t>
+              <a:t>•  Fedora Lane can standardize the e-commerce web OS with a repeatable RHEL gold image</a:t>
             </a:r>
           </a:p>
           <a:p>
@@ -4323,7 +4340,7 @@
                 </a:solidFill>
                 <a:latin typeface="Calibri"/>
               </a:rPr>
-              <a:t>•  Use Launch Template / scale set for new capacity; keep Git as change control</a:t>
+              <a:t>•  Built with Red Hat Image Builder, versioned in Git, proven on AWS and Azure</a:t>
             </a:r>
           </a:p>
           <a:p>
@@ -4339,41 +4356,7 @@
                 </a:solidFill>
                 <a:latin typeface="Calibri"/>
               </a:rPr>
-              <a:t>•  After pilot: wave-replace selected prod pools</a:t>
-            </a:r>
-          </a:p>
-        </p:txBody>
-      </p:sp>
-      <p:sp>
-        <p:nvSpPr>
-          <p:cNvPr id="9" name="TextBox 8"/>
-          <p:cNvSpPr txBox="1"/>
-          <p:nvPr/>
-        </p:nvSpPr>
-        <p:spPr>
-          <a:xfrm>
-            <a:off x="548640" y="6263640"/>
-            <a:ext cx="10972800" cy="365760"/>
-          </a:xfrm>
-          <a:prstGeom prst="rect">
-            <a:avLst/>
-          </a:prstGeom>
-          <a:noFill/>
-        </p:spPr>
-        <p:txBody>
-          <a:bodyPr wrap="none">
-            <a:spAutoFit/>
-          </a:bodyPr>
-          <a:lstStyle/>
-          <a:p>
-            <a:r>
-              <a:rPr sz="1300" b="0">
-                <a:solidFill>
-                  <a:srgbClr val="666666"/>
-                </a:solidFill>
-                <a:latin typeface="Calibri"/>
-              </a:rPr>
-              <a:t>Ask: green-light non-prod pilot as the web OS standard</a:t>
+              <a:t>•  Technical value today: Expansion Pack controls + containerized httpd + dual-cloud deploy</a:t>
             </a:r>
           </a:p>
         </p:txBody>
@@ -4411,7 +4394,7 @@
             <a:avLst/>
           </a:prstGeom>
           <a:solidFill>
-            <a:srgbClr val="1A1A1A"/>
+            <a:srgbClr val="F5F5F5"/>
           </a:solidFill>
           <a:ln>
             <a:noFill/>
@@ -4448,7 +4431,7 @@
         <p:spPr>
           <a:xfrm>
             <a:off x="0" y="0"/>
-            <a:ext cx="12191695" cy="137160"/>
+            <a:ext cx="109728" cy="6858000"/>
           </a:xfrm>
           <a:prstGeom prst="rect">
             <a:avLst/>
@@ -4484,14 +4467,57 @@
       </p:sp>
       <p:sp>
         <p:nvSpPr>
-          <p:cNvPr id="4" name="TextBox 3"/>
+          <p:cNvPr id="4" name="Rounded Rectangle 3"/>
+          <p:cNvSpPr/>
+          <p:nvPr/>
+        </p:nvSpPr>
+        <p:spPr>
+          <a:xfrm>
+            <a:off x="548640" y="228600"/>
+            <a:ext cx="2377440" cy="320040"/>
+          </a:xfrm>
+          <a:prstGeom prst="roundRect">
+            <a:avLst/>
+          </a:prstGeom>
+          <a:solidFill>
+            <a:srgbClr val="EE0000"/>
+          </a:solidFill>
+          <a:ln>
+            <a:noFill/>
+          </a:ln>
+        </p:spPr>
+        <p:style>
+          <a:lnRef idx="1">
+            <a:schemeClr val="accent1"/>
+          </a:lnRef>
+          <a:fillRef idx="3">
+            <a:schemeClr val="accent1"/>
+          </a:fillRef>
+          <a:effectRef idx="2">
+            <a:schemeClr val="accent1"/>
+          </a:effectRef>
+          <a:fontRef idx="minor">
+            <a:schemeClr val="lt1"/>
+          </a:fontRef>
+        </p:style>
+        <p:txBody>
+          <a:bodyPr rtlCol="0" anchor="ctr"/>
+          <a:lstStyle/>
+          <a:p>
+            <a:pPr algn="ctr"/>
+          </a:p>
+        </p:txBody>
+      </p:sp>
+      <p:sp>
+        <p:nvSpPr>
+          <p:cNvPr id="5" name="TextBox 4"/>
           <p:cNvSpPr txBox="1"/>
           <p:nvPr/>
         </p:nvSpPr>
         <p:spPr>
           <a:xfrm>
-            <a:off x="731520" y="1920240"/>
-            <a:ext cx="10515600" cy="1097280"/>
+            <a:off x="548640" y="256032"/>
+            <a:ext cx="2377440" cy="292608"/>
           </a:xfrm>
           <a:prstGeom prst="rect">
             <a:avLst/>
@@ -4504,28 +4530,29 @@
           </a:bodyPr>
           <a:lstStyle/>
           <a:p>
-            <a:r>
-              <a:rPr sz="3600" b="1">
+            <a:pPr algn="ctr"/>
+            <a:r>
+              <a:rPr sz="1100" b="1">
                 <a:solidFill>
                   <a:srgbClr val="FFFFFF"/>
                 </a:solidFill>
                 <a:latin typeface="Calibri"/>
               </a:rPr>
-              <a:t>Thank you — questions welcome</a:t>
-            </a:r>
-          </a:p>
-        </p:txBody>
-      </p:sp>
-      <p:sp>
-        <p:nvSpPr>
-          <p:cNvPr id="5" name="TextBox 4"/>
+              <a:t>CLOSING</a:t>
+            </a:r>
+          </a:p>
+        </p:txBody>
+      </p:sp>
+      <p:sp>
+        <p:nvSpPr>
+          <p:cNvPr id="6" name="TextBox 5"/>
           <p:cNvSpPr txBox="1"/>
           <p:nvPr/>
         </p:nvSpPr>
         <p:spPr>
           <a:xfrm>
-            <a:off x="731520" y="3200400"/>
-            <a:ext cx="10515600" cy="411480"/>
+            <a:off x="548640" y="640080"/>
+            <a:ext cx="10972800" cy="548640"/>
           </a:xfrm>
           <a:prstGeom prst="rect">
             <a:avLst/>
@@ -4539,27 +4566,141 @@
           <a:lstStyle/>
           <a:p>
             <a:r>
+              <a:rPr sz="2600" b="1">
+                <a:solidFill>
+                  <a:srgbClr val="1A1A1A"/>
+                </a:solidFill>
+                <a:latin typeface="Calibri"/>
+              </a:rPr>
+              <a:t>One concrete next step</a:t>
+            </a:r>
+          </a:p>
+        </p:txBody>
+      </p:sp>
+      <p:sp>
+        <p:nvSpPr>
+          <p:cNvPr id="7" name="Rectangle 6"/>
+          <p:cNvSpPr/>
+          <p:nvPr/>
+        </p:nvSpPr>
+        <p:spPr>
+          <a:xfrm>
+            <a:off x="548640" y="1234440"/>
+            <a:ext cx="1828800" cy="45720"/>
+          </a:xfrm>
+          <a:prstGeom prst="rect">
+            <a:avLst/>
+          </a:prstGeom>
+          <a:solidFill>
+            <a:srgbClr val="EE0000"/>
+          </a:solidFill>
+          <a:ln>
+            <a:noFill/>
+          </a:ln>
+        </p:spPr>
+        <p:style>
+          <a:lnRef idx="1">
+            <a:schemeClr val="accent1"/>
+          </a:lnRef>
+          <a:fillRef idx="3">
+            <a:schemeClr val="accent1"/>
+          </a:fillRef>
+          <a:effectRef idx="2">
+            <a:schemeClr val="accent1"/>
+          </a:effectRef>
+          <a:fontRef idx="minor">
+            <a:schemeClr val="lt1"/>
+          </a:fontRef>
+        </p:style>
+        <p:txBody>
+          <a:bodyPr rtlCol="0" anchor="ctr"/>
+          <a:lstStyle/>
+          <a:p>
+            <a:pPr algn="ctr"/>
+          </a:p>
+        </p:txBody>
+      </p:sp>
+      <p:sp>
+        <p:nvSpPr>
+          <p:cNvPr id="8" name="TextBox 7"/>
+          <p:cNvSpPr txBox="1"/>
+          <p:nvPr/>
+        </p:nvSpPr>
+        <p:spPr>
+          <a:xfrm>
+            <a:off x="548640" y="1463040"/>
+            <a:ext cx="10972800" cy="4572000"/>
+          </a:xfrm>
+          <a:prstGeom prst="rect">
+            <a:avLst/>
+          </a:prstGeom>
+          <a:noFill/>
+        </p:spPr>
+        <p:txBody>
+          <a:bodyPr wrap="square">
+            <a:spAutoFit/>
+          </a:bodyPr>
+          <a:lstStyle/>
+          <a:p>
+            <a:pPr>
+              <a:spcAft>
+                <a:spcPts val="900"/>
+              </a:spcAft>
+            </a:pPr>
+            <a:r>
               <a:rPr sz="1800" b="0">
                 <a:solidFill>
-                  <a:srgbClr val="CCCCCC"/>
-                </a:solidFill>
-                <a:latin typeface="Calibri"/>
-              </a:rPr>
-              <a:t>Git source of truth: github.com/ydandge-oss/fedora-lane-core-pack-faster</a:t>
-            </a:r>
-          </a:p>
-        </p:txBody>
-      </p:sp>
-      <p:sp>
-        <p:nvSpPr>
-          <p:cNvPr id="6" name="TextBox 5"/>
+                  <a:srgbClr val="1A1A1A"/>
+                </a:solidFill>
+                <a:latin typeface="Calibri"/>
+              </a:rPr>
+              <a:t>•  Approve a non-prod pilot: launch web nodes from the gold AMI / Azure image</a:t>
+            </a:r>
+          </a:p>
+          <a:p>
+            <a:pPr>
+              <a:spcAft>
+                <a:spcPts val="900"/>
+              </a:spcAft>
+            </a:pPr>
+            <a:r>
+              <a:rPr sz="1800" b="0">
+                <a:solidFill>
+                  <a:srgbClr val="1A1A1A"/>
+                </a:solidFill>
+                <a:latin typeface="Calibri"/>
+              </a:rPr>
+              <a:t>•  Use Launch Template / scale set for new capacity; keep Git as change control</a:t>
+            </a:r>
+          </a:p>
+          <a:p>
+            <a:pPr>
+              <a:spcAft>
+                <a:spcPts val="900"/>
+              </a:spcAft>
+            </a:pPr>
+            <a:r>
+              <a:rPr sz="1800" b="0">
+                <a:solidFill>
+                  <a:srgbClr val="1A1A1A"/>
+                </a:solidFill>
+                <a:latin typeface="Calibri"/>
+              </a:rPr>
+              <a:t>•  After pilot: wave-replace selected prod pools</a:t>
+            </a:r>
+          </a:p>
+        </p:txBody>
+      </p:sp>
+      <p:sp>
+        <p:nvSpPr>
+          <p:cNvPr id="9" name="TextBox 8"/>
           <p:cNvSpPr txBox="1"/>
           <p:nvPr/>
         </p:nvSpPr>
         <p:spPr>
           <a:xfrm>
-            <a:off x="731520" y="3611880"/>
-            <a:ext cx="10515600" cy="411480"/>
+            <a:off x="548640" y="6263640"/>
+            <a:ext cx="10972800" cy="365760"/>
           </a:xfrm>
           <a:prstGeom prst="rect">
             <a:avLst/>
@@ -4573,27 +4714,131 @@
           <a:lstStyle/>
           <a:p>
             <a:r>
-              <a:rPr sz="1800" b="0">
-                <a:solidFill>
-                  <a:srgbClr val="CCCCCC"/>
-                </a:solidFill>
-                <a:latin typeface="Calibri"/>
-              </a:rPr>
-              <a:t>Branch: expansion-tdp-solution  ·  README + runbooks + verify checklist</a:t>
-            </a:r>
-          </a:p>
-        </p:txBody>
-      </p:sp>
-      <p:sp>
-        <p:nvSpPr>
-          <p:cNvPr id="7" name="TextBox 6"/>
+              <a:rPr sz="1300" b="0">
+                <a:solidFill>
+                  <a:srgbClr val="666666"/>
+                </a:solidFill>
+                <a:latin typeface="Calibri"/>
+              </a:rPr>
+              <a:t>Ask: green-light non-prod pilot as the web OS standard</a:t>
+            </a:r>
+          </a:p>
+        </p:txBody>
+      </p:sp>
+    </p:spTree>
+  </p:cSld>
+  <p:clrMapOvr>
+    <a:masterClrMapping/>
+  </p:clrMapOvr>
+</p:sld>
+</file>
+
+<file path=ppt/slides/slide14.xml><?xml version="1.0" encoding="utf-8"?>
+<p:sld xmlns:a="http://schemas.openxmlformats.org/drawingml/2006/main" xmlns:p="http://schemas.openxmlformats.org/presentationml/2006/main" xmlns:r="http://schemas.openxmlformats.org/officeDocument/2006/relationships">
+  <p:cSld>
+    <p:spTree>
+      <p:nvGrpSpPr>
+        <p:cNvPr id="1" name=""/>
+        <p:cNvGrpSpPr/>
+        <p:nvPr/>
+      </p:nvGrpSpPr>
+      <p:grpSpPr/>
+      <p:sp>
+        <p:nvSpPr>
+          <p:cNvPr id="2" name="Rectangle 1"/>
+          <p:cNvSpPr/>
+          <p:nvPr/>
+        </p:nvSpPr>
+        <p:spPr>
+          <a:xfrm>
+            <a:off x="0" y="0"/>
+            <a:ext cx="12191695" cy="6858000"/>
+          </a:xfrm>
+          <a:prstGeom prst="rect">
+            <a:avLst/>
+          </a:prstGeom>
+          <a:solidFill>
+            <a:srgbClr val="1A1A1A"/>
+          </a:solidFill>
+          <a:ln>
+            <a:noFill/>
+          </a:ln>
+        </p:spPr>
+        <p:style>
+          <a:lnRef idx="1">
+            <a:schemeClr val="accent1"/>
+          </a:lnRef>
+          <a:fillRef idx="3">
+            <a:schemeClr val="accent1"/>
+          </a:fillRef>
+          <a:effectRef idx="2">
+            <a:schemeClr val="accent1"/>
+          </a:effectRef>
+          <a:fontRef idx="minor">
+            <a:schemeClr val="lt1"/>
+          </a:fontRef>
+        </p:style>
+        <p:txBody>
+          <a:bodyPr rtlCol="0" anchor="ctr"/>
+          <a:lstStyle/>
+          <a:p>
+            <a:pPr algn="ctr"/>
+          </a:p>
+        </p:txBody>
+      </p:sp>
+      <p:sp>
+        <p:nvSpPr>
+          <p:cNvPr id="3" name="Rectangle 2"/>
+          <p:cNvSpPr/>
+          <p:nvPr/>
+        </p:nvSpPr>
+        <p:spPr>
+          <a:xfrm>
+            <a:off x="0" y="0"/>
+            <a:ext cx="12191695" cy="137160"/>
+          </a:xfrm>
+          <a:prstGeom prst="rect">
+            <a:avLst/>
+          </a:prstGeom>
+          <a:solidFill>
+            <a:srgbClr val="EE0000"/>
+          </a:solidFill>
+          <a:ln>
+            <a:noFill/>
+          </a:ln>
+        </p:spPr>
+        <p:style>
+          <a:lnRef idx="1">
+            <a:schemeClr val="accent1"/>
+          </a:lnRef>
+          <a:fillRef idx="3">
+            <a:schemeClr val="accent1"/>
+          </a:fillRef>
+          <a:effectRef idx="2">
+            <a:schemeClr val="accent1"/>
+          </a:effectRef>
+          <a:fontRef idx="minor">
+            <a:schemeClr val="lt1"/>
+          </a:fontRef>
+        </p:style>
+        <p:txBody>
+          <a:bodyPr rtlCol="0" anchor="ctr"/>
+          <a:lstStyle/>
+          <a:p>
+            <a:pPr algn="ctr"/>
+          </a:p>
+        </p:txBody>
+      </p:sp>
+      <p:sp>
+        <p:nvSpPr>
+          <p:cNvPr id="4" name="TextBox 3"/>
           <p:cNvSpPr txBox="1"/>
           <p:nvPr/>
         </p:nvSpPr>
         <p:spPr>
           <a:xfrm>
-            <a:off x="731520" y="4023360"/>
-            <a:ext cx="10515600" cy="411480"/>
+            <a:off x="731520" y="1920240"/>
+            <a:ext cx="10515600" cy="1097280"/>
           </a:xfrm>
           <a:prstGeom prst="rect">
             <a:avLst/>
@@ -4607,13 +4852,115 @@
           <a:lstStyle/>
           <a:p>
             <a:r>
+              <a:rPr sz="3600" b="1">
+                <a:solidFill>
+                  <a:srgbClr val="FFFFFF"/>
+                </a:solidFill>
+                <a:latin typeface="Calibri"/>
+              </a:rPr>
+              <a:t>Thank you — questions welcome</a:t>
+            </a:r>
+          </a:p>
+        </p:txBody>
+      </p:sp>
+      <p:sp>
+        <p:nvSpPr>
+          <p:cNvPr id="5" name="TextBox 4"/>
+          <p:cNvSpPr txBox="1"/>
+          <p:nvPr/>
+        </p:nvSpPr>
+        <p:spPr>
+          <a:xfrm>
+            <a:off x="731520" y="3200400"/>
+            <a:ext cx="10515600" cy="411480"/>
+          </a:xfrm>
+          <a:prstGeom prst="rect">
+            <a:avLst/>
+          </a:prstGeom>
+          <a:noFill/>
+        </p:spPr>
+        <p:txBody>
+          <a:bodyPr wrap="none">
+            <a:spAutoFit/>
+          </a:bodyPr>
+          <a:lstStyle/>
+          <a:p>
+            <a:r>
               <a:rPr sz="1800" b="0">
                 <a:solidFill>
                   <a:srgbClr val="CCCCCC"/>
                 </a:solidFill>
                 <a:latin typeface="Calibri"/>
               </a:rPr>
-              <a:t>Spoken script: docs/presentation-script-part1-video.md</a:t>
+              <a:t>Git: github.com/ydandge-oss/fedora-lane-core-pack-faster  ·  branch expansion-tdp-solution</a:t>
+            </a:r>
+          </a:p>
+        </p:txBody>
+      </p:sp>
+      <p:sp>
+        <p:nvSpPr>
+          <p:cNvPr id="6" name="TextBox 5"/>
+          <p:cNvSpPr txBox="1"/>
+          <p:nvPr/>
+        </p:nvSpPr>
+        <p:spPr>
+          <a:xfrm>
+            <a:off x="731520" y="3611880"/>
+            <a:ext cx="10515600" cy="411480"/>
+          </a:xfrm>
+          <a:prstGeom prst="rect">
+            <a:avLst/>
+          </a:prstGeom>
+          <a:noFill/>
+        </p:spPr>
+        <p:txBody>
+          <a:bodyPr wrap="none">
+            <a:spAutoFit/>
+          </a:bodyPr>
+          <a:lstStyle/>
+          <a:p>
+            <a:r>
+              <a:rPr sz="1800" b="0">
+                <a:solidFill>
+                  <a:srgbClr val="CCCCCC"/>
+                </a:solidFill>
+                <a:latin typeface="Calibri"/>
+              </a:rPr>
+              <a:t>How to build and run: docs/how-to-build-and-run.md</a:t>
+            </a:r>
+          </a:p>
+        </p:txBody>
+      </p:sp>
+      <p:sp>
+        <p:nvSpPr>
+          <p:cNvPr id="7" name="TextBox 6"/>
+          <p:cNvSpPr txBox="1"/>
+          <p:nvPr/>
+        </p:nvSpPr>
+        <p:spPr>
+          <a:xfrm>
+            <a:off x="731520" y="4023360"/>
+            <a:ext cx="10515600" cy="411480"/>
+          </a:xfrm>
+          <a:prstGeom prst="rect">
+            <a:avLst/>
+          </a:prstGeom>
+          <a:noFill/>
+        </p:spPr>
+        <p:txBody>
+          <a:bodyPr wrap="none">
+            <a:spAutoFit/>
+          </a:bodyPr>
+          <a:lstStyle/>
+          <a:p>
+            <a:r>
+              <a:rPr sz="1800" b="0">
+                <a:solidFill>
+                  <a:srgbClr val="CCCCCC"/>
+                </a:solidFill>
+                <a:latin typeface="Calibri"/>
+              </a:rPr>
+              <a:t>AWS create AMI steps: docs/aws-gold-ami-poc-runbook.md</a:t>
             </a:r>
           </a:p>
         </p:txBody>
@@ -4731,7 +5078,7 @@
         <p:spPr>
           <a:xfrm>
             <a:off x="548640" y="228600"/>
-            <a:ext cx="2194560" cy="320040"/>
+            <a:ext cx="2377440" cy="320040"/>
           </a:xfrm>
           <a:prstGeom prst="roundRect">
             <a:avLst/>
@@ -4774,7 +5121,7 @@
         <p:spPr>
           <a:xfrm>
             <a:off x="548640" y="256032"/>
-            <a:ext cx="2194560" cy="292608"/>
+            <a:ext cx="2377440" cy="292608"/>
           </a:xfrm>
           <a:prstGeom prst="rect">
             <a:avLst/>
@@ -4787,7 +5134,7 @@
           </a:bodyPr>
           <a:lstStyle/>
           <a:p>
-            <a:pPr algn="l"/>
+            <a:pPr algn="ctr"/>
             <a:r>
               <a:rPr sz="1100" b="1">
                 <a:solidFill>
@@ -5077,7 +5424,7 @@
         <p:spPr>
           <a:xfrm>
             <a:off x="548640" y="228600"/>
-            <a:ext cx="2194560" cy="320040"/>
+            <a:ext cx="2377440" cy="320040"/>
           </a:xfrm>
           <a:prstGeom prst="roundRect">
             <a:avLst/>
@@ -5120,7 +5467,7 @@
         <p:spPr>
           <a:xfrm>
             <a:off x="548640" y="256032"/>
-            <a:ext cx="2194560" cy="292608"/>
+            <a:ext cx="2377440" cy="292608"/>
           </a:xfrm>
           <a:prstGeom prst="rect">
             <a:avLst/>
@@ -5133,7 +5480,7 @@
           </a:bodyPr>
           <a:lstStyle/>
           <a:p>
-            <a:pPr algn="l"/>
+            <a:pPr algn="ctr"/>
             <a:r>
               <a:rPr sz="1100" b="1">
                 <a:solidFill>
@@ -5273,7 +5620,7 @@
                 </a:solidFill>
                 <a:latin typeface="Calibri"/>
               </a:rPr>
-              <a:t>•  Risky / untraceable change — drift and ad-hoc updates drive long outages</a:t>
+              <a:t>•  Risky / untraceable change — drift and ad-hoc updates create long outages</a:t>
             </a:r>
           </a:p>
           <a:p>
@@ -5289,7 +5636,7 @@
                 </a:solidFill>
                 <a:latin typeface="Calibri"/>
               </a:rPr>
-              <a:t>•  Container skills gap — ops need a clear, repeatable container path on RHEL</a:t>
+              <a:t>•  Container skills gap — need a clear, repeatable container path on RHEL</a:t>
             </a:r>
           </a:p>
           <a:p>
@@ -5457,7 +5804,7 @@
         <p:spPr>
           <a:xfrm>
             <a:off x="548640" y="228600"/>
-            <a:ext cx="2194560" cy="320040"/>
+            <a:ext cx="2377440" cy="320040"/>
           </a:xfrm>
           <a:prstGeom prst="roundRect">
             <a:avLst/>
@@ -5500,7 +5847,7 @@
         <p:spPr>
           <a:xfrm>
             <a:off x="548640" y="256032"/>
-            <a:ext cx="2194560" cy="292608"/>
+            <a:ext cx="2377440" cy="292608"/>
           </a:xfrm>
           <a:prstGeom prst="rect">
             <a:avLst/>
@@ -5513,7 +5860,7 @@
           </a:bodyPr>
           <a:lstStyle/>
           <a:p>
-            <a:pPr algn="l"/>
+            <a:pPr algn="ctr"/>
             <a:r>
               <a:rPr sz="1100" b="1">
                 <a:solidFill>
@@ -5653,7 +6000,7 @@
                 </a:solidFill>
                 <a:latin typeface="Calibri"/>
               </a:rPr>
-              <a:t>•  Live walkthrough — end-user path: gold image → VM → prove controls (5–10 min)</a:t>
+              <a:t>•  Live walkthrough — architecture → build steps → gold VM prove (5–10 min)</a:t>
             </a:r>
           </a:p>
           <a:p>
@@ -5837,7 +6184,7 @@
         <p:spPr>
           <a:xfrm>
             <a:off x="548640" y="228600"/>
-            <a:ext cx="2194560" cy="320040"/>
+            <a:ext cx="2377440" cy="320040"/>
           </a:xfrm>
           <a:prstGeom prst="roundRect">
             <a:avLst/>
@@ -5880,7 +6227,7 @@
         <p:spPr>
           <a:xfrm>
             <a:off x="548640" y="256032"/>
-            <a:ext cx="2194560" cy="292608"/>
+            <a:ext cx="2377440" cy="292608"/>
           </a:xfrm>
           <a:prstGeom prst="rect">
             <a:avLst/>
@@ -5893,7 +6240,7 @@
           </a:bodyPr>
           <a:lstStyle/>
           <a:p>
-            <a:pPr algn="l"/>
+            <a:pPr algn="ctr"/>
             <a:r>
               <a:rPr sz="1100" b="1">
                 <a:solidFill>
@@ -6199,7 +6546,7 @@
         <p:spPr>
           <a:xfrm>
             <a:off x="548640" y="228600"/>
-            <a:ext cx="2194560" cy="320040"/>
+            <a:ext cx="2377440" cy="320040"/>
           </a:xfrm>
           <a:prstGeom prst="roundRect">
             <a:avLst/>
@@ -6242,7 +6589,7 @@
         <p:spPr>
           <a:xfrm>
             <a:off x="548640" y="256032"/>
-            <a:ext cx="2194560" cy="292608"/>
+            <a:ext cx="2377440" cy="292608"/>
           </a:xfrm>
           <a:prstGeom prst="rect">
             <a:avLst/>
@@ -6255,7 +6602,7 @@
           </a:bodyPr>
           <a:lstStyle/>
           <a:p>
-            <a:pPr algn="l"/>
+            <a:pPr algn="ctr"/>
             <a:r>
               <a:rPr sz="1100" b="1">
                 <a:solidFill>
@@ -6277,7 +6624,7 @@
         <p:spPr>
           <a:xfrm>
             <a:off x="548640" y="640080"/>
-            <a:ext cx="10972800" cy="548640"/>
+            <a:ext cx="10972800" cy="457200"/>
           </a:xfrm>
           <a:prstGeom prst="rect">
             <a:avLst/>
@@ -6291,29 +6638,143 @@
           <a:lstStyle/>
           <a:p>
             <a:r>
-              <a:rPr sz="2600" b="1">
+              <a:rPr sz="2800" b="1">
                 <a:solidFill>
                   <a:srgbClr val="1A1A1A"/>
                 </a:solidFill>
                 <a:latin typeface="Calibri"/>
               </a:rPr>
-              <a:t>Critical decisions — and why</a:t>
-            </a:r>
-          </a:p>
-        </p:txBody>
-      </p:sp>
-      <p:sp>
-        <p:nvSpPr>
-          <p:cNvPr id="7" name="Rectangle 6"/>
+              <a:t>Solution architecture</a:t>
+            </a:r>
+          </a:p>
+        </p:txBody>
+      </p:sp>
+      <p:sp>
+        <p:nvSpPr>
+          <p:cNvPr id="7" name="Rounded Rectangle 6"/>
           <p:cNvSpPr/>
           <p:nvPr/>
         </p:nvSpPr>
         <p:spPr>
           <a:xfrm>
-            <a:off x="548640" y="1234440"/>
-            <a:ext cx="1828800" cy="45720"/>
-          </a:xfrm>
-          <a:prstGeom prst="rect">
+            <a:off x="502920" y="1417320"/>
+            <a:ext cx="1737360" cy="1234440"/>
+          </a:xfrm>
+          <a:prstGeom prst="roundRect">
+            <a:avLst/>
+          </a:prstGeom>
+          <a:solidFill>
+            <a:srgbClr val="2A2A2A"/>
+          </a:solidFill>
+          <a:ln>
+            <a:noFill/>
+          </a:ln>
+        </p:spPr>
+        <p:style>
+          <a:lnRef idx="1">
+            <a:schemeClr val="accent1"/>
+          </a:lnRef>
+          <a:fillRef idx="3">
+            <a:schemeClr val="accent1"/>
+          </a:fillRef>
+          <a:effectRef idx="2">
+            <a:schemeClr val="accent1"/>
+          </a:effectRef>
+          <a:fontRef idx="minor">
+            <a:schemeClr val="lt1"/>
+          </a:fontRef>
+        </p:style>
+        <p:txBody>
+          <a:bodyPr rtlCol="0" anchor="ctr"/>
+          <a:lstStyle/>
+          <a:p>
+            <a:pPr algn="ctr"/>
+          </a:p>
+        </p:txBody>
+      </p:sp>
+      <p:sp>
+        <p:nvSpPr>
+          <p:cNvPr id="8" name="TextBox 7"/>
+          <p:cNvSpPr txBox="1"/>
+          <p:nvPr/>
+        </p:nvSpPr>
+        <p:spPr>
+          <a:xfrm>
+            <a:off x="576072" y="1645920"/>
+            <a:ext cx="1591056" cy="868680"/>
+          </a:xfrm>
+          <a:prstGeom prst="rect">
+            <a:avLst/>
+          </a:prstGeom>
+          <a:noFill/>
+        </p:spPr>
+        <p:txBody>
+          <a:bodyPr wrap="square">
+            <a:spAutoFit/>
+          </a:bodyPr>
+          <a:lstStyle/>
+          <a:p>
+            <a:pPr algn="ctr"/>
+            <a:r>
+              <a:rPr sz="1400" b="1">
+                <a:solidFill>
+                  <a:srgbClr val="FFFFFF"/>
+                </a:solidFill>
+                <a:latin typeface="Calibri"/>
+              </a:rPr>
+              <a:t>TOML
+distro=rhel-10.x</a:t>
+            </a:r>
+          </a:p>
+        </p:txBody>
+      </p:sp>
+      <p:sp>
+        <p:nvSpPr>
+          <p:cNvPr id="9" name="TextBox 8"/>
+          <p:cNvSpPr txBox="1"/>
+          <p:nvPr/>
+        </p:nvSpPr>
+        <p:spPr>
+          <a:xfrm>
+            <a:off x="502920" y="2724912"/>
+            <a:ext cx="1737360" cy="320040"/>
+          </a:xfrm>
+          <a:prstGeom prst="rect">
+            <a:avLst/>
+          </a:prstGeom>
+          <a:noFill/>
+        </p:spPr>
+        <p:txBody>
+          <a:bodyPr wrap="none">
+            <a:spAutoFit/>
+          </a:bodyPr>
+          <a:lstStyle/>
+          <a:p>
+            <a:pPr algn="ctr"/>
+            <a:r>
+              <a:rPr sz="1100" b="0">
+                <a:solidFill>
+                  <a:srgbClr val="666666"/>
+                </a:solidFill>
+                <a:latin typeface="Calibri"/>
+              </a:rPr>
+              <a:t>Source of truth</a:t>
+            </a:r>
+          </a:p>
+        </p:txBody>
+      </p:sp>
+      <p:sp>
+        <p:nvSpPr>
+          <p:cNvPr id="10" name="Right Arrow 9"/>
+          <p:cNvSpPr/>
+          <p:nvPr/>
+        </p:nvSpPr>
+        <p:spPr>
+          <a:xfrm>
+            <a:off x="2286000" y="1874520"/>
+            <a:ext cx="301752" cy="320040"/>
+          </a:xfrm>
+          <a:prstGeom prst="rightArrow">
             <a:avLst/>
           </a:prstGeom>
           <a:solidFill>
@@ -6347,14 +6808,57 @@
       </p:sp>
       <p:sp>
         <p:nvSpPr>
-          <p:cNvPr id="8" name="TextBox 7"/>
+          <p:cNvPr id="11" name="Rounded Rectangle 10"/>
+          <p:cNvSpPr/>
+          <p:nvPr/>
+        </p:nvSpPr>
+        <p:spPr>
+          <a:xfrm>
+            <a:off x="2816352" y="1417320"/>
+            <a:ext cx="1737360" cy="1234440"/>
+          </a:xfrm>
+          <a:prstGeom prst="roundRect">
+            <a:avLst/>
+          </a:prstGeom>
+          <a:solidFill>
+            <a:srgbClr val="2A2A2A"/>
+          </a:solidFill>
+          <a:ln>
+            <a:noFill/>
+          </a:ln>
+        </p:spPr>
+        <p:style>
+          <a:lnRef idx="1">
+            <a:schemeClr val="accent1"/>
+          </a:lnRef>
+          <a:fillRef idx="3">
+            <a:schemeClr val="accent1"/>
+          </a:fillRef>
+          <a:effectRef idx="2">
+            <a:schemeClr val="accent1"/>
+          </a:effectRef>
+          <a:fontRef idx="minor">
+            <a:schemeClr val="lt1"/>
+          </a:fontRef>
+        </p:style>
+        <p:txBody>
+          <a:bodyPr rtlCol="0" anchor="ctr"/>
+          <a:lstStyle/>
+          <a:p>
+            <a:pPr algn="ctr"/>
+          </a:p>
+        </p:txBody>
+      </p:sp>
+      <p:sp>
+        <p:nvSpPr>
+          <p:cNvPr id="12" name="TextBox 11"/>
           <p:cNvSpPr txBox="1"/>
           <p:nvPr/>
         </p:nvSpPr>
         <p:spPr>
           <a:xfrm>
-            <a:off x="548640" y="1463040"/>
-            <a:ext cx="10972800" cy="4572000"/>
+            <a:off x="2889504" y="1645920"/>
+            <a:ext cx="1591056" cy="868680"/>
           </a:xfrm>
           <a:prstGeom prst="rect">
             <a:avLst/>
@@ -6367,83 +6871,916 @@
           </a:bodyPr>
           <a:lstStyle/>
           <a:p>
+            <a:pPr algn="ctr"/>
+            <a:r>
+              <a:rPr sz="1400" b="1">
+                <a:solidFill>
+                  <a:srgbClr val="FFFFFF"/>
+                </a:solidFill>
+                <a:latin typeface="Calibri"/>
+              </a:rPr>
+              <a:t>Local Image
+Builder</a:t>
+            </a:r>
+          </a:p>
+        </p:txBody>
+      </p:sp>
+      <p:sp>
+        <p:nvSpPr>
+          <p:cNvPr id="13" name="TextBox 12"/>
+          <p:cNvSpPr txBox="1"/>
+          <p:nvPr/>
+        </p:nvSpPr>
+        <p:spPr>
+          <a:xfrm>
+            <a:off x="2816352" y="2724912"/>
+            <a:ext cx="1737360" cy="320040"/>
+          </a:xfrm>
+          <a:prstGeom prst="rect">
+            <a:avLst/>
+          </a:prstGeom>
+          <a:noFill/>
+        </p:spPr>
+        <p:txBody>
+          <a:bodyPr wrap="none">
+            <a:spAutoFit/>
+          </a:bodyPr>
+          <a:lstStyle/>
+          <a:p>
+            <a:pPr algn="ctr"/>
+            <a:r>
+              <a:rPr sz="1100" b="0">
+                <a:solidFill>
+                  <a:srgbClr val="666666"/>
+                </a:solidFill>
+                <a:latin typeface="Calibri"/>
+              </a:rPr>
+              <a:t>On RHEL 10 host</a:t>
+            </a:r>
+          </a:p>
+        </p:txBody>
+      </p:sp>
+      <p:sp>
+        <p:nvSpPr>
+          <p:cNvPr id="14" name="Right Arrow 13"/>
+          <p:cNvSpPr/>
+          <p:nvPr/>
+        </p:nvSpPr>
+        <p:spPr>
+          <a:xfrm>
+            <a:off x="4599432" y="1874520"/>
+            <a:ext cx="301752" cy="320040"/>
+          </a:xfrm>
+          <a:prstGeom prst="rightArrow">
+            <a:avLst/>
+          </a:prstGeom>
+          <a:solidFill>
+            <a:srgbClr val="EE0000"/>
+          </a:solidFill>
+          <a:ln>
+            <a:noFill/>
+          </a:ln>
+        </p:spPr>
+        <p:style>
+          <a:lnRef idx="1">
+            <a:schemeClr val="accent1"/>
+          </a:lnRef>
+          <a:fillRef idx="3">
+            <a:schemeClr val="accent1"/>
+          </a:fillRef>
+          <a:effectRef idx="2">
+            <a:schemeClr val="accent1"/>
+          </a:effectRef>
+          <a:fontRef idx="minor">
+            <a:schemeClr val="lt1"/>
+          </a:fontRef>
+        </p:style>
+        <p:txBody>
+          <a:bodyPr rtlCol="0" anchor="ctr"/>
+          <a:lstStyle/>
+          <a:p>
+            <a:pPr algn="ctr"/>
+          </a:p>
+        </p:txBody>
+      </p:sp>
+      <p:sp>
+        <p:nvSpPr>
+          <p:cNvPr id="15" name="Rounded Rectangle 14"/>
+          <p:cNvSpPr/>
+          <p:nvPr/>
+        </p:nvSpPr>
+        <p:spPr>
+          <a:xfrm>
+            <a:off x="5129784" y="1417320"/>
+            <a:ext cx="1737360" cy="1234440"/>
+          </a:xfrm>
+          <a:prstGeom prst="roundRect">
+            <a:avLst/>
+          </a:prstGeom>
+          <a:solidFill>
+            <a:srgbClr val="2A2A2A"/>
+          </a:solidFill>
+          <a:ln>
+            <a:noFill/>
+          </a:ln>
+        </p:spPr>
+        <p:style>
+          <a:lnRef idx="1">
+            <a:schemeClr val="accent1"/>
+          </a:lnRef>
+          <a:fillRef idx="3">
+            <a:schemeClr val="accent1"/>
+          </a:fillRef>
+          <a:effectRef idx="2">
+            <a:schemeClr val="accent1"/>
+          </a:effectRef>
+          <a:fontRef idx="minor">
+            <a:schemeClr val="lt1"/>
+          </a:fontRef>
+        </p:style>
+        <p:txBody>
+          <a:bodyPr rtlCol="0" anchor="ctr"/>
+          <a:lstStyle/>
+          <a:p>
+            <a:pPr algn="ctr"/>
+          </a:p>
+        </p:txBody>
+      </p:sp>
+      <p:sp>
+        <p:nvSpPr>
+          <p:cNvPr id="16" name="TextBox 15"/>
+          <p:cNvSpPr txBox="1"/>
+          <p:nvPr/>
+        </p:nvSpPr>
+        <p:spPr>
+          <a:xfrm>
+            <a:off x="5202936" y="1645920"/>
+            <a:ext cx="1591056" cy="868680"/>
+          </a:xfrm>
+          <a:prstGeom prst="rect">
+            <a:avLst/>
+          </a:prstGeom>
+          <a:noFill/>
+        </p:spPr>
+        <p:txBody>
+          <a:bodyPr wrap="square">
+            <a:spAutoFit/>
+          </a:bodyPr>
+          <a:lstStyle/>
+          <a:p>
+            <a:pPr algn="ctr"/>
+            <a:r>
+              <a:rPr sz="1400" b="1">
+                <a:solidFill>
+                  <a:srgbClr val="FFFFFF"/>
+                </a:solidFill>
+                <a:latin typeface="Calibri"/>
+              </a:rPr>
+              <a:t>Gold disk
+(.raw)</a:t>
+            </a:r>
+          </a:p>
+        </p:txBody>
+      </p:sp>
+      <p:sp>
+        <p:nvSpPr>
+          <p:cNvPr id="17" name="TextBox 16"/>
+          <p:cNvSpPr txBox="1"/>
+          <p:nvPr/>
+        </p:nvSpPr>
+        <p:spPr>
+          <a:xfrm>
+            <a:off x="5129784" y="2724912"/>
+            <a:ext cx="1737360" cy="320040"/>
+          </a:xfrm>
+          <a:prstGeom prst="rect">
+            <a:avLst/>
+          </a:prstGeom>
+          <a:noFill/>
+        </p:spPr>
+        <p:txBody>
+          <a:bodyPr wrap="none">
+            <a:spAutoFit/>
+          </a:bodyPr>
+          <a:lstStyle/>
+          <a:p>
+            <a:pPr algn="ctr"/>
+            <a:r>
+              <a:rPr sz="1100" b="0">
+                <a:solidFill>
+                  <a:srgbClr val="666666"/>
+                </a:solidFill>
+                <a:latin typeface="Calibri"/>
+              </a:rPr>
+              <a:t>Hardened RHEL</a:t>
+            </a:r>
+          </a:p>
+        </p:txBody>
+      </p:sp>
+      <p:sp>
+        <p:nvSpPr>
+          <p:cNvPr id="18" name="Right Arrow 17"/>
+          <p:cNvSpPr/>
+          <p:nvPr/>
+        </p:nvSpPr>
+        <p:spPr>
+          <a:xfrm>
+            <a:off x="6912864" y="1874520"/>
+            <a:ext cx="301752" cy="320040"/>
+          </a:xfrm>
+          <a:prstGeom prst="rightArrow">
+            <a:avLst/>
+          </a:prstGeom>
+          <a:solidFill>
+            <a:srgbClr val="EE0000"/>
+          </a:solidFill>
+          <a:ln>
+            <a:noFill/>
+          </a:ln>
+        </p:spPr>
+        <p:style>
+          <a:lnRef idx="1">
+            <a:schemeClr val="accent1"/>
+          </a:lnRef>
+          <a:fillRef idx="3">
+            <a:schemeClr val="accent1"/>
+          </a:fillRef>
+          <a:effectRef idx="2">
+            <a:schemeClr val="accent1"/>
+          </a:effectRef>
+          <a:fontRef idx="minor">
+            <a:schemeClr val="lt1"/>
+          </a:fontRef>
+        </p:style>
+        <p:txBody>
+          <a:bodyPr rtlCol="0" anchor="ctr"/>
+          <a:lstStyle/>
+          <a:p>
+            <a:pPr algn="ctr"/>
+          </a:p>
+        </p:txBody>
+      </p:sp>
+      <p:sp>
+        <p:nvSpPr>
+          <p:cNvPr id="19" name="Rounded Rectangle 18"/>
+          <p:cNvSpPr/>
+          <p:nvPr/>
+        </p:nvSpPr>
+        <p:spPr>
+          <a:xfrm>
+            <a:off x="7443216" y="1417320"/>
+            <a:ext cx="1737360" cy="1234440"/>
+          </a:xfrm>
+          <a:prstGeom prst="roundRect">
+            <a:avLst/>
+          </a:prstGeom>
+          <a:solidFill>
+            <a:srgbClr val="2A2A2A"/>
+          </a:solidFill>
+          <a:ln>
+            <a:noFill/>
+          </a:ln>
+        </p:spPr>
+        <p:style>
+          <a:lnRef idx="1">
+            <a:schemeClr val="accent1"/>
+          </a:lnRef>
+          <a:fillRef idx="3">
+            <a:schemeClr val="accent1"/>
+          </a:fillRef>
+          <a:effectRef idx="2">
+            <a:schemeClr val="accent1"/>
+          </a:effectRef>
+          <a:fontRef idx="minor">
+            <a:schemeClr val="lt1"/>
+          </a:fontRef>
+        </p:style>
+        <p:txBody>
+          <a:bodyPr rtlCol="0" anchor="ctr"/>
+          <a:lstStyle/>
+          <a:p>
+            <a:pPr algn="ctr"/>
+          </a:p>
+        </p:txBody>
+      </p:sp>
+      <p:sp>
+        <p:nvSpPr>
+          <p:cNvPr id="20" name="TextBox 19"/>
+          <p:cNvSpPr txBox="1"/>
+          <p:nvPr/>
+        </p:nvSpPr>
+        <p:spPr>
+          <a:xfrm>
+            <a:off x="7516368" y="1645920"/>
+            <a:ext cx="1591056" cy="868680"/>
+          </a:xfrm>
+          <a:prstGeom prst="rect">
+            <a:avLst/>
+          </a:prstGeom>
+          <a:noFill/>
+        </p:spPr>
+        <p:txBody>
+          <a:bodyPr wrap="square">
+            <a:spAutoFit/>
+          </a:bodyPr>
+          <a:lstStyle/>
+          <a:p>
+            <a:pPr algn="ctr"/>
+            <a:r>
+              <a:rPr sz="1400" b="1">
+                <a:solidFill>
+                  <a:srgbClr val="FFFFFF"/>
+                </a:solidFill>
+                <a:latin typeface="Calibri"/>
+              </a:rPr>
+              <a:t>AWS AMI
+(+ Azure VHD)</a:t>
+            </a:r>
+          </a:p>
+        </p:txBody>
+      </p:sp>
+      <p:sp>
+        <p:nvSpPr>
+          <p:cNvPr id="21" name="TextBox 20"/>
+          <p:cNvSpPr txBox="1"/>
+          <p:nvPr/>
+        </p:nvSpPr>
+        <p:spPr>
+          <a:xfrm>
+            <a:off x="7443216" y="2724912"/>
+            <a:ext cx="1737360" cy="320040"/>
+          </a:xfrm>
+          <a:prstGeom prst="rect">
+            <a:avLst/>
+          </a:prstGeom>
+          <a:noFill/>
+        </p:spPr>
+        <p:txBody>
+          <a:bodyPr wrap="none">
+            <a:spAutoFit/>
+          </a:bodyPr>
+          <a:lstStyle/>
+          <a:p>
+            <a:pPr algn="ctr"/>
+            <a:r>
+              <a:rPr sz="1100" b="0">
+                <a:solidFill>
+                  <a:srgbClr val="666666"/>
+                </a:solidFill>
+                <a:latin typeface="Calibri"/>
+              </a:rPr>
+              <a:t>Catalog entry</a:t>
+            </a:r>
+          </a:p>
+        </p:txBody>
+      </p:sp>
+      <p:sp>
+        <p:nvSpPr>
+          <p:cNvPr id="22" name="Right Arrow 21"/>
+          <p:cNvSpPr/>
+          <p:nvPr/>
+        </p:nvSpPr>
+        <p:spPr>
+          <a:xfrm>
+            <a:off x="9226296" y="1874520"/>
+            <a:ext cx="301752" cy="320040"/>
+          </a:xfrm>
+          <a:prstGeom prst="rightArrow">
+            <a:avLst/>
+          </a:prstGeom>
+          <a:solidFill>
+            <a:srgbClr val="EE0000"/>
+          </a:solidFill>
+          <a:ln>
+            <a:noFill/>
+          </a:ln>
+        </p:spPr>
+        <p:style>
+          <a:lnRef idx="1">
+            <a:schemeClr val="accent1"/>
+          </a:lnRef>
+          <a:fillRef idx="3">
+            <a:schemeClr val="accent1"/>
+          </a:fillRef>
+          <a:effectRef idx="2">
+            <a:schemeClr val="accent1"/>
+          </a:effectRef>
+          <a:fontRef idx="minor">
+            <a:schemeClr val="lt1"/>
+          </a:fontRef>
+        </p:style>
+        <p:txBody>
+          <a:bodyPr rtlCol="0" anchor="ctr"/>
+          <a:lstStyle/>
+          <a:p>
+            <a:pPr algn="ctr"/>
+          </a:p>
+        </p:txBody>
+      </p:sp>
+      <p:sp>
+        <p:nvSpPr>
+          <p:cNvPr id="23" name="Rounded Rectangle 22"/>
+          <p:cNvSpPr/>
+          <p:nvPr/>
+        </p:nvSpPr>
+        <p:spPr>
+          <a:xfrm>
+            <a:off x="9756648" y="1417320"/>
+            <a:ext cx="1737360" cy="1234440"/>
+          </a:xfrm>
+          <a:prstGeom prst="roundRect">
+            <a:avLst/>
+          </a:prstGeom>
+          <a:solidFill>
+            <a:srgbClr val="2A2A2A"/>
+          </a:solidFill>
+          <a:ln>
+            <a:noFill/>
+          </a:ln>
+        </p:spPr>
+        <p:style>
+          <a:lnRef idx="1">
+            <a:schemeClr val="accent1"/>
+          </a:lnRef>
+          <a:fillRef idx="3">
+            <a:schemeClr val="accent1"/>
+          </a:fillRef>
+          <a:effectRef idx="2">
+            <a:schemeClr val="accent1"/>
+          </a:effectRef>
+          <a:fontRef idx="minor">
+            <a:schemeClr val="lt1"/>
+          </a:fontRef>
+        </p:style>
+        <p:txBody>
+          <a:bodyPr rtlCol="0" anchor="ctr"/>
+          <a:lstStyle/>
+          <a:p>
+            <a:pPr algn="ctr"/>
+          </a:p>
+        </p:txBody>
+      </p:sp>
+      <p:sp>
+        <p:nvSpPr>
+          <p:cNvPr id="24" name="TextBox 23"/>
+          <p:cNvSpPr txBox="1"/>
+          <p:nvPr/>
+        </p:nvSpPr>
+        <p:spPr>
+          <a:xfrm>
+            <a:off x="9829800" y="1645920"/>
+            <a:ext cx="1591056" cy="868680"/>
+          </a:xfrm>
+          <a:prstGeom prst="rect">
+            <a:avLst/>
+          </a:prstGeom>
+          <a:noFill/>
+        </p:spPr>
+        <p:txBody>
+          <a:bodyPr wrap="square">
+            <a:spAutoFit/>
+          </a:bodyPr>
+          <a:lstStyle/>
+          <a:p>
+            <a:pPr algn="ctr"/>
+            <a:r>
+              <a:rPr sz="1400" b="1">
+                <a:solidFill>
+                  <a:srgbClr val="FFFFFF"/>
+                </a:solidFill>
+                <a:latin typeface="Calibri"/>
+              </a:rPr>
+              <a:t>Web nodes
+(EC2 / Azure)</a:t>
+            </a:r>
+          </a:p>
+        </p:txBody>
+      </p:sp>
+      <p:sp>
+        <p:nvSpPr>
+          <p:cNvPr id="25" name="TextBox 24"/>
+          <p:cNvSpPr txBox="1"/>
+          <p:nvPr/>
+        </p:nvSpPr>
+        <p:spPr>
+          <a:xfrm>
+            <a:off x="9756648" y="2724912"/>
+            <a:ext cx="1737360" cy="320040"/>
+          </a:xfrm>
+          <a:prstGeom prst="rect">
+            <a:avLst/>
+          </a:prstGeom>
+          <a:noFill/>
+        </p:spPr>
+        <p:txBody>
+          <a:bodyPr wrap="none">
+            <a:spAutoFit/>
+          </a:bodyPr>
+          <a:lstStyle/>
+          <a:p>
+            <a:pPr algn="ctr"/>
+            <a:r>
+              <a:rPr sz="1100" b="0">
+                <a:solidFill>
+                  <a:srgbClr val="666666"/>
+                </a:solidFill>
+                <a:latin typeface="Calibri"/>
+              </a:rPr>
+              <a:t>Identical launches</a:t>
+            </a:r>
+          </a:p>
+        </p:txBody>
+      </p:sp>
+      <p:sp>
+        <p:nvSpPr>
+          <p:cNvPr id="26" name="Rounded Rectangle 25"/>
+          <p:cNvSpPr/>
+          <p:nvPr/>
+        </p:nvSpPr>
+        <p:spPr>
+          <a:xfrm>
+            <a:off x="502920" y="3246120"/>
+            <a:ext cx="11155680" cy="3108960"/>
+          </a:xfrm>
+          <a:prstGeom prst="roundRect">
+            <a:avLst/>
+          </a:prstGeom>
+          <a:solidFill>
+            <a:srgbClr val="EEEEEE"/>
+          </a:solidFill>
+          <a:ln>
+            <a:solidFill>
+              <a:srgbClr val="E0E0E0"/>
+            </a:solidFill>
+          </a:ln>
+        </p:spPr>
+        <p:style>
+          <a:lnRef idx="1">
+            <a:schemeClr val="accent1"/>
+          </a:lnRef>
+          <a:fillRef idx="3">
+            <a:schemeClr val="accent1"/>
+          </a:fillRef>
+          <a:effectRef idx="2">
+            <a:schemeClr val="accent1"/>
+          </a:effectRef>
+          <a:fontRef idx="minor">
+            <a:schemeClr val="lt1"/>
+          </a:fontRef>
+        </p:style>
+        <p:txBody>
+          <a:bodyPr rtlCol="0" anchor="ctr"/>
+          <a:lstStyle/>
+          <a:p>
+            <a:pPr algn="ctr"/>
+          </a:p>
+        </p:txBody>
+      </p:sp>
+      <p:sp>
+        <p:nvSpPr>
+          <p:cNvPr id="27" name="TextBox 26"/>
+          <p:cNvSpPr txBox="1"/>
+          <p:nvPr/>
+        </p:nvSpPr>
+        <p:spPr>
+          <a:xfrm>
+            <a:off x="731520" y="3383280"/>
+            <a:ext cx="10515600" cy="365760"/>
+          </a:xfrm>
+          <a:prstGeom prst="rect">
+            <a:avLst/>
+          </a:prstGeom>
+          <a:noFill/>
+        </p:spPr>
+        <p:txBody>
+          <a:bodyPr wrap="none">
+            <a:spAutoFit/>
+          </a:bodyPr>
+          <a:lstStyle/>
+          <a:p>
+            <a:r>
+              <a:rPr sz="1600" b="1">
+                <a:solidFill>
+                  <a:srgbClr val="1A1A1A"/>
+                </a:solidFill>
+                <a:latin typeface="Calibri"/>
+              </a:rPr>
+              <a:t>On every VM from the gold image</a:t>
+            </a:r>
+          </a:p>
+        </p:txBody>
+      </p:sp>
+      <p:sp>
+        <p:nvSpPr>
+          <p:cNvPr id="28" name="TextBox 27"/>
+          <p:cNvSpPr txBox="1"/>
+          <p:nvPr/>
+        </p:nvSpPr>
+        <p:spPr>
+          <a:xfrm>
+            <a:off x="731520" y="3886200"/>
+            <a:ext cx="3200400" cy="320040"/>
+          </a:xfrm>
+          <a:prstGeom prst="rect">
+            <a:avLst/>
+          </a:prstGeom>
+          <a:noFill/>
+        </p:spPr>
+        <p:txBody>
+          <a:bodyPr wrap="none">
+            <a:spAutoFit/>
+          </a:bodyPr>
+          <a:lstStyle/>
+          <a:p>
+            <a:r>
+              <a:rPr sz="1400" b="1">
+                <a:solidFill>
+                  <a:srgbClr val="EE0000"/>
+                </a:solidFill>
+                <a:latin typeface="Calibri"/>
+              </a:rPr>
+              <a:t>Access</a:t>
+            </a:r>
+          </a:p>
+        </p:txBody>
+      </p:sp>
+      <p:sp>
+        <p:nvSpPr>
+          <p:cNvPr id="29" name="TextBox 28"/>
+          <p:cNvSpPr txBox="1"/>
+          <p:nvPr/>
+        </p:nvSpPr>
+        <p:spPr>
+          <a:xfrm>
+            <a:off x="731520" y="4251960"/>
+            <a:ext cx="3200400" cy="1828800"/>
+          </a:xfrm>
+          <a:prstGeom prst="rect">
+            <a:avLst/>
+          </a:prstGeom>
+          <a:noFill/>
+        </p:spPr>
+        <p:txBody>
+          <a:bodyPr wrap="square">
+            <a:spAutoFit/>
+          </a:bodyPr>
+          <a:lstStyle/>
+          <a:p>
             <a:pPr>
               <a:spcAft>
-                <a:spcPts val="900"/>
+                <a:spcPts val="400"/>
               </a:spcAft>
             </a:pPr>
             <a:r>
-              <a:rPr sz="1800" b="0">
+              <a:rPr sz="1300" b="0">
                 <a:solidFill>
                   <a:srgbClr val="1A1A1A"/>
                 </a:solidFill>
                 <a:latin typeface="Calibri"/>
               </a:rPr>
-              <a:t>•  Local Image Builder (not hosted console.redhat.com) — matches Expansion Pack manual compose</a:t>
+              <a:t>•  SSH :2222</a:t>
             </a:r>
           </a:p>
           <a:p>
             <a:pPr>
               <a:spcAft>
-                <a:spcPts val="900"/>
+                <a:spcPts val="400"/>
               </a:spcAft>
             </a:pPr>
             <a:r>
-              <a:rPr sz="1800" b="0">
+              <a:rPr sz="1300" b="0">
                 <a:solidFill>
                   <a:srgbClr val="1A1A1A"/>
                 </a:solidFill>
                 <a:latin typeface="Calibri"/>
               </a:rPr>
-              <a:t>•  One blueprint → two cloud artifacts — same controls on AWS and Azure</a:t>
+              <a:t>•  Users: fladmin1 / fladmin2</a:t>
             </a:r>
           </a:p>
           <a:p>
             <a:pPr>
               <a:spcAft>
-                <a:spcPts val="900"/>
+                <a:spcPts val="400"/>
               </a:spcAft>
             </a:pPr>
             <a:r>
-              <a:rPr sz="1800" b="0">
+              <a:rPr sz="1300" b="0">
                 <a:solidFill>
                   <a:srgbClr val="1A1A1A"/>
                 </a:solidFill>
                 <a:latin typeface="Calibri"/>
               </a:rPr>
-              <a:t>•  Replace from gold image in waves — not rebuild 1,600×, not in-place root swap</a:t>
-            </a:r>
-          </a:p>
+              <a:t>•  Key-only SSH · fladmins sudo</a:t>
+            </a:r>
+          </a:p>
+        </p:txBody>
+      </p:sp>
+      <p:sp>
+        <p:nvSpPr>
+          <p:cNvPr id="30" name="TextBox 29"/>
+          <p:cNvSpPr txBox="1"/>
+          <p:nvPr/>
+        </p:nvSpPr>
+        <p:spPr>
+          <a:xfrm>
+            <a:off x="4297680" y="3886200"/>
+            <a:ext cx="3200400" cy="320040"/>
+          </a:xfrm>
+          <a:prstGeom prst="rect">
+            <a:avLst/>
+          </a:prstGeom>
+          <a:noFill/>
+        </p:spPr>
+        <p:txBody>
+          <a:bodyPr wrap="none">
+            <a:spAutoFit/>
+          </a:bodyPr>
+          <a:lstStyle/>
+          <a:p>
+            <a:r>
+              <a:rPr sz="1400" b="1">
+                <a:solidFill>
+                  <a:srgbClr val="EE0000"/>
+                </a:solidFill>
+                <a:latin typeface="Calibri"/>
+              </a:rPr>
+              <a:t>Web service</a:t>
+            </a:r>
+          </a:p>
+        </p:txBody>
+      </p:sp>
+      <p:sp>
+        <p:nvSpPr>
+          <p:cNvPr id="31" name="TextBox 30"/>
+          <p:cNvSpPr txBox="1"/>
+          <p:nvPr/>
+        </p:nvSpPr>
+        <p:spPr>
+          <a:xfrm>
+            <a:off x="4297680" y="4251960"/>
+            <a:ext cx="3200400" cy="1828800"/>
+          </a:xfrm>
+          <a:prstGeom prst="rect">
+            <a:avLst/>
+          </a:prstGeom>
+          <a:noFill/>
+        </p:spPr>
+        <p:txBody>
+          <a:bodyPr wrap="square">
+            <a:spAutoFit/>
+          </a:bodyPr>
+          <a:lstStyle/>
           <a:p>
             <a:pPr>
               <a:spcAft>
-                <a:spcPts val="900"/>
+                <a:spcPts val="400"/>
               </a:spcAft>
             </a:pPr>
             <a:r>
-              <a:rPr sz="1800" b="0">
+              <a:rPr sz="1300" b="0">
                 <a:solidFill>
                   <a:srgbClr val="1A1A1A"/>
                 </a:solidFill>
                 <a:latin typeface="Calibri"/>
               </a:rPr>
-              <a:t>•  Firstboot / User data starts httpd — image has the tooling; launch completes the service</a:t>
+              <a:t>•  httpd in Podman :35443</a:t>
             </a:r>
           </a:p>
           <a:p>
             <a:pPr>
               <a:spcAft>
-                <a:spcPts val="900"/>
+                <a:spcPts val="400"/>
               </a:spcAft>
             </a:pPr>
             <a:r>
-              <a:rPr sz="1800" b="0">
+              <a:rPr sz="1300" b="0">
                 <a:solidFill>
                   <a:srgbClr val="1A1A1A"/>
                 </a:solidFill>
                 <a:latin typeface="Calibri"/>
               </a:rPr>
-              <a:t>•  SG/NSG separate from image — network policy stays in cloud controls</a:t>
+              <a:t>•  Dummy boutique app (demo)</a:t>
+            </a:r>
+          </a:p>
+          <a:p>
+            <a:pPr>
+              <a:spcAft>
+                <a:spcPts val="400"/>
+              </a:spcAft>
+            </a:pPr>
+            <a:r>
+              <a:rPr sz="1300" b="0">
+                <a:solidFill>
+                  <a:srgbClr val="1A1A1A"/>
+                </a:solidFill>
+                <a:latin typeface="Calibri"/>
+              </a:rPr>
+              <a:t>•  systemd: fl-httpd / firstboot</a:t>
+            </a:r>
+          </a:p>
+        </p:txBody>
+      </p:sp>
+      <p:sp>
+        <p:nvSpPr>
+          <p:cNvPr id="32" name="TextBox 31"/>
+          <p:cNvSpPr txBox="1"/>
+          <p:nvPr/>
+        </p:nvSpPr>
+        <p:spPr>
+          <a:xfrm>
+            <a:off x="7863840" y="3886200"/>
+            <a:ext cx="3200400" cy="320040"/>
+          </a:xfrm>
+          <a:prstGeom prst="rect">
+            <a:avLst/>
+          </a:prstGeom>
+          <a:noFill/>
+        </p:spPr>
+        <p:txBody>
+          <a:bodyPr wrap="none">
+            <a:spAutoFit/>
+          </a:bodyPr>
+          <a:lstStyle/>
+          <a:p>
+            <a:r>
+              <a:rPr sz="1400" b="1">
+                <a:solidFill>
+                  <a:srgbClr val="EE0000"/>
+                </a:solidFill>
+                <a:latin typeface="Calibri"/>
+              </a:rPr>
+              <a:t>Security baseline</a:t>
+            </a:r>
+          </a:p>
+        </p:txBody>
+      </p:sp>
+      <p:sp>
+        <p:nvSpPr>
+          <p:cNvPr id="33" name="TextBox 32"/>
+          <p:cNvSpPr txBox="1"/>
+          <p:nvPr/>
+        </p:nvSpPr>
+        <p:spPr>
+          <a:xfrm>
+            <a:off x="7863840" y="4251960"/>
+            <a:ext cx="3200400" cy="1828800"/>
+          </a:xfrm>
+          <a:prstGeom prst="rect">
+            <a:avLst/>
+          </a:prstGeom>
+          <a:noFill/>
+        </p:spPr>
+        <p:txBody>
+          <a:bodyPr wrap="square">
+            <a:spAutoFit/>
+          </a:bodyPr>
+          <a:lstStyle/>
+          <a:p>
+            <a:pPr>
+              <a:spcAft>
+                <a:spcPts val="400"/>
+              </a:spcAft>
+            </a:pPr>
+            <a:r>
+              <a:rPr sz="1300" b="0">
+                <a:solidFill>
+                  <a:srgbClr val="1A1A1A"/>
+                </a:solidFill>
+                <a:latin typeface="Calibri"/>
+              </a:rPr>
+              <a:t>•  Firewall: 2222 + 35443 only</a:t>
+            </a:r>
+          </a:p>
+          <a:p>
+            <a:pPr>
+              <a:spcAft>
+                <a:spcPts val="400"/>
+              </a:spcAft>
+            </a:pPr>
+            <a:r>
+              <a:rPr sz="1300" b="0">
+                <a:solidFill>
+                  <a:srgbClr val="1A1A1A"/>
+                </a:solidFill>
+                <a:latin typeface="Calibri"/>
+              </a:rPr>
+              <a:t>•  SELinux enforcing</a:t>
+            </a:r>
+          </a:p>
+          <a:p>
+            <a:pPr>
+              <a:spcAft>
+                <a:spcPts val="400"/>
+              </a:spcAft>
+            </a:pPr>
+            <a:r>
+              <a:rPr sz="1300" b="0">
+                <a:solidFill>
+                  <a:srgbClr val="1A1A1A"/>
+                </a:solidFill>
+                <a:latin typeface="Calibri"/>
+              </a:rPr>
+              <a:t>•  /tmp noexec · separate mounts</a:t>
             </a:r>
           </a:p>
         </p:txBody>
@@ -6561,7 +7898,7 @@
         <p:spPr>
           <a:xfrm>
             <a:off x="548640" y="228600"/>
-            <a:ext cx="2194560" cy="320040"/>
+            <a:ext cx="2377440" cy="320040"/>
           </a:xfrm>
           <a:prstGeom prst="roundRect">
             <a:avLst/>
@@ -6604,7 +7941,7 @@
         <p:spPr>
           <a:xfrm>
             <a:off x="548640" y="256032"/>
-            <a:ext cx="2194560" cy="292608"/>
+            <a:ext cx="2377440" cy="292608"/>
           </a:xfrm>
           <a:prstGeom prst="rect">
             <a:avLst/>
@@ -6617,7 +7954,7 @@
           </a:bodyPr>
           <a:lstStyle/>
           <a:p>
-            <a:pPr algn="l"/>
+            <a:pPr algn="ctr"/>
             <a:r>
               <a:rPr sz="1100" b="1">
                 <a:solidFill>
@@ -6659,7 +7996,7 @@
                 </a:solidFill>
                 <a:latin typeface="Calibri"/>
               </a:rPr>
-              <a:t>Live path (end-user view)</a:t>
+              <a:t>Build steps (what we run)</a:t>
             </a:r>
           </a:p>
         </p:txBody>
@@ -6741,7 +8078,7 @@
                 </a:solidFill>
                 <a:latin typeface="Calibri"/>
               </a:rPr>
-              <a:t>•  1. Blueprint in Git — recipe for mounts, SSH, fladmins, ports</a:t>
+              <a:t>•  1. Blueprint in Git — fl-rhel-gold.toml (distro=rhel-10.x)</a:t>
             </a:r>
           </a:p>
           <a:p>
@@ -6757,7 +8094,7 @@
                 </a:solidFill>
                 <a:latin typeface="Calibri"/>
               </a:rPr>
-              <a:t>•  2. Compose on subscribed RHEL builder → AMI or VHD</a:t>
+              <a:t>•  2. Builder host — install image-builder; sudo rhc connect</a:t>
             </a:r>
           </a:p>
           <a:p>
@@ -6773,7 +8110,7 @@
                 </a:solidFill>
                 <a:latin typeface="Calibri"/>
               </a:rPr>
-              <a:t>•  3. Register gold image in AWS / Azure</a:t>
+              <a:t>•  3. Compose — image-builder build ami → .raw on builder</a:t>
             </a:r>
           </a:p>
           <a:p>
@@ -6789,7 +8126,7 @@
                 </a:solidFill>
                 <a:latin typeface="Calibri"/>
               </a:rPr>
-              <a:t>•  4. Launch VM from gold image (Console or CLI)</a:t>
+              <a:t>•  4. Upload + register — S3 + vmimport → AMI fl-rhel-gold</a:t>
             </a:r>
           </a:p>
           <a:p>
@@ -6805,7 +8142,7 @@
                 </a:solidFill>
                 <a:latin typeface="Calibri"/>
               </a:rPr>
-              <a:t>•  5. Firstboot starts httpd container on 35443</a:t>
+              <a:t>•  5. Launch — EC2 from AMI (SG: 2222 + 35443)</a:t>
             </a:r>
           </a:p>
           <a:p>
@@ -6821,7 +8158,7 @@
                 </a:solidFill>
                 <a:latin typeface="Calibri"/>
               </a:rPr>
-              <a:t>•  6. Verify live: SELinux, mounts, ports, curl, reboot</a:t>
+              <a:t>•  6. Prove — SSH fladmin1, curl :35443, verify + reboot</a:t>
             </a:r>
           </a:p>
         </p:txBody>
@@ -6855,7 +8192,7 @@
                 </a:solidFill>
                 <a:latin typeface="Calibri"/>
               </a:rPr>
-              <a:t>Demo now: open gold VM + verify commands (see presentation script)</a:t>
+              <a:t>Same recipe → Azure VHD for dual-cloud</a:t>
             </a:r>
           </a:p>
         </p:txBody>
@@ -6973,7 +8310,7 @@
         <p:spPr>
           <a:xfrm>
             <a:off x="548640" y="228600"/>
-            <a:ext cx="2194560" cy="320040"/>
+            <a:ext cx="2377440" cy="320040"/>
           </a:xfrm>
           <a:prstGeom prst="roundRect">
             <a:avLst/>
@@ -7016,7 +8353,7 @@
         <p:spPr>
           <a:xfrm>
             <a:off x="548640" y="256032"/>
-            <a:ext cx="2194560" cy="292608"/>
+            <a:ext cx="2377440" cy="292608"/>
           </a:xfrm>
           <a:prstGeom prst="rect">
             <a:avLst/>
@@ -7029,7 +8366,7 @@
           </a:bodyPr>
           <a:lstStyle/>
           <a:p>
-            <a:pPr algn="l"/>
+            <a:pPr algn="ctr"/>
             <a:r>
               <a:rPr sz="1100" b="1">
                 <a:solidFill>
@@ -7051,7 +8388,7 @@
         <p:spPr>
           <a:xfrm>
             <a:off x="548640" y="640080"/>
-            <a:ext cx="10972800" cy="502920"/>
+            <a:ext cx="10972800" cy="548640"/>
           </a:xfrm>
           <a:prstGeom prst="rect">
             <a:avLst/>
@@ -7065,38 +8402,36 @@
           <a:lstStyle/>
           <a:p>
             <a:r>
-              <a:rPr sz="2400" b="1">
+              <a:rPr sz="2600" b="1">
                 <a:solidFill>
                   <a:srgbClr val="1A1A1A"/>
                 </a:solidFill>
                 <a:latin typeface="Calibri"/>
               </a:rPr>
-              <a:t>What we prove on the live VM</a:t>
-            </a:r>
-          </a:p>
-        </p:txBody>
-      </p:sp>
-      <p:sp>
-        <p:nvSpPr>
-          <p:cNvPr id="7" name="Rounded Rectangle 6"/>
+              <a:t>Critical decisions — and why</a:t>
+            </a:r>
+          </a:p>
+        </p:txBody>
+      </p:sp>
+      <p:sp>
+        <p:nvSpPr>
+          <p:cNvPr id="7" name="Rectangle 6"/>
           <p:cNvSpPr/>
           <p:nvPr/>
         </p:nvSpPr>
         <p:spPr>
           <a:xfrm>
-            <a:off x="548640" y="1371600"/>
-            <a:ext cx="5120640" cy="4663440"/>
-          </a:xfrm>
-          <a:prstGeom prst="roundRect">
+            <a:off x="548640" y="1234440"/>
+            <a:ext cx="1828800" cy="45720"/>
+          </a:xfrm>
+          <a:prstGeom prst="rect">
             <a:avLst/>
           </a:prstGeom>
           <a:solidFill>
-            <a:srgbClr val="FFFFFF"/>
+            <a:srgbClr val="EE0000"/>
           </a:solidFill>
           <a:ln>
-            <a:solidFill>
-              <a:srgbClr val="E0E0E0"/>
-            </a:solidFill>
+            <a:noFill/>
           </a:ln>
         </p:spPr>
         <p:style>
@@ -7129,42 +8464,8 @@
         </p:nvSpPr>
         <p:spPr>
           <a:xfrm>
-            <a:off x="822959" y="1554480"/>
-            <a:ext cx="4572000" cy="411480"/>
-          </a:xfrm>
-          <a:prstGeom prst="rect">
-            <a:avLst/>
-          </a:prstGeom>
-          <a:noFill/>
-        </p:spPr>
-        <p:txBody>
-          <a:bodyPr wrap="none">
-            <a:spAutoFit/>
-          </a:bodyPr>
-          <a:lstStyle/>
-          <a:p>
-            <a:r>
-              <a:rPr sz="1600" b="1">
-                <a:solidFill>
-                  <a:srgbClr val="EE0000"/>
-                </a:solidFill>
-                <a:latin typeface="Calibri"/>
-              </a:rPr>
-              <a:t>Expansion Pack controls</a:t>
-            </a:r>
-          </a:p>
-        </p:txBody>
-      </p:sp>
-      <p:sp>
-        <p:nvSpPr>
-          <p:cNvPr id="9" name="TextBox 8"/>
-          <p:cNvSpPr txBox="1"/>
-          <p:nvPr/>
-        </p:nvSpPr>
-        <p:spPr>
-          <a:xfrm>
-            <a:off x="822959" y="2103120"/>
-            <a:ext cx="4572000" cy="3657600"/>
+            <a:off x="548640" y="1463040"/>
+            <a:ext cx="10972800" cy="4572000"/>
           </a:xfrm>
           <a:prstGeom prst="rect">
             <a:avLst/>
@@ -7179,279 +8480,81 @@
           <a:p>
             <a:pPr>
               <a:spcAft>
-                <a:spcPts val="700"/>
+                <a:spcPts val="900"/>
               </a:spcAft>
             </a:pPr>
             <a:r>
-              <a:rPr sz="1500" b="0">
+              <a:rPr sz="1800" b="0">
                 <a:solidFill>
                   <a:srgbClr val="1A1A1A"/>
                 </a:solidFill>
                 <a:latin typeface="Calibri"/>
               </a:rPr>
-              <a:t>•  SELinux Enforcing</a:t>
+              <a:t>•  Local Image Builder (not hosted console.redhat.com) — matches Expansion Pack</a:t>
             </a:r>
           </a:p>
           <a:p>
             <a:pPr>
               <a:spcAft>
-                <a:spcPts val="700"/>
+                <a:spcPts val="900"/>
               </a:spcAft>
             </a:pPr>
             <a:r>
-              <a:rPr sz="1500" b="0">
+              <a:rPr sz="1800" b="0">
                 <a:solidFill>
                   <a:srgbClr val="1A1A1A"/>
                 </a:solidFill>
                 <a:latin typeface="Calibri"/>
               </a:rPr>
-              <a:t>•  Separate /var/log /home /tmp /var/tmp</a:t>
+              <a:t>•  One blueprint → two cloud artifacts — same controls on AWS and Azure</a:t>
             </a:r>
           </a:p>
           <a:p>
             <a:pPr>
               <a:spcAft>
-                <a:spcPts val="700"/>
+                <a:spcPts val="900"/>
               </a:spcAft>
             </a:pPr>
             <a:r>
-              <a:rPr sz="1500" b="0">
+              <a:rPr sz="1800" b="0">
                 <a:solidFill>
                   <a:srgbClr val="1A1A1A"/>
                 </a:solidFill>
                 <a:latin typeface="Calibri"/>
               </a:rPr>
-              <a:t>•  /tmp noexec</a:t>
+              <a:t>•  Replace from gold image in waves — not rebuild 1,600×, not in-place root swap</a:t>
             </a:r>
           </a:p>
           <a:p>
             <a:pPr>
               <a:spcAft>
-                <a:spcPts val="700"/>
+                <a:spcPts val="900"/>
               </a:spcAft>
             </a:pPr>
             <a:r>
-              <a:rPr sz="1500" b="0">
+              <a:rPr sz="1800" b="0">
                 <a:solidFill>
                   <a:srgbClr val="1A1A1A"/>
                 </a:solidFill>
                 <a:latin typeface="Calibri"/>
               </a:rPr>
-              <a:t>•  SSH 2222 key-only · no root SSH</a:t>
+              <a:t>•  Firstboot / User data starts httpd — image has tooling; launch completes service</a:t>
             </a:r>
           </a:p>
           <a:p>
             <a:pPr>
               <a:spcAft>
-                <a:spcPts val="700"/>
+                <a:spcPts val="900"/>
               </a:spcAft>
             </a:pPr>
             <a:r>
-              <a:rPr sz="1500" b="0">
+              <a:rPr sz="1800" b="0">
                 <a:solidFill>
                   <a:srgbClr val="1A1A1A"/>
                 </a:solidFill>
                 <a:latin typeface="Calibri"/>
               </a:rPr>
-              <a:t>•  fladmins · fladmin1 / fladmin2</a:t>
-            </a:r>
-          </a:p>
-          <a:p>
-            <a:pPr>
-              <a:spcAft>
-                <a:spcPts val="700"/>
-              </a:spcAft>
-            </a:pPr>
-            <a:r>
-              <a:rPr sz="1500" b="0">
-                <a:solidFill>
-                  <a:srgbClr val="1A1A1A"/>
-                </a:solidFill>
-                <a:latin typeface="Calibri"/>
-              </a:rPr>
-              <a:t>•  Firewall: 2222 + 35443 only</a:t>
-            </a:r>
-          </a:p>
-        </p:txBody>
-      </p:sp>
-      <p:sp>
-        <p:nvSpPr>
-          <p:cNvPr id="10" name="Rounded Rectangle 9"/>
-          <p:cNvSpPr/>
-          <p:nvPr/>
-        </p:nvSpPr>
-        <p:spPr>
-          <a:xfrm>
-            <a:off x="6400800" y="1371600"/>
-            <a:ext cx="5120640" cy="4663440"/>
-          </a:xfrm>
-          <a:prstGeom prst="roundRect">
-            <a:avLst/>
-          </a:prstGeom>
-          <a:solidFill>
-            <a:srgbClr val="FFFFFF"/>
-          </a:solidFill>
-          <a:ln>
-            <a:solidFill>
-              <a:srgbClr val="E0E0E0"/>
-            </a:solidFill>
-          </a:ln>
-        </p:spPr>
-        <p:style>
-          <a:lnRef idx="1">
-            <a:schemeClr val="accent1"/>
-          </a:lnRef>
-          <a:fillRef idx="3">
-            <a:schemeClr val="accent1"/>
-          </a:fillRef>
-          <a:effectRef idx="2">
-            <a:schemeClr val="accent1"/>
-          </a:effectRef>
-          <a:fontRef idx="minor">
-            <a:schemeClr val="lt1"/>
-          </a:fontRef>
-        </p:style>
-        <p:txBody>
-          <a:bodyPr rtlCol="0" anchor="ctr"/>
-          <a:lstStyle/>
-          <a:p>
-            <a:pPr algn="ctr"/>
-          </a:p>
-        </p:txBody>
-      </p:sp>
-      <p:sp>
-        <p:nvSpPr>
-          <p:cNvPr id="11" name="TextBox 10"/>
-          <p:cNvSpPr txBox="1"/>
-          <p:nvPr/>
-        </p:nvSpPr>
-        <p:spPr>
-          <a:xfrm>
-            <a:off x="6675120" y="1554480"/>
-            <a:ext cx="4572000" cy="411480"/>
-          </a:xfrm>
-          <a:prstGeom prst="rect">
-            <a:avLst/>
-          </a:prstGeom>
-          <a:noFill/>
-        </p:spPr>
-        <p:txBody>
-          <a:bodyPr wrap="none">
-            <a:spAutoFit/>
-          </a:bodyPr>
-          <a:lstStyle/>
-          <a:p>
-            <a:r>
-              <a:rPr sz="1600" b="1">
-                <a:solidFill>
-                  <a:srgbClr val="EE0000"/>
-                </a:solidFill>
-                <a:latin typeface="Calibri"/>
-              </a:rPr>
-              <a:t>Service in action</a:t>
-            </a:r>
-          </a:p>
-        </p:txBody>
-      </p:sp>
-      <p:sp>
-        <p:nvSpPr>
-          <p:cNvPr id="12" name="TextBox 11"/>
-          <p:cNvSpPr txBox="1"/>
-          <p:nvPr/>
-        </p:nvSpPr>
-        <p:spPr>
-          <a:xfrm>
-            <a:off x="6675120" y="2103120"/>
-            <a:ext cx="4572000" cy="3657600"/>
-          </a:xfrm>
-          <a:prstGeom prst="rect">
-            <a:avLst/>
-          </a:prstGeom>
-          <a:noFill/>
-        </p:spPr>
-        <p:txBody>
-          <a:bodyPr wrap="square">
-            <a:spAutoFit/>
-          </a:bodyPr>
-          <a:lstStyle/>
-          <a:p>
-            <a:pPr>
-              <a:spcAft>
-                <a:spcPts val="700"/>
-              </a:spcAft>
-            </a:pPr>
-            <a:r>
-              <a:rPr sz="1500" b="0">
-                <a:solidFill>
-                  <a:srgbClr val="1A1A1A"/>
-                </a:solidFill>
-                <a:latin typeface="Calibri"/>
-              </a:rPr>
-              <a:t>•  httpd container listening on 35443</a:t>
-            </a:r>
-          </a:p>
-          <a:p>
-            <a:pPr>
-              <a:spcAft>
-                <a:spcPts val="700"/>
-              </a:spcAft>
-            </a:pPr>
-            <a:r>
-              <a:rPr sz="1500" b="0">
-                <a:solidFill>
-                  <a:srgbClr val="1A1A1A"/>
-                </a:solidFill>
-                <a:latin typeface="Calibri"/>
-              </a:rPr>
-              <a:t>•  Fedora Lane index page via curl</a:t>
-            </a:r>
-          </a:p>
-          <a:p>
-            <a:pPr>
-              <a:spcAft>
-                <a:spcPts val="700"/>
-              </a:spcAft>
-            </a:pPr>
-            <a:r>
-              <a:rPr sz="1500" b="0">
-                <a:solidFill>
-                  <a:srgbClr val="1A1A1A"/>
-                </a:solidFill>
-                <a:latin typeface="Calibri"/>
-              </a:rPr>
-              <a:t>•  Same checklist after reboot</a:t>
-            </a:r>
-          </a:p>
-          <a:p>
-            <a:pPr>
-              <a:spcAft>
-                <a:spcPts val="700"/>
-              </a:spcAft>
-            </a:pPr>
-            <a:r>
-              <a:rPr sz="1500" b="0">
-                <a:solidFill>
-                  <a:srgbClr val="1A1A1A"/>
-                </a:solidFill>
-                <a:latin typeface="Calibri"/>
-              </a:rPr>
-              <a:t>•  Proven on AWS and Azure</a:t>
-            </a:r>
-          </a:p>
-          <a:p>
-            <a:pPr>
-              <a:spcAft>
-                <a:spcPts val="700"/>
-              </a:spcAft>
-            </a:pPr>
-            <a:r>
-              <a:rPr sz="1500" b="0">
-                <a:solidFill>
-                  <a:srgbClr val="1A1A1A"/>
-                </a:solidFill>
-                <a:latin typeface="Calibri"/>
-              </a:rPr>
-              <a:t>•  Repeatable from README + runbooks</a:t>
+              <a:t>•  App updates via volume deploy — OS changes need a new gold image</a:t>
             </a:r>
           </a:p>
         </p:txBody>
@@ -7569,7 +8672,7 @@
         <p:spPr>
           <a:xfrm>
             <a:off x="548640" y="228600"/>
-            <a:ext cx="2194560" cy="320040"/>
+            <a:ext cx="2377440" cy="320040"/>
           </a:xfrm>
           <a:prstGeom prst="roundRect">
             <a:avLst/>
@@ -7612,7 +8715,7 @@
         <p:spPr>
           <a:xfrm>
             <a:off x="548640" y="256032"/>
-            <a:ext cx="2194560" cy="292608"/>
+            <a:ext cx="2377440" cy="292608"/>
           </a:xfrm>
           <a:prstGeom prst="rect">
             <a:avLst/>
@@ -7625,7 +8728,7 @@
           </a:bodyPr>
           <a:lstStyle/>
           <a:p>
-            <a:pPr algn="l"/>
+            <a:pPr algn="ctr"/>
             <a:r>
               <a:rPr sz="1100" b="1">
                 <a:solidFill>
@@ -7633,7 +8736,7 @@
                 </a:solidFill>
                 <a:latin typeface="Calibri"/>
               </a:rPr>
-              <a:t>VALUE · 2–5 min</a:t>
+              <a:t>WALKTHROUGH</a:t>
             </a:r>
           </a:p>
         </p:txBody>
@@ -7647,7 +8750,7 @@
         <p:spPr>
           <a:xfrm>
             <a:off x="548640" y="640080"/>
-            <a:ext cx="10972800" cy="548640"/>
+            <a:ext cx="10972800" cy="502920"/>
           </a:xfrm>
           <a:prstGeom prst="rect">
             <a:avLst/>
@@ -7661,36 +8764,38 @@
           <a:lstStyle/>
           <a:p>
             <a:r>
-              <a:rPr sz="2600" b="1">
+              <a:rPr sz="2400" b="1">
                 <a:solidFill>
                   <a:srgbClr val="1A1A1A"/>
                 </a:solidFill>
                 <a:latin typeface="Calibri"/>
               </a:rPr>
-              <a:t>How this addresses Fedora Lane’s challenges</a:t>
-            </a:r>
-          </a:p>
-        </p:txBody>
-      </p:sp>
-      <p:sp>
-        <p:nvSpPr>
-          <p:cNvPr id="7" name="Rectangle 6"/>
+              <a:t>What we prove on the live VM</a:t>
+            </a:r>
+          </a:p>
+        </p:txBody>
+      </p:sp>
+      <p:sp>
+        <p:nvSpPr>
+          <p:cNvPr id="7" name="Rounded Rectangle 6"/>
           <p:cNvSpPr/>
           <p:nvPr/>
         </p:nvSpPr>
         <p:spPr>
           <a:xfrm>
-            <a:off x="548640" y="1234440"/>
-            <a:ext cx="1828800" cy="45720"/>
-          </a:xfrm>
-          <a:prstGeom prst="rect">
+            <a:off x="548640" y="1371600"/>
+            <a:ext cx="5120640" cy="4663440"/>
+          </a:xfrm>
+          <a:prstGeom prst="roundRect">
             <a:avLst/>
           </a:prstGeom>
           <a:solidFill>
-            <a:srgbClr val="EE0000"/>
+            <a:srgbClr val="FFFFFF"/>
           </a:solidFill>
           <a:ln>
-            <a:noFill/>
+            <a:solidFill>
+              <a:srgbClr val="E0E0E0"/>
+            </a:solidFill>
           </a:ln>
         </p:spPr>
         <p:style>
@@ -7723,8 +8828,42 @@
         </p:nvSpPr>
         <p:spPr>
           <a:xfrm>
-            <a:off x="548640" y="1463040"/>
-            <a:ext cx="10972800" cy="4572000"/>
+            <a:off x="822959" y="1554480"/>
+            <a:ext cx="4572000" cy="411480"/>
+          </a:xfrm>
+          <a:prstGeom prst="rect">
+            <a:avLst/>
+          </a:prstGeom>
+          <a:noFill/>
+        </p:spPr>
+        <p:txBody>
+          <a:bodyPr wrap="none">
+            <a:spAutoFit/>
+          </a:bodyPr>
+          <a:lstStyle/>
+          <a:p>
+            <a:r>
+              <a:rPr sz="1600" b="1">
+                <a:solidFill>
+                  <a:srgbClr val="EE0000"/>
+                </a:solidFill>
+                <a:latin typeface="Calibri"/>
+              </a:rPr>
+              <a:t>Expansion Pack controls</a:t>
+            </a:r>
+          </a:p>
+        </p:txBody>
+      </p:sp>
+      <p:sp>
+        <p:nvSpPr>
+          <p:cNvPr id="9" name="TextBox 8"/>
+          <p:cNvSpPr txBox="1"/>
+          <p:nvPr/>
+        </p:nvSpPr>
+        <p:spPr>
+          <a:xfrm>
+            <a:off x="822959" y="2103120"/>
+            <a:ext cx="4572000" cy="3657600"/>
           </a:xfrm>
           <a:prstGeom prst="rect">
             <a:avLst/>
@@ -7739,65 +8878,279 @@
           <a:p>
             <a:pPr>
               <a:spcAft>
-                <a:spcPts val="900"/>
+                <a:spcPts val="700"/>
               </a:spcAft>
             </a:pPr>
             <a:r>
-              <a:rPr sz="1800" b="0">
+              <a:rPr sz="1500" b="0">
                 <a:solidFill>
                   <a:srgbClr val="1A1A1A"/>
                 </a:solidFill>
                 <a:latin typeface="Calibri"/>
               </a:rPr>
-              <a:t>•  Inconsistency → one Git blueprint → identical gold baselines on AWS and Azure</a:t>
+              <a:t>•  SELinux Enforcing</a:t>
             </a:r>
           </a:p>
           <a:p>
             <a:pPr>
               <a:spcAft>
-                <a:spcPts val="900"/>
+                <a:spcPts val="700"/>
               </a:spcAft>
             </a:pPr>
             <a:r>
-              <a:rPr sz="1800" b="0">
+              <a:rPr sz="1500" b="0">
                 <a:solidFill>
                   <a:srgbClr val="1A1A1A"/>
                 </a:solidFill>
                 <a:latin typeface="Calibri"/>
               </a:rPr>
-              <a:t>•  Risky change → hardened SSH/sudo baked in; rebuild anytime from source of truth</a:t>
+              <a:t>•  Separate /var/log /home /tmp /var/tmp</a:t>
             </a:r>
           </a:p>
           <a:p>
             <a:pPr>
               <a:spcAft>
-                <a:spcPts val="900"/>
+                <a:spcPts val="700"/>
               </a:spcAft>
             </a:pPr>
             <a:r>
-              <a:rPr sz="1800" b="0">
+              <a:rPr sz="1500" b="0">
                 <a:solidFill>
                   <a:srgbClr val="1A1A1A"/>
                 </a:solidFill>
                 <a:latin typeface="Calibri"/>
               </a:rPr>
-              <a:t>•  Container skills gap → httpd runs as a container on every gold web VM</a:t>
+              <a:t>•  /tmp noexec</a:t>
             </a:r>
           </a:p>
           <a:p>
             <a:pPr>
               <a:spcAft>
-                <a:spcPts val="900"/>
+                <a:spcPts val="700"/>
               </a:spcAft>
             </a:pPr>
             <a:r>
-              <a:rPr sz="1800" b="0">
+              <a:rPr sz="1500" b="0">
                 <a:solidFill>
                   <a:srgbClr val="1A1A1A"/>
                 </a:solidFill>
                 <a:latin typeface="Calibri"/>
               </a:rPr>
-              <a:t>•  Dual-cloud reality → proven AMI path and VHD path with the same recipe</a:t>
+              <a:t>•  SSH 2222 key-only · no root SSH</a:t>
+            </a:r>
+          </a:p>
+          <a:p>
+            <a:pPr>
+              <a:spcAft>
+                <a:spcPts val="700"/>
+              </a:spcAft>
+            </a:pPr>
+            <a:r>
+              <a:rPr sz="1500" b="0">
+                <a:solidFill>
+                  <a:srgbClr val="1A1A1A"/>
+                </a:solidFill>
+                <a:latin typeface="Calibri"/>
+              </a:rPr>
+              <a:t>•  fladmins · fladmin1 / fladmin2</a:t>
+            </a:r>
+          </a:p>
+          <a:p>
+            <a:pPr>
+              <a:spcAft>
+                <a:spcPts val="700"/>
+              </a:spcAft>
+            </a:pPr>
+            <a:r>
+              <a:rPr sz="1500" b="0">
+                <a:solidFill>
+                  <a:srgbClr val="1A1A1A"/>
+                </a:solidFill>
+                <a:latin typeface="Calibri"/>
+              </a:rPr>
+              <a:t>•  Firewall: 2222 + 35443 only</a:t>
+            </a:r>
+          </a:p>
+        </p:txBody>
+      </p:sp>
+      <p:sp>
+        <p:nvSpPr>
+          <p:cNvPr id="10" name="Rounded Rectangle 9"/>
+          <p:cNvSpPr/>
+          <p:nvPr/>
+        </p:nvSpPr>
+        <p:spPr>
+          <a:xfrm>
+            <a:off x="6400800" y="1371600"/>
+            <a:ext cx="5120640" cy="4663440"/>
+          </a:xfrm>
+          <a:prstGeom prst="roundRect">
+            <a:avLst/>
+          </a:prstGeom>
+          <a:solidFill>
+            <a:srgbClr val="FFFFFF"/>
+          </a:solidFill>
+          <a:ln>
+            <a:solidFill>
+              <a:srgbClr val="E0E0E0"/>
+            </a:solidFill>
+          </a:ln>
+        </p:spPr>
+        <p:style>
+          <a:lnRef idx="1">
+            <a:schemeClr val="accent1"/>
+          </a:lnRef>
+          <a:fillRef idx="3">
+            <a:schemeClr val="accent1"/>
+          </a:fillRef>
+          <a:effectRef idx="2">
+            <a:schemeClr val="accent1"/>
+          </a:effectRef>
+          <a:fontRef idx="minor">
+            <a:schemeClr val="lt1"/>
+          </a:fontRef>
+        </p:style>
+        <p:txBody>
+          <a:bodyPr rtlCol="0" anchor="ctr"/>
+          <a:lstStyle/>
+          <a:p>
+            <a:pPr algn="ctr"/>
+          </a:p>
+        </p:txBody>
+      </p:sp>
+      <p:sp>
+        <p:nvSpPr>
+          <p:cNvPr id="11" name="TextBox 10"/>
+          <p:cNvSpPr txBox="1"/>
+          <p:nvPr/>
+        </p:nvSpPr>
+        <p:spPr>
+          <a:xfrm>
+            <a:off x="6675120" y="1554480"/>
+            <a:ext cx="4572000" cy="411480"/>
+          </a:xfrm>
+          <a:prstGeom prst="rect">
+            <a:avLst/>
+          </a:prstGeom>
+          <a:noFill/>
+        </p:spPr>
+        <p:txBody>
+          <a:bodyPr wrap="none">
+            <a:spAutoFit/>
+          </a:bodyPr>
+          <a:lstStyle/>
+          <a:p>
+            <a:r>
+              <a:rPr sz="1600" b="1">
+                <a:solidFill>
+                  <a:srgbClr val="EE0000"/>
+                </a:solidFill>
+                <a:latin typeface="Calibri"/>
+              </a:rPr>
+              <a:t>Service in action</a:t>
+            </a:r>
+          </a:p>
+        </p:txBody>
+      </p:sp>
+      <p:sp>
+        <p:nvSpPr>
+          <p:cNvPr id="12" name="TextBox 11"/>
+          <p:cNvSpPr txBox="1"/>
+          <p:nvPr/>
+        </p:nvSpPr>
+        <p:spPr>
+          <a:xfrm>
+            <a:off x="6675120" y="2103120"/>
+            <a:ext cx="4572000" cy="3657600"/>
+          </a:xfrm>
+          <a:prstGeom prst="rect">
+            <a:avLst/>
+          </a:prstGeom>
+          <a:noFill/>
+        </p:spPr>
+        <p:txBody>
+          <a:bodyPr wrap="square">
+            <a:spAutoFit/>
+          </a:bodyPr>
+          <a:lstStyle/>
+          <a:p>
+            <a:pPr>
+              <a:spcAft>
+                <a:spcPts val="700"/>
+              </a:spcAft>
+            </a:pPr>
+            <a:r>
+              <a:rPr sz="1500" b="0">
+                <a:solidFill>
+                  <a:srgbClr val="1A1A1A"/>
+                </a:solidFill>
+                <a:latin typeface="Calibri"/>
+              </a:rPr>
+              <a:t>•  httpd container on 35443</a:t>
+            </a:r>
+          </a:p>
+          <a:p>
+            <a:pPr>
+              <a:spcAft>
+                <a:spcPts val="700"/>
+              </a:spcAft>
+            </a:pPr>
+            <a:r>
+              <a:rPr sz="1500" b="0">
+                <a:solidFill>
+                  <a:srgbClr val="1A1A1A"/>
+                </a:solidFill>
+                <a:latin typeface="Calibri"/>
+              </a:rPr>
+              <a:t>•  Boutique demo app + health.json</a:t>
+            </a:r>
+          </a:p>
+          <a:p>
+            <a:pPr>
+              <a:spcAft>
+                <a:spcPts val="700"/>
+              </a:spcAft>
+            </a:pPr>
+            <a:r>
+              <a:rPr sz="1500" b="0">
+                <a:solidFill>
+                  <a:srgbClr val="1A1A1A"/>
+                </a:solidFill>
+                <a:latin typeface="Calibri"/>
+              </a:rPr>
+              <a:t>•  Same checklist after reboot</a:t>
+            </a:r>
+          </a:p>
+          <a:p>
+            <a:pPr>
+              <a:spcAft>
+                <a:spcPts val="700"/>
+              </a:spcAft>
+            </a:pPr>
+            <a:r>
+              <a:rPr sz="1500" b="0">
+                <a:solidFill>
+                  <a:srgbClr val="1A1A1A"/>
+                </a:solidFill>
+                <a:latin typeface="Calibri"/>
+              </a:rPr>
+              <a:t>•  Proven on AWS and Azure</a:t>
+            </a:r>
+          </a:p>
+          <a:p>
+            <a:pPr>
+              <a:spcAft>
+                <a:spcPts val="700"/>
+              </a:spcAft>
+            </a:pPr>
+            <a:r>
+              <a:rPr sz="1500" b="0">
+                <a:solidFill>
+                  <a:srgbClr val="1A1A1A"/>
+                </a:solidFill>
+                <a:latin typeface="Calibri"/>
+              </a:rPr>
+              <a:t>•  Repeatable from README + runbooks</a:t>
             </a:r>
           </a:p>
         </p:txBody>

</xml_diff>